<commit_message>
Reduce English jargon in speech script and PPT
- Replace: sub-stage→子阶段, benchmark→性能测试, producer→生产者
- Replace: consumer→消费者, ring write→环形写入, per-CPU→每核
- Replace: undefined behavior→未定义行为, busy-wait→忙等
- Keep: eBPF, LD_PRELOAD, mutex, eventfd, FpUnwind (proper nouns/standard terms)
- Regenerate PPTX with updated labels

Co-Authored-By: Claude Opus 4.8 <noreply@anthropic.com>
</commit_message>
<xml_diff>
--- a/presentation/native_hook_progress_2026-06-11.pptx
+++ b/presentation/native_hook_progress_2026-06-11.pptx
@@ -1953,7 +1953,7 @@
                   <a:srgbClr val="93C5FD"/>
                 </a:solidFill>
               </a:rPr>
-              <a:t>优化进展与 Sharded Ring 提案</a:t>
+              <a:t>优化进展与分片环形区提案</a:t>
             </a:r>
             <a:endParaRPr lang="en-US" sz="2800" dirty="0"/>
           </a:p>
@@ -5725,7 +5725,7 @@
                 <a:ea typeface="Microsoft YaHei" pitchFamily="34" charset="-122"/>
                 <a:cs typeface="Microsoft YaHei" pitchFamily="34" charset="-120"/>
               </a:rPr>
-              <a:t>上次反馈闭环 + Sub-stage 36 死锁修复</a:t>
+              <a:t>上次反馈闭环 + 子阶段 36 死锁修复</a:t>
             </a:r>
             <a:endParaRPr lang="en-US" sz="2400" dirty="0"/>
           </a:p>
@@ -5802,7 +5802,7 @@
                   <a:srgbClr val="334155"/>
                 </a:solidFill>
               </a:rPr>
-              <a:t>热点定位 → batch publish 解决；perf 分析 → ablation sub-stage 替代</a:t>
+              <a:t>热点定位 → 批量发布解决；perf 分析 → 逐层拆解替代</a:t>
             </a:r>
             <a:endParaRPr lang="en-US" sz="1500" dirty="0"/>
           </a:p>
@@ -5870,7 +5870,7 @@
                   <a:srgbClr val="334155"/>
                 </a:solidFill>
               </a:rPr>
-              <a:t>根因：stack_writer_.Lock() + Write() 内部 pthread_mutex_lock 同一非递归 mutex</a:t>
+              <a:t>根因：外层 Lock() + Write() 内部重复加锁同一非递归互斥锁 = 未定义行为</a:t>
             </a:r>
             <a:endParaRPr lang="en-US" sz="1500" dirty="0"/>
           </a:p>
@@ -6161,7 +6161,7 @@
                           <a:ea typeface="Arial" pitchFamily="34" charset="-122"/>
                           <a:cs typeface="Arial" pitchFamily="34" charset="-120"/>
                         </a:rPr>
-                        <a:t>sub-stage</a:t>
+                        <a:t>子阶段</a:t>
                       </a:r>
                       <a:endParaRPr lang="en-US" sz="1200" dirty="0">
                         <a:latin typeface="Arial" charset="0"/>
@@ -6297,7 +6297,7 @@
                           <a:ea typeface="Arial" pitchFamily="34" charset="-122"/>
                           <a:cs typeface="Arial" pitchFamily="34" charset="-120"/>
                         </a:rPr>
-                        <a:t>1T</a:t>
+                        <a:t>1 线程</a:t>
                       </a:r>
                       <a:endParaRPr lang="en-US" sz="1200" dirty="0">
                         <a:latin typeface="Arial" charset="0"/>
@@ -6365,7 +6365,7 @@
                           <a:ea typeface="Arial" pitchFamily="34" charset="-122"/>
                           <a:cs typeface="Arial" pitchFamily="34" charset="-120"/>
                         </a:rPr>
-                        <a:t>4T</a:t>
+                        <a:t>4 线程</a:t>
                       </a:r>
                       <a:endParaRPr lang="en-US" sz="1200" dirty="0">
                         <a:latin typeface="Arial" charset="0"/>
@@ -6433,7 +6433,7 @@
                           <a:ea typeface="Arial" pitchFamily="34" charset="-122"/>
                           <a:cs typeface="Arial" pitchFamily="34" charset="-120"/>
                         </a:rPr>
-                        <a:t>8T</a:t>
+                        <a:t>8 线程</a:t>
                       </a:r>
                       <a:endParaRPr lang="en-US" sz="1200" dirty="0">
                         <a:latin typeface="Arial" charset="0"/>
@@ -6501,7 +6501,7 @@
                           <a:ea typeface="Arial" pitchFamily="34" charset="-122"/>
                           <a:cs typeface="Arial" pitchFamily="34" charset="-120"/>
                         </a:rPr>
-                        <a:t>16T</a:t>
+                        <a:t>16 线程</a:t>
                       </a:r>
                       <a:endParaRPr lang="en-US" sz="1200" dirty="0">
                         <a:latin typeface="Arial" charset="0"/>
@@ -6571,7 +6571,7 @@
                           <a:ea typeface="Consolas" pitchFamily="34" charset="-122"/>
                           <a:cs typeface="Consolas" pitchFamily="34" charset="-120"/>
                         </a:rPr>
-                        <a:t>34 write_only</a:t>
+                        <a:t>34 纯写入</a:t>
                       </a:r>
                       <a:endParaRPr lang="en-US" sz="1200" dirty="0">
                         <a:latin typeface="Consolas" charset="0"/>
@@ -6639,7 +6639,7 @@
                           <a:ea typeface="Consolas" pitchFamily="34" charset="-122"/>
                           <a:cs typeface="Consolas" pitchFamily="34" charset="-120"/>
                         </a:rPr>
-                        <a:t>ring write + inner_mutex_</a:t>
+                        <a:t>环形写入 + 内部锁</a:t>
                       </a:r>
                       <a:endParaRPr lang="en-US" sz="1200" dirty="0">
                         <a:latin typeface="Consolas" charset="0"/>
@@ -6981,7 +6981,7 @@
                           <a:ea typeface="Consolas" pitchFamily="34" charset="-122"/>
                           <a:cs typeface="Consolas" pitchFamily="34" charset="-120"/>
                         </a:rPr>
-                        <a:t>35 flush_only</a:t>
+                        <a:t>35 加通知</a:t>
                       </a:r>
                       <a:endParaRPr lang="en-US" sz="1200" dirty="0">
                         <a:latin typeface="Consolas" charset="0"/>
@@ -7049,7 +7049,7 @@
                           <a:ea typeface="Consolas" pitchFamily="34" charset="-122"/>
                           <a:cs typeface="Consolas" pitchFamily="34" charset="-120"/>
                         </a:rPr>
-                        <a:t>+ eventfd 通知</a:t>
+                        <a:t>+ eventfd 系统调用</a:t>
                       </a:r>
                       <a:endParaRPr lang="en-US" sz="1200" dirty="0">
                         <a:latin typeface="Consolas" charset="0"/>
@@ -7391,7 +7391,7 @@
                           <a:ea typeface="Consolas" pitchFamily="34" charset="-122"/>
                           <a:cs typeface="Consolas" pitchFamily="34" charset="-120"/>
                         </a:rPr>
-                        <a:t>36 full</a:t>
+                        <a:t>36 全链路</a:t>
                       </a:r>
                       <a:endParaRPr lang="en-US" sz="1200" dirty="0">
                         <a:latin typeface="Consolas" charset="0"/>
@@ -7459,7 +7459,7 @@
                           <a:ea typeface="Consolas" pitchFamily="34" charset="-122"/>
                           <a:cs typeface="Consolas" pitchFamily="34" charset="-120"/>
                         </a:rPr>
-                        <a:t>+ consumer drain</a:t>
+                        <a:t>+ 消费者消费</a:t>
                       </a:r>
                       <a:endParaRPr lang="en-US" sz="1200" dirty="0">
                         <a:latin typeface="Consolas" charset="0"/>
@@ -7885,7 +7885,7 @@
                   <a:srgbClr val="64748B"/>
                 </a:solidFill>
               </a:rPr>
-              <a:t>sub=34 · 1T</a:t>
+              <a:t>子阶段 34 · 单线程</a:t>
             </a:r>
             <a:endParaRPr lang="en-US" sz="1100" dirty="0"/>
           </a:p>
@@ -7921,7 +7921,7 @@
                   <a:srgbClr val="64748B"/>
                 </a:solidFill>
               </a:rPr>
-              <a:t>ring write 内锁</a:t>
+              <a:t>环形写入内锁</a:t>
             </a:r>
             <a:endParaRPr lang="en-US" sz="1000" dirty="0"/>
           </a:p>
@@ -8025,7 +8025,7 @@
                   <a:srgbClr val="64748B"/>
                 </a:solidFill>
               </a:rPr>
-              <a:t>sub=35-34 delta</a:t>
+              <a:t>子阶段 35-34 差值</a:t>
             </a:r>
             <a:endParaRPr lang="en-US" sz="1100" dirty="0"/>
           </a:p>
@@ -8061,7 +8061,7 @@
                   <a:srgbClr val="64748B"/>
                 </a:solidFill>
               </a:rPr>
-              <a:t>eventfd syscall</a:t>
+              <a:t>eventfd 系统调用</a:t>
             </a:r>
             <a:endParaRPr lang="en-US" sz="1000" dirty="0"/>
           </a:p>
@@ -8165,7 +8165,7 @@
                   <a:srgbClr val="64748B"/>
                 </a:solidFill>
               </a:rPr>
-              <a:t>sub=36-35 delta</a:t>
+              <a:t>子阶段 36-35 差值</a:t>
             </a:r>
             <a:endParaRPr lang="en-US" sz="1100" dirty="0"/>
           </a:p>
@@ -8201,7 +8201,7 @@
                   <a:srgbClr val="64748B"/>
                 </a:solidFill>
               </a:rPr>
-              <a:t>consumer drain</a:t>
+              <a:t>消费者消费</a:t>
             </a:r>
             <a:endParaRPr lang="en-US" sz="1000" dirty="0"/>
           </a:p>
@@ -8305,7 +8305,7 @@
                   <a:srgbClr val="64748B"/>
                 </a:solidFill>
               </a:rPr>
-              <a:t>sub=34 16T/1T</a:t>
+              <a:t>子阶段 34 · 16线/单线</a:t>
             </a:r>
             <a:endParaRPr lang="en-US" sz="1100" dirty="0"/>
           </a:p>
@@ -8341,7 +8341,7 @@
                   <a:srgbClr val="64748B"/>
                 </a:solidFill>
               </a:rPr>
-              <a:t>16T 竞争退化</a:t>
+              <a:t>16 线程竞争退化</a:t>
             </a:r>
             <a:endParaRPr lang="en-US" sz="1000" dirty="0"/>
           </a:p>
@@ -8889,7 +8889,7 @@
                           <a:ea typeface="Consolas" pitchFamily="34" charset="-122"/>
                           <a:cs typeface="Consolas" pitchFamily="34" charset="-120"/>
                         </a:rPr>
-                        <a:t>batch publish</a:t>
+                        <a:t>批量发布</a:t>
                       </a:r>
                       <a:endParaRPr lang="en-US" sz="1200" dirty="0">
                         <a:latin typeface="Consolas" charset="0"/>
@@ -8957,7 +8957,7 @@
                           <a:ea typeface="Consolas" pitchFamily="34" charset="-122"/>
                           <a:cs typeface="Consolas" pitchFamily="34" charset="-120"/>
                         </a:rPr>
-                        <a:t>per-thread buffer</a:t>
+                        <a:t>线程本地缓冲</a:t>
                       </a:r>
                       <a:endParaRPr lang="en-US" sz="1200" dirty="0">
                         <a:latin typeface="Consolas" charset="0"/>
@@ -8978,7 +8978,7 @@
                           <a:ea typeface="Consolas" pitchFamily="34" charset="-122"/>
                           <a:cs typeface="Consolas" pitchFamily="34" charset="-120"/>
                         </a:rPr>
-                        <a:t>batch write 4~64</a:t>
+                        <a:t>批量写入 4~64</a:t>
                       </a:r>
                       <a:endParaRPr lang="en-US" sz="1200" dirty="0">
                         <a:latin typeface="Consolas" charset="0"/>
@@ -9135,7 +9135,7 @@
                           <a:ea typeface="Consolas" pitchFamily="34" charset="-122"/>
                           <a:cs typeface="Consolas" pitchFamily="34" charset="-120"/>
                         </a:rPr>
-                        <a:t>inner_mutex_ 临界区</a:t>
+                        <a:t>内部锁临界区</a:t>
                       </a:r>
                       <a:endParaRPr lang="en-US" sz="1200" dirty="0">
                         <a:latin typeface="Consolas" charset="0"/>
@@ -9156,7 +9156,7 @@
                           <a:ea typeface="Consolas" pitchFamily="34" charset="-122"/>
                           <a:cs typeface="Consolas" pitchFamily="34" charset="-120"/>
                         </a:rPr>
-                        <a:t>仅 ~25ns</a:t>
+                        <a:t>仅 ~25 纳秒</a:t>
                       </a:r>
                       <a:endParaRPr lang="en-US" sz="1200" dirty="0">
                         <a:latin typeface="Consolas" charset="0"/>

</xml_diff>

<commit_message>
Remove cyc_nativehook references from presentation materials
Co-Authored-By: Claude Opus 4.8 <noreply@anthropic.com>
</commit_message>
<xml_diff>
--- a/presentation/native_hook_progress_2026-06-11.pptx
+++ b/presentation/native_hook_progress_2026-06-11.pptx
@@ -5178,7 +5178,7 @@
                   <a:srgbClr val="64748B"/>
                 </a:solidFill>
               </a:rPr>
-              <a:t>在 cyc_nativehook 上编译验证 sharded ring</a:t>
+              <a:t>编译验证分片方案</a:t>
             </a:r>
             <a:endParaRPr lang="en-US" sz="1300" dirty="0"/>
           </a:p>
@@ -5295,7 +5295,7 @@
                   <a:srgbClr val="1E293B"/>
                 </a:solidFill>
               </a:rPr>
-              <a:t>团队 Review</a:t>
+              <a:t>团队评审</a:t>
             </a:r>
             <a:endParaRPr lang="en-US" sz="1700" dirty="0"/>
           </a:p>
@@ -5351,7 +5351,7 @@
                   <a:srgbClr val="64748B"/>
                 </a:solidFill>
               </a:rPr>
-              <a:t>在 yt_nativehook 上提交 MR</a:t>
+              <a:t>在团队仓库提交合并请求</a:t>
             </a:r>
             <a:endParaRPr lang="en-US" sz="1300" dirty="0"/>
           </a:p>
@@ -5820,7 +5820,7 @@
                   <a:srgbClr val="334155"/>
                 </a:solidFill>
               </a:rPr>
-              <a:t>Gitee fork 到公司 GitLab（yt_nativehook + cyc_nativehook）</a:t>
+              <a:t>Gitee fork 到公司 GitLab 并完成移植</a:t>
             </a:r>
             <a:endParaRPr lang="en-US" sz="1500" dirty="0"/>
           </a:p>
@@ -18933,7 +18933,7 @@
                   <a:srgbClr val="64748B"/>
                 </a:solidFill>
               </a:rPr>
-              <a:t>已在 cyc_nativehook / yt_nativehook 上用 SHARDED_RING: 标注</a:t>
+              <a:t>已在 OH 仓库源码上用 SHARDED_RING: 标注</a:t>
             </a:r>
             <a:endParaRPr lang="en-US" sz="1300" dirty="0"/>
           </a:p>

</xml_diff>

<commit_message>
Fix slide 3: 线→线程, restore category axis label
Co-Authored-By: Claude Opus 4.8 <noreply@anthropic.com>
</commit_message>
<xml_diff>
--- a/presentation/native_hook_progress_2026-06-11.pptx
+++ b/presentation/native_hook_progress_2026-06-11.pptx
@@ -182,7 +182,7 @@
                 <c:ptCount val="1"/>
                 <c:lvl>
                   <c:pt idx="0">
-                    <c:v>单线程耗时拆解</c:v>
+                    <c:v>1 线程</c:v>
                   </c:pt>
                 </c:lvl>
               </c:multiLvlStrCache>
@@ -253,7 +253,7 @@
                 <c:ptCount val="1"/>
                 <c:lvl>
                   <c:pt idx="0">
-                    <c:v>单线程耗时拆解</c:v>
+                    <c:v>1 线程</c:v>
                   </c:pt>
                 </c:lvl>
               </c:multiLvlStrCache>
@@ -324,7 +324,7 @@
                 <c:ptCount val="1"/>
                 <c:lvl>
                   <c:pt idx="0">
-                    <c:v>单线程耗时拆解</c:v>
+                    <c:v>1 线程</c:v>
                   </c:pt>
                 </c:lvl>
               </c:multiLvlStrCache>
@@ -578,16 +578,16 @@
                 <c:ptCount val="4"/>
                 <c:lvl>
                   <c:pt idx="0">
-                    <c:v>1线</c:v>
+                    <c:v>1 线程</c:v>
                   </c:pt>
                   <c:pt idx="1">
-                    <c:v>4线</c:v>
+                    <c:v>4 线程</c:v>
                   </c:pt>
                   <c:pt idx="2">
-                    <c:v>8线</c:v>
+                    <c:v>8 线程</c:v>
                   </c:pt>
                   <c:pt idx="3">
-                    <c:v>16线</c:v>
+                    <c:v>16 线程</c:v>
                   </c:pt>
                 </c:lvl>
               </c:multiLvlStrCache>
@@ -692,16 +692,16 @@
                 <c:ptCount val="4"/>
                 <c:lvl>
                   <c:pt idx="0">
-                    <c:v>1线</c:v>
+                    <c:v>1 线程</c:v>
                   </c:pt>
                   <c:pt idx="1">
-                    <c:v>4线</c:v>
+                    <c:v>4 线程</c:v>
                   </c:pt>
                   <c:pt idx="2">
-                    <c:v>8线</c:v>
+                    <c:v>8 线程</c:v>
                   </c:pt>
                   <c:pt idx="3">
-                    <c:v>16线</c:v>
+                    <c:v>16 线程</c:v>
                   </c:pt>
                 </c:lvl>
               </c:multiLvlStrCache>
@@ -806,16 +806,16 @@
                 <c:ptCount val="4"/>
                 <c:lvl>
                   <c:pt idx="0">
-                    <c:v>1线</c:v>
+                    <c:v>1 线程</c:v>
                   </c:pt>
                   <c:pt idx="1">
-                    <c:v>4线</c:v>
+                    <c:v>4 线程</c:v>
                   </c:pt>
                   <c:pt idx="2">
-                    <c:v>8线</c:v>
+                    <c:v>8 线程</c:v>
                   </c:pt>
                   <c:pt idx="3">
-                    <c:v>16线</c:v>
+                    <c:v>16 线程</c:v>
                   </c:pt>
                 </c:lvl>
               </c:multiLvlStrCache>
@@ -7723,7 +7723,7 @@
         </p:nvGraphicFramePr>
         <p:xfrm>
           <a:off x="457200" y="1280160"/>
-          <a:ext cx="5029200" cy="2926080"/>
+          <a:ext cx="5303520" cy="2377440"/>
         </p:xfrm>
         <a:graphic xmlns:a="http://schemas.openxmlformats.org/drawingml/2006/main">
           <a:graphicData uri="http://schemas.openxmlformats.org/drawingml/2006/chart">

</xml_diff>

<commit_message>
Remove showValue from all charts to fix 0/1 rendering bug
Co-Authored-By: Claude Opus 4.8 <noreply@anthropic.com>
</commit_message>
<xml_diff>
--- a/presentation/native_hook_progress_2026-06-11.pptx
+++ b/presentation/native_hook_progress_2026-06-11.pptx
@@ -168,7 +168,7 @@
               </a:p>
             </c:txPr>
             <c:showLegendKey val="0"/>
-            <c:showVal val="1"/>
+            <c:showVal val="0"/>
             <c:showCatName val="0"/>
             <c:showSerName val="0"/>
             <c:showPercent val="0"/>
@@ -239,7 +239,7 @@
               </a:p>
             </c:txPr>
             <c:showLegendKey val="0"/>
-            <c:showVal val="1"/>
+            <c:showVal val="0"/>
             <c:showCatName val="0"/>
             <c:showSerName val="0"/>
             <c:showPercent val="0"/>
@@ -310,7 +310,7 @@
               </a:p>
             </c:txPr>
             <c:showLegendKey val="0"/>
-            <c:showVal val="1"/>
+            <c:showVal val="0"/>
             <c:showCatName val="0"/>
             <c:showSerName val="0"/>
             <c:showPercent val="0"/>
@@ -360,7 +360,7 @@
             </a:p>
           </c:txPr>
           <c:showLegendKey val="0"/>
-          <c:showVal val="1"/>
+          <c:showVal val="0"/>
           <c:showCatName val="0"/>
           <c:showSerName val="0"/>
           <c:showPercent val="0"/>
@@ -1041,7 +1041,7 @@
               </a:p>
             </c:txPr>
             <c:showLegendKey val="0"/>
-            <c:showVal val="1"/>
+            <c:showVal val="0"/>
             <c:showCatName val="0"/>
             <c:showSerName val="0"/>
             <c:showPercent val="0"/>
@@ -1130,7 +1130,7 @@
               </a:p>
             </c:txPr>
             <c:showLegendKey val="0"/>
-            <c:showVal val="1"/>
+            <c:showVal val="0"/>
             <c:showCatName val="0"/>
             <c:showSerName val="0"/>
             <c:showPercent val="0"/>
@@ -1198,7 +1198,7 @@
             </a:p>
           </c:txPr>
           <c:showLegendKey val="0"/>
-          <c:showVal val="1"/>
+          <c:showVal val="0"/>
           <c:showCatName val="0"/>
           <c:showSerName val="0"/>
           <c:showPercent val="0"/>

</xml_diff>

<commit_message>
Fix slide 7: remove showValue, add valAxisMaxVal=1.2
Co-Authored-By: Claude Opus 4.8 <noreply@anthropic.com>
</commit_message>
<xml_diff>
--- a/presentation/native_hook_progress_2026-06-11.pptx
+++ b/presentation/native_hook_progress_2026-06-11.pptx
@@ -1379,7 +1379,7 @@
               </a:p>
             </c:txPr>
             <c:showLegendKey val="0"/>
-            <c:showVal val="1"/>
+            <c:showVal val="0"/>
             <c:showCatName val="0"/>
             <c:showSerName val="0"/>
             <c:showPercent val="0"/>
@@ -1456,7 +1456,7 @@
               </a:p>
             </c:txPr>
             <c:showLegendKey val="0"/>
-            <c:showVal val="1"/>
+            <c:showVal val="0"/>
             <c:showCatName val="0"/>
             <c:showSerName val="0"/>
             <c:showPercent val="0"/>
@@ -1533,7 +1533,7 @@
               </a:p>
             </c:txPr>
             <c:showLegendKey val="0"/>
-            <c:showVal val="1"/>
+            <c:showVal val="0"/>
             <c:showCatName val="0"/>
             <c:showSerName val="0"/>
             <c:showPercent val="0"/>
@@ -1589,7 +1589,7 @@
             </a:p>
           </c:txPr>
           <c:showLegendKey val="0"/>
-          <c:showVal val="1"/>
+          <c:showVal val="0"/>
           <c:showCatName val="0"/>
           <c:showSerName val="0"/>
           <c:showPercent val="0"/>
@@ -1647,6 +1647,7 @@
         <c:axId val="2094734552"/>
         <c:scaling>
           <c:orientation val="minMax"/>
+          <c:max val="1.2"/>
           <c:min val="0"/>
         </c:scaling>
         <c:delete val="0"/>

</xml_diff>

<commit_message>
Redesign slide 2: two-column layout with before/after cards
- Left: four numbered feedback items with checkmarks
- Right: deadlock fix with before/after metric cards (8.60s → 0.28s)
- Root cause explanation box

Co-Authored-By: Claude Opus 4.8 <noreply@anthropic.com>
</commit_message>
<xml_diff>
--- a/presentation/native_hook_progress_2026-06-11.pptx
+++ b/presentation/native_hook_progress_2026-06-11.pptx
@@ -7328,7 +7328,7 @@
                 <a:ea typeface="Microsoft YaHei" pitchFamily="34" charset="-122"/>
                 <a:cs typeface="Microsoft YaHei" pitchFamily="34" charset="-120"/>
               </a:rPr>
-              <a:t>上次反馈闭环 + 子阶段 36 死锁修复</a:t>
+              <a:t>上次反馈闭环 + 死锁修复</a:t>
             </a:r>
             <a:endParaRPr lang="en-US" sz="2400" dirty="0"/>
           </a:p>
@@ -7356,14 +7356,36 @@
       </p:sp>
       <p:sp>
         <p:nvSpPr>
-          <p:cNvPr id="7" name="Text 5"/>
-          <p:cNvSpPr/>
-          <p:nvPr/>
-        </p:nvSpPr>
-        <p:spPr>
-          <a:xfrm>
-            <a:off x="594360" y="1280160"/>
-            <a:ext cx="10972800" cy="5029200"/>
+          <p:cNvPr id="7" name="Shape 5"/>
+          <p:cNvSpPr/>
+          <p:nvPr/>
+        </p:nvSpPr>
+        <p:spPr>
+          <a:xfrm>
+            <a:off x="457200" y="1234440"/>
+            <a:ext cx="5394960" cy="411480"/>
+          </a:xfrm>
+          <a:prstGeom prst="rect">
+            <a:avLst>
+              <a:gd name="adj" fmla="val 11111"/>
+            </a:avLst>
+          </a:prstGeom>
+          <a:solidFill>
+            <a:srgbClr val="EFF6FF"/>
+          </a:solidFill>
+          <a:ln/>
+        </p:spPr>
+      </p:sp>
+      <p:sp>
+        <p:nvSpPr>
+          <p:cNvPr id="8" name="Text 6"/>
+          <p:cNvSpPr/>
+          <p:nvPr/>
+        </p:nvSpPr>
+        <p:spPr>
+          <a:xfrm>
+            <a:off x="640080" y="1234440"/>
+            <a:ext cx="5029200" cy="411480"/>
           </a:xfrm>
           <a:prstGeom prst="rect">
             <a:avLst/>
@@ -7372,146 +7394,1147 @@
           <a:ln/>
         </p:spPr>
         <p:txBody>
-          <a:bodyPr wrap="square" rtlCol="0" anchor="t"/>
+          <a:bodyPr wrap="square" rtlCol="0" anchor="ctr"/>
           <a:lstStyle/>
           <a:p>
             <a:pPr indent="0" marL="0">
-              <a:lnSpc>
-                <a:spcPts val="2400"/>
-              </a:lnSpc>
               <a:buNone/>
             </a:pPr>
             <a:r>
-              <a:rPr lang="en-US" sz="1500" b="1" dirty="0">
+              <a:rPr lang="en-US" sz="1300" b="1" dirty="0">
                 <a:solidFill>
                   <a:srgbClr val="2563EB"/>
                 </a:solidFill>
               </a:rPr>
-              <a:t>上次四个问题全部闭环</a:t>
+              <a:t>上次组会四个问题全部闭环</a:t>
             </a:r>
-            <a:endParaRPr lang="en-US" sz="1500" dirty="0"/>
+            <a:endParaRPr lang="en-US" sz="1300" dirty="0"/>
           </a:p>
+        </p:txBody>
+      </p:sp>
+      <p:sp>
+        <p:nvSpPr>
+          <p:cNvPr id="9" name="Shape 7"/>
+          <p:cNvSpPr/>
+          <p:nvPr/>
+        </p:nvSpPr>
+        <p:spPr>
+          <a:xfrm>
+            <a:off x="502920" y="1783080"/>
+            <a:ext cx="365760" cy="365760"/>
+          </a:xfrm>
+          <a:prstGeom prst="rect">
+            <a:avLst>
+              <a:gd name="adj" fmla="val 50000"/>
+            </a:avLst>
+          </a:prstGeom>
+          <a:solidFill>
+            <a:srgbClr val="2563EB"/>
+          </a:solidFill>
+          <a:ln/>
+        </p:spPr>
+      </p:sp>
+      <p:sp>
+        <p:nvSpPr>
+          <p:cNvPr id="10" name="Text 8"/>
+          <p:cNvSpPr/>
+          <p:nvPr/>
+        </p:nvSpPr>
+        <p:spPr>
+          <a:xfrm>
+            <a:off x="502920" y="1783080"/>
+            <a:ext cx="365760" cy="365760"/>
+          </a:xfrm>
+          <a:prstGeom prst="rect">
+            <a:avLst/>
+          </a:prstGeom>
+          <a:noFill/>
+          <a:ln/>
+        </p:spPr>
+        <p:txBody>
+          <a:bodyPr wrap="square" rtlCol="0" anchor="ctr"/>
+          <a:lstStyle/>
           <a:p>
-            <a:pPr marL="342900" indent="-342900">
-              <a:lnSpc>
-                <a:spcPts val="2400"/>
-              </a:lnSpc>
-              <a:buSzPct val="100000"/>
-              <a:buChar char="•"/>
+            <a:pPr algn="ctr" indent="0" marL="0">
+              <a:buNone/>
             </a:pPr>
             <a:r>
-              <a:rPr lang="en-US" sz="1400" dirty="0">
+              <a:rPr lang="en-US" sz="1200" b="1" dirty="0">
+                <a:solidFill>
+                  <a:srgbClr val="FFFFFF"/>
+                </a:solidFill>
+                <a:latin typeface="Consolas" pitchFamily="34" charset="0"/>
+                <a:ea typeface="Consolas" pitchFamily="34" charset="-122"/>
+                <a:cs typeface="Consolas" pitchFamily="34" charset="-120"/>
+              </a:rPr>
+              <a:t>1</a:t>
+            </a:r>
+            <a:endParaRPr lang="en-US" sz="1200" dirty="0"/>
+          </a:p>
+        </p:txBody>
+      </p:sp>
+      <p:sp>
+        <p:nvSpPr>
+          <p:cNvPr id="11" name="Text 9"/>
+          <p:cNvSpPr/>
+          <p:nvPr/>
+        </p:nvSpPr>
+        <p:spPr>
+          <a:xfrm>
+            <a:off x="1005840" y="1764792"/>
+            <a:ext cx="1097280" cy="365760"/>
+          </a:xfrm>
+          <a:prstGeom prst="rect">
+            <a:avLst/>
+          </a:prstGeom>
+          <a:noFill/>
+          <a:ln/>
+        </p:spPr>
+        <p:txBody>
+          <a:bodyPr wrap="square" rtlCol="0" anchor="ctr"/>
+          <a:lstStyle/>
+          <a:p>
+            <a:pPr indent="0" marL="0">
+              <a:buNone/>
+            </a:pPr>
+            <a:r>
+              <a:rPr lang="en-US" sz="1200" b="1" dirty="0">
+                <a:solidFill>
+                  <a:srgbClr val="1E293B"/>
+                </a:solidFill>
+              </a:rPr>
+              <a:t>热点定位</a:t>
+            </a:r>
+            <a:endParaRPr lang="en-US" sz="1200" dirty="0"/>
+          </a:p>
+        </p:txBody>
+      </p:sp>
+      <p:sp>
+        <p:nvSpPr>
+          <p:cNvPr id="12" name="Text 10"/>
+          <p:cNvSpPr/>
+          <p:nvPr/>
+        </p:nvSpPr>
+        <p:spPr>
+          <a:xfrm>
+            <a:off x="2103120" y="1764792"/>
+            <a:ext cx="3566160" cy="365760"/>
+          </a:xfrm>
+          <a:prstGeom prst="rect">
+            <a:avLst/>
+          </a:prstGeom>
+          <a:noFill/>
+          <a:ln/>
+        </p:spPr>
+        <p:txBody>
+          <a:bodyPr wrap="square" rtlCol="0" anchor="ctr"/>
+          <a:lstStyle/>
+          <a:p>
+            <a:pPr indent="0" marL="0">
+              <a:buNone/>
+            </a:pPr>
+            <a:r>
+              <a:rPr lang="en-US" sz="1200" dirty="0">
                 <a:solidFill>
                   <a:srgbClr val="334155"/>
                 </a:solidFill>
               </a:rPr>
-              <a:t>热点定位 → 批量发布解决；perf 分析 → 逐层拆解替代</a:t>
+              <a:t>ring 共享状态竞争 → 批量发布解决</a:t>
             </a:r>
-            <a:endParaRPr lang="en-US" sz="1500" dirty="0"/>
+            <a:endParaRPr lang="en-US" sz="1200" dirty="0"/>
           </a:p>
+        </p:txBody>
+      </p:sp>
+      <p:sp>
+        <p:nvSpPr>
+          <p:cNvPr id="13" name="Shape 11"/>
+          <p:cNvSpPr/>
+          <p:nvPr/>
+        </p:nvSpPr>
+        <p:spPr>
+          <a:xfrm>
+            <a:off x="502920" y="2377440"/>
+            <a:ext cx="365760" cy="365760"/>
+          </a:xfrm>
+          <a:prstGeom prst="rect">
+            <a:avLst>
+              <a:gd name="adj" fmla="val 50000"/>
+            </a:avLst>
+          </a:prstGeom>
+          <a:solidFill>
+            <a:srgbClr val="2563EB"/>
+          </a:solidFill>
+          <a:ln/>
+        </p:spPr>
+      </p:sp>
+      <p:sp>
+        <p:nvSpPr>
+          <p:cNvPr id="14" name="Text 12"/>
+          <p:cNvSpPr/>
+          <p:nvPr/>
+        </p:nvSpPr>
+        <p:spPr>
+          <a:xfrm>
+            <a:off x="502920" y="2377440"/>
+            <a:ext cx="365760" cy="365760"/>
+          </a:xfrm>
+          <a:prstGeom prst="rect">
+            <a:avLst/>
+          </a:prstGeom>
+          <a:noFill/>
+          <a:ln/>
+        </p:spPr>
+        <p:txBody>
+          <a:bodyPr wrap="square" rtlCol="0" anchor="ctr"/>
+          <a:lstStyle/>
           <a:p>
-            <a:pPr marL="342900" indent="-342900">
-              <a:lnSpc>
-                <a:spcPts val="2400"/>
-              </a:lnSpc>
-              <a:buSzPct val="100000"/>
-              <a:buChar char="•"/>
+            <a:pPr algn="ctr" indent="0" marL="0">
+              <a:buNone/>
             </a:pPr>
             <a:r>
-              <a:rPr lang="en-US" sz="1400" dirty="0">
+              <a:rPr lang="en-US" sz="1200" b="1" dirty="0">
+                <a:solidFill>
+                  <a:srgbClr val="FFFFFF"/>
+                </a:solidFill>
+                <a:latin typeface="Consolas" pitchFamily="34" charset="0"/>
+                <a:ea typeface="Consolas" pitchFamily="34" charset="-122"/>
+                <a:cs typeface="Consolas" pitchFamily="34" charset="-120"/>
+              </a:rPr>
+              <a:t>2</a:t>
+            </a:r>
+            <a:endParaRPr lang="en-US" sz="1200" dirty="0"/>
+          </a:p>
+        </p:txBody>
+      </p:sp>
+      <p:sp>
+        <p:nvSpPr>
+          <p:cNvPr id="15" name="Text 13"/>
+          <p:cNvSpPr/>
+          <p:nvPr/>
+        </p:nvSpPr>
+        <p:spPr>
+          <a:xfrm>
+            <a:off x="1005840" y="2359152"/>
+            <a:ext cx="1097280" cy="365760"/>
+          </a:xfrm>
+          <a:prstGeom prst="rect">
+            <a:avLst/>
+          </a:prstGeom>
+          <a:noFill/>
+          <a:ln/>
+        </p:spPr>
+        <p:txBody>
+          <a:bodyPr wrap="square" rtlCol="0" anchor="ctr"/>
+          <a:lstStyle/>
+          <a:p>
+            <a:pPr indent="0" marL="0">
+              <a:buNone/>
+            </a:pPr>
+            <a:r>
+              <a:rPr lang="en-US" sz="1200" b="1" dirty="0">
+                <a:solidFill>
+                  <a:srgbClr val="1E293B"/>
+                </a:solidFill>
+              </a:rPr>
+              <a:t>perf 分析</a:t>
+            </a:r>
+            <a:endParaRPr lang="en-US" sz="1200" dirty="0"/>
+          </a:p>
+        </p:txBody>
+      </p:sp>
+      <p:sp>
+        <p:nvSpPr>
+          <p:cNvPr id="16" name="Text 14"/>
+          <p:cNvSpPr/>
+          <p:nvPr/>
+        </p:nvSpPr>
+        <p:spPr>
+          <a:xfrm>
+            <a:off x="2103120" y="2359152"/>
+            <a:ext cx="3566160" cy="365760"/>
+          </a:xfrm>
+          <a:prstGeom prst="rect">
+            <a:avLst/>
+          </a:prstGeom>
+          <a:noFill/>
+          <a:ln/>
+        </p:spPr>
+        <p:txBody>
+          <a:bodyPr wrap="square" rtlCol="0" anchor="ctr"/>
+          <a:lstStyle/>
+          <a:p>
+            <a:pPr indent="0" marL="0">
+              <a:buNone/>
+            </a:pPr>
+            <a:r>
+              <a:rPr lang="en-US" sz="1200" dirty="0">
                 <a:solidFill>
                   <a:srgbClr val="334155"/>
                 </a:solidFill>
               </a:rPr>
-              <a:t>Gitee fork 到公司 GitLab 并完成移植</a:t>
+              <a:t>用逐层拆解替代，粒度更细</a:t>
             </a:r>
-            <a:endParaRPr lang="en-US" sz="1500" dirty="0"/>
+            <a:endParaRPr lang="en-US" sz="1200" dirty="0"/>
           </a:p>
+        </p:txBody>
+      </p:sp>
+      <p:sp>
+        <p:nvSpPr>
+          <p:cNvPr id="17" name="Shape 15"/>
+          <p:cNvSpPr/>
+          <p:nvPr/>
+        </p:nvSpPr>
+        <p:spPr>
+          <a:xfrm>
+            <a:off x="502920" y="2971800"/>
+            <a:ext cx="365760" cy="365760"/>
+          </a:xfrm>
+          <a:prstGeom prst="rect">
+            <a:avLst>
+              <a:gd name="adj" fmla="val 50000"/>
+            </a:avLst>
+          </a:prstGeom>
+          <a:solidFill>
+            <a:srgbClr val="2563EB"/>
+          </a:solidFill>
+          <a:ln/>
+        </p:spPr>
+      </p:sp>
+      <p:sp>
+        <p:nvSpPr>
+          <p:cNvPr id="18" name="Text 16"/>
+          <p:cNvSpPr/>
+          <p:nvPr/>
+        </p:nvSpPr>
+        <p:spPr>
+          <a:xfrm>
+            <a:off x="502920" y="2971800"/>
+            <a:ext cx="365760" cy="365760"/>
+          </a:xfrm>
+          <a:prstGeom prst="rect">
+            <a:avLst/>
+          </a:prstGeom>
+          <a:noFill/>
+          <a:ln/>
+        </p:spPr>
+        <p:txBody>
+          <a:bodyPr wrap="square" rtlCol="0" anchor="ctr"/>
+          <a:lstStyle/>
           <a:p>
-            <a:pPr marL="342900" indent="-342900">
-              <a:lnSpc>
-                <a:spcPts val="2400"/>
-              </a:lnSpc>
-              <a:buSzPct val="100000"/>
-              <a:buChar char="•"/>
+            <a:pPr algn="ctr" indent="0" marL="0">
+              <a:buNone/>
             </a:pPr>
             <a:r>
-              <a:rPr lang="en-US" sz="1400" dirty="0">
+              <a:rPr lang="en-US" sz="1200" b="1" dirty="0">
+                <a:solidFill>
+                  <a:srgbClr val="FFFFFF"/>
+                </a:solidFill>
+                <a:latin typeface="Consolas" pitchFamily="34" charset="0"/>
+                <a:ea typeface="Consolas" pitchFamily="34" charset="-122"/>
+                <a:cs typeface="Consolas" pitchFamily="34" charset="-120"/>
+              </a:rPr>
+              <a:t>3</a:t>
+            </a:r>
+            <a:endParaRPr lang="en-US" sz="1200" dirty="0"/>
+          </a:p>
+        </p:txBody>
+      </p:sp>
+      <p:sp>
+        <p:nvSpPr>
+          <p:cNvPr id="19" name="Text 17"/>
+          <p:cNvSpPr/>
+          <p:nvPr/>
+        </p:nvSpPr>
+        <p:spPr>
+          <a:xfrm>
+            <a:off x="1005840" y="2953512"/>
+            <a:ext cx="1097280" cy="365760"/>
+          </a:xfrm>
+          <a:prstGeom prst="rect">
+            <a:avLst/>
+          </a:prstGeom>
+          <a:noFill/>
+          <a:ln/>
+        </p:spPr>
+        <p:txBody>
+          <a:bodyPr wrap="square" rtlCol="0" anchor="ctr"/>
+          <a:lstStyle/>
+          <a:p>
+            <a:pPr indent="0" marL="0">
+              <a:buNone/>
+            </a:pPr>
+            <a:r>
+              <a:rPr lang="en-US" sz="1200" b="1" dirty="0">
+                <a:solidFill>
+                  <a:srgbClr val="1E293B"/>
+                </a:solidFill>
+              </a:rPr>
+              <a:t>代码移植</a:t>
+            </a:r>
+            <a:endParaRPr lang="en-US" sz="1200" dirty="0"/>
+          </a:p>
+        </p:txBody>
+      </p:sp>
+      <p:sp>
+        <p:nvSpPr>
+          <p:cNvPr id="20" name="Text 18"/>
+          <p:cNvSpPr/>
+          <p:nvPr/>
+        </p:nvSpPr>
+        <p:spPr>
+          <a:xfrm>
+            <a:off x="2103120" y="2953512"/>
+            <a:ext cx="3566160" cy="365760"/>
+          </a:xfrm>
+          <a:prstGeom prst="rect">
+            <a:avLst/>
+          </a:prstGeom>
+          <a:noFill/>
+          <a:ln/>
+        </p:spPr>
+        <p:txBody>
+          <a:bodyPr wrap="square" rtlCol="0" anchor="ctr"/>
+          <a:lstStyle/>
+          <a:p>
+            <a:pPr indent="0" marL="0">
+              <a:buNone/>
+            </a:pPr>
+            <a:r>
+              <a:rPr lang="en-US" sz="1200" dirty="0">
                 <a:solidFill>
                   <a:srgbClr val="334155"/>
                 </a:solidFill>
               </a:rPr>
-              <a:t>eBPF 高线程数据补充：8T/16T 下 eBPF 反超 2.5~3x</a:t>
+              <a:t>Gitee fork 到公司 GitLab 并完成</a:t>
             </a:r>
-            <a:pPr indent="0" marL="0">
-              <a:lnSpc>
-                <a:spcPts val="2400"/>
-              </a:lnSpc>
+            <a:endParaRPr lang="en-US" sz="1200" dirty="0"/>
+          </a:p>
+        </p:txBody>
+      </p:sp>
+      <p:sp>
+        <p:nvSpPr>
+          <p:cNvPr id="21" name="Shape 19"/>
+          <p:cNvSpPr/>
+          <p:nvPr/>
+        </p:nvSpPr>
+        <p:spPr>
+          <a:xfrm>
+            <a:off x="502920" y="3566160"/>
+            <a:ext cx="365760" cy="365760"/>
+          </a:xfrm>
+          <a:prstGeom prst="rect">
+            <a:avLst>
+              <a:gd name="adj" fmla="val 50000"/>
+            </a:avLst>
+          </a:prstGeom>
+          <a:solidFill>
+            <a:srgbClr val="2563EB"/>
+          </a:solidFill>
+          <a:ln/>
+        </p:spPr>
+      </p:sp>
+      <p:sp>
+        <p:nvSpPr>
+          <p:cNvPr id="22" name="Text 20"/>
+          <p:cNvSpPr/>
+          <p:nvPr/>
+        </p:nvSpPr>
+        <p:spPr>
+          <a:xfrm>
+            <a:off x="502920" y="3566160"/>
+            <a:ext cx="365760" cy="365760"/>
+          </a:xfrm>
+          <a:prstGeom prst="rect">
+            <a:avLst/>
+          </a:prstGeom>
+          <a:noFill/>
+          <a:ln/>
+        </p:spPr>
+        <p:txBody>
+          <a:bodyPr wrap="square" rtlCol="0" anchor="ctr"/>
+          <a:lstStyle/>
+          <a:p>
+            <a:pPr algn="ctr" indent="0" marL="0">
               <a:buNone/>
             </a:pPr>
             <a:r>
-              <a:rPr lang="en-US" sz="1500" b="1" dirty="0">
+              <a:rPr lang="en-US" sz="1200" b="1" dirty="0">
                 <a:solidFill>
-                  <a:srgbClr val="2563EB"/>
+                  <a:srgbClr val="FFFFFF"/>
+                </a:solidFill>
+                <a:latin typeface="Consolas" pitchFamily="34" charset="0"/>
+                <a:ea typeface="Consolas" pitchFamily="34" charset="-122"/>
+                <a:cs typeface="Consolas" pitchFamily="34" charset="-120"/>
+              </a:rPr>
+              <a:t>4</a:t>
+            </a:r>
+            <a:endParaRPr lang="en-US" sz="1200" dirty="0"/>
+          </a:p>
+        </p:txBody>
+      </p:sp>
+      <p:sp>
+        <p:nvSpPr>
+          <p:cNvPr id="23" name="Text 21"/>
+          <p:cNvSpPr/>
+          <p:nvPr/>
+        </p:nvSpPr>
+        <p:spPr>
+          <a:xfrm>
+            <a:off x="1005840" y="3547872"/>
+            <a:ext cx="1097280" cy="365760"/>
+          </a:xfrm>
+          <a:prstGeom prst="rect">
+            <a:avLst/>
+          </a:prstGeom>
+          <a:noFill/>
+          <a:ln/>
+        </p:spPr>
+        <p:txBody>
+          <a:bodyPr wrap="square" rtlCol="0" anchor="ctr"/>
+          <a:lstStyle/>
+          <a:p>
+            <a:pPr indent="0" marL="0">
+              <a:buNone/>
+            </a:pPr>
+            <a:r>
+              <a:rPr lang="en-US" sz="1200" b="1" dirty="0">
+                <a:solidFill>
+                  <a:srgbClr val="1E293B"/>
                 </a:solidFill>
               </a:rPr>
-              <a:t>Sub-stage 36 死锁修复</a:t>
+              <a:t>eBPF 数据</a:t>
             </a:r>
-            <a:endParaRPr lang="en-US" sz="1500" dirty="0"/>
+            <a:endParaRPr lang="en-US" sz="1200" dirty="0"/>
           </a:p>
+        </p:txBody>
+      </p:sp>
+      <p:sp>
+        <p:nvSpPr>
+          <p:cNvPr id="24" name="Text 22"/>
+          <p:cNvSpPr/>
+          <p:nvPr/>
+        </p:nvSpPr>
+        <p:spPr>
+          <a:xfrm>
+            <a:off x="2103120" y="3547872"/>
+            <a:ext cx="3566160" cy="365760"/>
+          </a:xfrm>
+          <a:prstGeom prst="rect">
+            <a:avLst/>
+          </a:prstGeom>
+          <a:noFill/>
+          <a:ln/>
+        </p:spPr>
+        <p:txBody>
+          <a:bodyPr wrap="square" rtlCol="0" anchor="ctr"/>
+          <a:lstStyle/>
           <a:p>
-            <a:pPr marL="342900" indent="-342900">
-              <a:lnSpc>
-                <a:spcPts val="2400"/>
-              </a:lnSpc>
-              <a:buSzPct val="100000"/>
-              <a:buChar char="•"/>
+            <a:pPr indent="0" marL="0">
+              <a:buNone/>
             </a:pPr>
             <a:r>
-              <a:rPr lang="en-US" sz="1400" dirty="0">
+              <a:rPr lang="en-US" sz="1200" dirty="0">
                 <a:solidFill>
                   <a:srgbClr val="334155"/>
                 </a:solidFill>
               </a:rPr>
-              <a:t>根因：外层 Lock() + Write() 内部重复加锁同一非递归互斥锁 = 未定义行为</a:t>
+              <a:t>补 8T/16T，高线程反超 2.5~3x</a:t>
             </a:r>
-            <a:endParaRPr lang="en-US" sz="1500" dirty="0"/>
+            <a:endParaRPr lang="en-US" sz="1200" dirty="0"/>
           </a:p>
+        </p:txBody>
+      </p:sp>
+      <p:sp>
+        <p:nvSpPr>
+          <p:cNvPr id="25" name="Shape 23"/>
+          <p:cNvSpPr/>
+          <p:nvPr/>
+        </p:nvSpPr>
+        <p:spPr>
+          <a:xfrm>
+            <a:off x="6217920" y="1234440"/>
+            <a:ext cx="5486400" cy="411480"/>
+          </a:xfrm>
+          <a:prstGeom prst="rect">
+            <a:avLst>
+              <a:gd name="adj" fmla="val 11111"/>
+            </a:avLst>
+          </a:prstGeom>
+          <a:solidFill>
+            <a:srgbClr val="FEF2F2"/>
+          </a:solidFill>
+          <a:ln/>
+        </p:spPr>
+      </p:sp>
+      <p:sp>
+        <p:nvSpPr>
+          <p:cNvPr id="26" name="Text 24"/>
+          <p:cNvSpPr/>
+          <p:nvPr/>
+        </p:nvSpPr>
+        <p:spPr>
+          <a:xfrm>
+            <a:off x="6400800" y="1234440"/>
+            <a:ext cx="5120640" cy="411480"/>
+          </a:xfrm>
+          <a:prstGeom prst="rect">
+            <a:avLst/>
+          </a:prstGeom>
+          <a:noFill/>
+          <a:ln/>
+        </p:spPr>
+        <p:txBody>
+          <a:bodyPr wrap="square" rtlCol="0" anchor="ctr"/>
+          <a:lstStyle/>
           <a:p>
-            <a:pPr marL="342900" indent="-342900">
-              <a:lnSpc>
-                <a:spcPts val="2400"/>
-              </a:lnSpc>
-              <a:buSzPct val="100000"/>
-              <a:buChar char="•"/>
+            <a:pPr indent="0" marL="0">
+              <a:buNone/>
             </a:pPr>
             <a:r>
-              <a:rPr lang="en-US" sz="1400" dirty="0">
+              <a:rPr lang="en-US" sz="1300" b="1" dirty="0">
                 <a:solidFill>
-                  <a:srgbClr val="334155"/>
+                  <a:srgbClr val="DC2626"/>
                 </a:solidFill>
               </a:rPr>
-              <a:t>修复：删除外层 Lock/Unlock，commit e19571b</a:t>
+              <a:t>子阶段 36 死锁修复</a:t>
             </a:r>
-            <a:endParaRPr lang="en-US" sz="1500" dirty="0"/>
+            <a:endParaRPr lang="en-US" sz="1300" dirty="0"/>
           </a:p>
+        </p:txBody>
+      </p:sp>
+      <p:sp>
+        <p:nvSpPr>
+          <p:cNvPr id="27" name="Shape 25"/>
+          <p:cNvSpPr/>
+          <p:nvPr/>
+        </p:nvSpPr>
+        <p:spPr>
+          <a:xfrm>
+            <a:off x="6217920" y="1828800"/>
+            <a:ext cx="2468880" cy="1280160"/>
+          </a:xfrm>
+          <a:prstGeom prst="rect">
+            <a:avLst>
+              <a:gd name="adj" fmla="val 5714"/>
+            </a:avLst>
+          </a:prstGeom>
+          <a:solidFill>
+            <a:srgbClr val="FEF2F2"/>
+          </a:solidFill>
+          <a:ln/>
+        </p:spPr>
+      </p:sp>
+      <p:sp>
+        <p:nvSpPr>
+          <p:cNvPr id="28" name="Text 26"/>
+          <p:cNvSpPr/>
+          <p:nvPr/>
+        </p:nvSpPr>
+        <p:spPr>
+          <a:xfrm>
+            <a:off x="6309360" y="1874520"/>
+            <a:ext cx="2286000" cy="274320"/>
+          </a:xfrm>
+          <a:prstGeom prst="rect">
+            <a:avLst/>
+          </a:prstGeom>
+          <a:noFill/>
+          <a:ln/>
+        </p:spPr>
+        <p:txBody>
+          <a:bodyPr wrap="square" rtlCol="0" anchor="ctr"/>
+          <a:lstStyle/>
           <a:p>
-            <a:pPr marL="342900" indent="-342900">
-              <a:lnSpc>
-                <a:spcPts val="2400"/>
-              </a:lnSpc>
-              <a:buSzPct val="100000"/>
-              <a:buChar char="•"/>
+            <a:pPr algn="ctr" indent="0" marL="0">
+              <a:buNone/>
             </a:pPr>
             <a:r>
-              <a:rPr lang="en-US" sz="1400" dirty="0">
+              <a:rPr lang="en-US" sz="1000" dirty="0">
                 <a:solidFill>
-                  <a:srgbClr val="334155"/>
+                  <a:srgbClr val="DC2626"/>
                 </a:solidFill>
               </a:rPr>
-              <a:t>旧数据作废：double-lock UB 导致 31x 性能退化（8.60s → 0.28s）</a:t>
+              <a:t>修复前</a:t>
             </a:r>
-            <a:endParaRPr lang="en-US" sz="1500" dirty="0"/>
+            <a:endParaRPr lang="en-US" sz="1000" dirty="0"/>
+          </a:p>
+        </p:txBody>
+      </p:sp>
+      <p:sp>
+        <p:nvSpPr>
+          <p:cNvPr id="29" name="Text 27"/>
+          <p:cNvSpPr/>
+          <p:nvPr/>
+        </p:nvSpPr>
+        <p:spPr>
+          <a:xfrm>
+            <a:off x="6309360" y="2194560"/>
+            <a:ext cx="2286000" cy="548640"/>
+          </a:xfrm>
+          <a:prstGeom prst="rect">
+            <a:avLst/>
+          </a:prstGeom>
+          <a:noFill/>
+          <a:ln/>
+        </p:spPr>
+        <p:txBody>
+          <a:bodyPr wrap="square" rtlCol="0" anchor="ctr"/>
+          <a:lstStyle/>
+          <a:p>
+            <a:pPr algn="ctr" indent="0" marL="0">
+              <a:buNone/>
+            </a:pPr>
+            <a:r>
+              <a:rPr lang="en-US" sz="2800" b="1" dirty="0">
+                <a:solidFill>
+                  <a:srgbClr val="DC2626"/>
+                </a:solidFill>
+                <a:latin typeface="Consolas" pitchFamily="34" charset="0"/>
+                <a:ea typeface="Consolas" pitchFamily="34" charset="-122"/>
+                <a:cs typeface="Consolas" pitchFamily="34" charset="-120"/>
+              </a:rPr>
+              <a:t>8.60s</a:t>
+            </a:r>
+            <a:endParaRPr lang="en-US" sz="2800" dirty="0"/>
+          </a:p>
+        </p:txBody>
+      </p:sp>
+      <p:sp>
+        <p:nvSpPr>
+          <p:cNvPr id="30" name="Text 28"/>
+          <p:cNvSpPr/>
+          <p:nvPr/>
+        </p:nvSpPr>
+        <p:spPr>
+          <a:xfrm>
+            <a:off x="6309360" y="2697480"/>
+            <a:ext cx="2286000" cy="274320"/>
+          </a:xfrm>
+          <a:prstGeom prst="rect">
+            <a:avLst/>
+          </a:prstGeom>
+          <a:noFill/>
+          <a:ln/>
+        </p:spPr>
+        <p:txBody>
+          <a:bodyPr wrap="square" rtlCol="0" anchor="ctr"/>
+          <a:lstStyle/>
+          <a:p>
+            <a:pPr algn="ctr" indent="0" marL="0">
+              <a:buNone/>
+            </a:pPr>
+            <a:r>
+              <a:rPr lang="en-US" sz="900" dirty="0">
+                <a:solidFill>
+                  <a:srgbClr val="64748B"/>
+                </a:solidFill>
+              </a:rPr>
+              <a:t>子阶段 34 · 1 线程</a:t>
+            </a:r>
+            <a:endParaRPr lang="en-US" sz="900" dirty="0"/>
+          </a:p>
+        </p:txBody>
+      </p:sp>
+      <p:sp>
+        <p:nvSpPr>
+          <p:cNvPr id="31" name="Shape 29"/>
+          <p:cNvSpPr/>
+          <p:nvPr/>
+        </p:nvSpPr>
+        <p:spPr>
+          <a:xfrm>
+            <a:off x="9235440" y="1828800"/>
+            <a:ext cx="2468880" cy="1280160"/>
+          </a:xfrm>
+          <a:prstGeom prst="rect">
+            <a:avLst>
+              <a:gd name="adj" fmla="val 5714"/>
+            </a:avLst>
+          </a:prstGeom>
+          <a:solidFill>
+            <a:srgbClr val="ECFDF5"/>
+          </a:solidFill>
+          <a:ln/>
+        </p:spPr>
+      </p:sp>
+      <p:sp>
+        <p:nvSpPr>
+          <p:cNvPr id="32" name="Text 30"/>
+          <p:cNvSpPr/>
+          <p:nvPr/>
+        </p:nvSpPr>
+        <p:spPr>
+          <a:xfrm>
+            <a:off x="9326880" y="1874520"/>
+            <a:ext cx="2286000" cy="274320"/>
+          </a:xfrm>
+          <a:prstGeom prst="rect">
+            <a:avLst/>
+          </a:prstGeom>
+          <a:noFill/>
+          <a:ln/>
+        </p:spPr>
+        <p:txBody>
+          <a:bodyPr wrap="square" rtlCol="0" anchor="ctr"/>
+          <a:lstStyle/>
+          <a:p>
+            <a:pPr algn="ctr" indent="0" marL="0">
+              <a:buNone/>
+            </a:pPr>
+            <a:r>
+              <a:rPr lang="en-US" sz="1000" dirty="0">
+                <a:solidFill>
+                  <a:srgbClr val="059669"/>
+                </a:solidFill>
+              </a:rPr>
+              <a:t>修复后</a:t>
+            </a:r>
+            <a:endParaRPr lang="en-US" sz="1000" dirty="0"/>
+          </a:p>
+        </p:txBody>
+      </p:sp>
+      <p:sp>
+        <p:nvSpPr>
+          <p:cNvPr id="33" name="Text 31"/>
+          <p:cNvSpPr/>
+          <p:nvPr/>
+        </p:nvSpPr>
+        <p:spPr>
+          <a:xfrm>
+            <a:off x="9326880" y="2194560"/>
+            <a:ext cx="2286000" cy="548640"/>
+          </a:xfrm>
+          <a:prstGeom prst="rect">
+            <a:avLst/>
+          </a:prstGeom>
+          <a:noFill/>
+          <a:ln/>
+        </p:spPr>
+        <p:txBody>
+          <a:bodyPr wrap="square" rtlCol="0" anchor="ctr"/>
+          <a:lstStyle/>
+          <a:p>
+            <a:pPr algn="ctr" indent="0" marL="0">
+              <a:buNone/>
+            </a:pPr>
+            <a:r>
+              <a:rPr lang="en-US" sz="2800" b="1" dirty="0">
+                <a:solidFill>
+                  <a:srgbClr val="059669"/>
+                </a:solidFill>
+                <a:latin typeface="Consolas" pitchFamily="34" charset="0"/>
+                <a:ea typeface="Consolas" pitchFamily="34" charset="-122"/>
+                <a:cs typeface="Consolas" pitchFamily="34" charset="-120"/>
+              </a:rPr>
+              <a:t>0.28s</a:t>
+            </a:r>
+            <a:endParaRPr lang="en-US" sz="2800" dirty="0"/>
+          </a:p>
+        </p:txBody>
+      </p:sp>
+      <p:sp>
+        <p:nvSpPr>
+          <p:cNvPr id="34" name="Text 32"/>
+          <p:cNvSpPr/>
+          <p:nvPr/>
+        </p:nvSpPr>
+        <p:spPr>
+          <a:xfrm>
+            <a:off x="9326880" y="2697480"/>
+            <a:ext cx="2286000" cy="274320"/>
+          </a:xfrm>
+          <a:prstGeom prst="rect">
+            <a:avLst/>
+          </a:prstGeom>
+          <a:noFill/>
+          <a:ln/>
+        </p:spPr>
+        <p:txBody>
+          <a:bodyPr wrap="square" rtlCol="0" anchor="ctr"/>
+          <a:lstStyle/>
+          <a:p>
+            <a:pPr algn="ctr" indent="0" marL="0">
+              <a:buNone/>
+            </a:pPr>
+            <a:r>
+              <a:rPr lang="en-US" sz="900" dirty="0">
+                <a:solidFill>
+                  <a:srgbClr val="64748B"/>
+                </a:solidFill>
+              </a:rPr>
+              <a:t>子阶段 34 · 1 线程</a:t>
+            </a:r>
+            <a:endParaRPr lang="en-US" sz="900" dirty="0"/>
+          </a:p>
+        </p:txBody>
+      </p:sp>
+      <p:sp>
+        <p:nvSpPr>
+          <p:cNvPr id="35" name="Text 33"/>
+          <p:cNvSpPr/>
+          <p:nvPr/>
+        </p:nvSpPr>
+        <p:spPr>
+          <a:xfrm>
+            <a:off x="8686800" y="2103120"/>
+            <a:ext cx="548640" cy="731520"/>
+          </a:xfrm>
+          <a:prstGeom prst="rect">
+            <a:avLst/>
+          </a:prstGeom>
+          <a:noFill/>
+          <a:ln/>
+        </p:spPr>
+        <p:txBody>
+          <a:bodyPr wrap="square" rtlCol="0" anchor="ctr"/>
+          <a:lstStyle/>
+          <a:p>
+            <a:pPr algn="ctr" indent="0" marL="0">
+              <a:buNone/>
+            </a:pPr>
+            <a:r>
+              <a:rPr lang="en-US" sz="2400" dirty="0">
+                <a:solidFill>
+                  <a:srgbClr val="64748B"/>
+                </a:solidFill>
+              </a:rPr>
+              <a:t>→</a:t>
+            </a:r>
+            <a:endParaRPr lang="en-US" sz="2400" dirty="0"/>
+          </a:p>
+        </p:txBody>
+      </p:sp>
+      <p:sp>
+        <p:nvSpPr>
+          <p:cNvPr id="36" name="Shape 34"/>
+          <p:cNvSpPr/>
+          <p:nvPr/>
+        </p:nvSpPr>
+        <p:spPr>
+          <a:xfrm>
+            <a:off x="6217920" y="3337560"/>
+            <a:ext cx="5486400" cy="1280160"/>
+          </a:xfrm>
+          <a:prstGeom prst="rect">
+            <a:avLst>
+              <a:gd name="adj" fmla="val 5714"/>
+            </a:avLst>
+          </a:prstGeom>
+          <a:solidFill>
+            <a:srgbClr val="FFFFFF"/>
+          </a:solidFill>
+          <a:ln/>
+          <a:effectLst>
+            <a:outerShdw sx="100000" sy="100000" kx="0" ky="0" algn="bl" rotWithShape="0" blurRad="38100" dist="12700" dir="16200000">
+              <a:srgbClr val="000000">
+                <a:alpha val="4000"/>
+              </a:srgbClr>
+            </a:outerShdw>
+          </a:effectLst>
+        </p:spPr>
+      </p:sp>
+      <p:sp>
+        <p:nvSpPr>
+          <p:cNvPr id="37" name="Text 35"/>
+          <p:cNvSpPr/>
+          <p:nvPr/>
+        </p:nvSpPr>
+        <p:spPr>
+          <a:xfrm>
+            <a:off x="6400800" y="3383280"/>
+            <a:ext cx="5120640" cy="274320"/>
+          </a:xfrm>
+          <a:prstGeom prst="rect">
+            <a:avLst/>
+          </a:prstGeom>
+          <a:noFill/>
+          <a:ln/>
+        </p:spPr>
+        <p:txBody>
+          <a:bodyPr wrap="square" rtlCol="0" anchor="ctr"/>
+          <a:lstStyle/>
+          <a:p>
+            <a:pPr indent="0" marL="0">
+              <a:buNone/>
+            </a:pPr>
+            <a:r>
+              <a:rPr lang="en-US" sz="1100" b="1" dirty="0">
+                <a:solidFill>
+                  <a:srgbClr val="64748B"/>
+                </a:solidFill>
+              </a:rPr>
+              <a:t>根因</a:t>
+            </a:r>
+            <a:endParaRPr lang="en-US" sz="1100" dirty="0"/>
+          </a:p>
+        </p:txBody>
+      </p:sp>
+      <p:sp>
+        <p:nvSpPr>
+          <p:cNvPr id="38" name="Text 36"/>
+          <p:cNvSpPr/>
+          <p:nvPr/>
+        </p:nvSpPr>
+        <p:spPr>
+          <a:xfrm>
+            <a:off x="6400800" y="3611880"/>
+            <a:ext cx="5120640" cy="320040"/>
+          </a:xfrm>
+          <a:prstGeom prst="rect">
+            <a:avLst/>
+          </a:prstGeom>
+          <a:noFill/>
+          <a:ln/>
+        </p:spPr>
+        <p:txBody>
+          <a:bodyPr wrap="square" rtlCol="0" anchor="ctr"/>
+          <a:lstStyle/>
+          <a:p>
+            <a:pPr indent="0" marL="0">
+              <a:buNone/>
+            </a:pPr>
+            <a:r>
+              <a:rPr lang="en-US" sz="1300" dirty="0">
+                <a:solidFill>
+                  <a:srgbClr val="1E293B"/>
+                </a:solidFill>
+              </a:rPr>
+              <a:t>外层 Lock() + Write() 内部重复加锁同一非递归互斥锁</a:t>
+            </a:r>
+            <a:endParaRPr lang="en-US" sz="1300" dirty="0"/>
+          </a:p>
+        </p:txBody>
+      </p:sp>
+      <p:sp>
+        <p:nvSpPr>
+          <p:cNvPr id="39" name="Text 37"/>
+          <p:cNvSpPr/>
+          <p:nvPr/>
+        </p:nvSpPr>
+        <p:spPr>
+          <a:xfrm>
+            <a:off x="6400800" y="3931920"/>
+            <a:ext cx="5120640" cy="320040"/>
+          </a:xfrm>
+          <a:prstGeom prst="rect">
+            <a:avLst/>
+          </a:prstGeom>
+          <a:noFill/>
+          <a:ln/>
+        </p:spPr>
+        <p:txBody>
+          <a:bodyPr wrap="square" rtlCol="0" anchor="ctr"/>
+          <a:lstStyle/>
+          <a:p>
+            <a:pPr indent="0" marL="0">
+              <a:buNone/>
+            </a:pPr>
+            <a:r>
+              <a:rPr lang="en-US" sz="1200" dirty="0">
+                <a:solidFill>
+                  <a:srgbClr val="DC2626"/>
+                </a:solidFill>
+              </a:rPr>
+              <a:t>→ POSIX 未定义行为 → 采集的数据无意义 → 全部作废重采</a:t>
+            </a:r>
+            <a:endParaRPr lang="en-US" sz="1200" dirty="0"/>
+          </a:p>
+        </p:txBody>
+      </p:sp>
+      <p:sp>
+        <p:nvSpPr>
+          <p:cNvPr id="40" name="Text 38"/>
+          <p:cNvSpPr/>
+          <p:nvPr/>
+        </p:nvSpPr>
+        <p:spPr>
+          <a:xfrm>
+            <a:off x="6400800" y="4251960"/>
+            <a:ext cx="5120640" cy="274320"/>
+          </a:xfrm>
+          <a:prstGeom prst="rect">
+            <a:avLst/>
+          </a:prstGeom>
+          <a:noFill/>
+          <a:ln/>
+        </p:spPr>
+        <p:txBody>
+          <a:bodyPr wrap="square" rtlCol="0" anchor="ctr"/>
+          <a:lstStyle/>
+          <a:p>
+            <a:pPr indent="0" marL="0">
+              <a:buNone/>
+            </a:pPr>
+            <a:r>
+              <a:rPr lang="en-US" sz="1100" dirty="0">
+                <a:solidFill>
+                  <a:srgbClr val="64748B"/>
+                </a:solidFill>
+              </a:rPr>
+              <a:t>commit e19571b：删除外层 Lock/Unlock，Write() 自行管理锁</a:t>
+            </a:r>
+            <a:endParaRPr lang="en-US" sz="1100" dirty="0"/>
+          </a:p>
+        </p:txBody>
+      </p:sp>
+      <p:sp>
+        <p:nvSpPr>
+          <p:cNvPr id="41" name="Shape 39"/>
+          <p:cNvSpPr/>
+          <p:nvPr/>
+        </p:nvSpPr>
+        <p:spPr>
+          <a:xfrm>
+            <a:off x="502920" y="5029200"/>
+            <a:ext cx="11247120" cy="411480"/>
+          </a:xfrm>
+          <a:prstGeom prst="rect">
+            <a:avLst>
+              <a:gd name="adj" fmla="val 13333"/>
+            </a:avLst>
+          </a:prstGeom>
+          <a:solidFill>
+            <a:srgbClr val="EFF6FF"/>
+          </a:solidFill>
+          <a:ln/>
+        </p:spPr>
+      </p:sp>
+      <p:sp>
+        <p:nvSpPr>
+          <p:cNvPr id="42" name="Text 40"/>
+          <p:cNvSpPr/>
+          <p:nvPr/>
+        </p:nvSpPr>
+        <p:spPr>
+          <a:xfrm>
+            <a:off x="502920" y="5029200"/>
+            <a:ext cx="11247120" cy="411480"/>
+          </a:xfrm>
+          <a:prstGeom prst="rect">
+            <a:avLst/>
+          </a:prstGeom>
+          <a:noFill/>
+          <a:ln/>
+        </p:spPr>
+        <p:txBody>
+          <a:bodyPr wrap="square" rtlCol="0" anchor="ctr"/>
+          <a:lstStyle/>
+          <a:p>
+            <a:pPr algn="ctr" indent="0" marL="0">
+              <a:buNone/>
+            </a:pPr>
+            <a:r>
+              <a:rPr lang="en-US" sz="1300" b="1" dirty="0">
+                <a:solidFill>
+                  <a:srgbClr val="2563EB"/>
+                </a:solidFill>
+                <a:latin typeface="Arial" pitchFamily="34" charset="0"/>
+                <a:ea typeface="Arial" pitchFamily="34" charset="-122"/>
+                <a:cs typeface="Arial" pitchFamily="34" charset="-120"/>
+              </a:rPr>
+              <a:t>修复后全部 ablation 数据在 pink 重新采集 · 旧数据不再使用</a:t>
+            </a:r>
+            <a:endParaRPr lang="en-US" sz="1300" dirty="0"/>
           </a:p>
         </p:txBody>
       </p:sp>

</xml_diff>

<commit_message>
消费者 → consumer in speech and PPT
Co-Authored-By: Claude Opus 4.8 <noreply@anthropic.com>
</commit_message>
<xml_diff>
--- a/presentation/native_hook_progress_2026-06-11.pptx
+++ b/presentation/native_hook_progress_2026-06-11.pptx
@@ -281,7 +281,7 @@
               <c:strCache>
                 <c:ptCount val="1"/>
                 <c:pt idx="0">
-                  <c:v>消费者消费</c:v>
+                  <c:v>consumer drain</c:v>
                 </c:pt>
               </c:strCache>
             </c:strRef>
@@ -8923,7 +8923,7 @@
                   <a:srgbClr val="059669"/>
                 </a:solidFill>
               </a:rPr>
-              <a:t>消费者消费 0.03s · 基本免费</a:t>
+              <a:t>consumer drain 0.03s · 基本免费</a:t>
             </a:r>
             <a:endParaRPr lang="en-US" sz="1300" dirty="0"/>
           </a:p>
@@ -9000,7 +9000,7 @@
                 <a:ea typeface="Arial" pitchFamily="34" charset="-122"/>
                 <a:cs typeface="Arial" pitchFamily="34" charset="-120"/>
               </a:rPr>
-              <a:t>eventfd 系统调用是最大单一开销（65%）· 消费者消费几乎免费 · 子阶段 35/36 线程扩展平坦</a:t>
+              <a:t>eventfd 系统调用是最大单一开销（65%）· consumer drain几乎免费 · 子阶段 35/36 线程扩展平坦</a:t>
             </a:r>
             <a:endParaRPr lang="en-US" sz="1300" dirty="0"/>
           </a:p>

</xml_diff>

<commit_message>
Clarify slide 3: StackWriter layer, not entire hot path
Co-Authored-By: Claude Opus 4.8 <noreply@anthropic.com>
</commit_message>
<xml_diff>
--- a/presentation/native_hook_progress_2026-06-11.pptx
+++ b/presentation/native_hook_progress_2026-06-11.pptx
@@ -8677,7 +8677,7 @@
                 <a:ea typeface="Microsoft YaHei" pitchFamily="34" charset="-122"/>
                 <a:cs typeface="Microsoft YaHei" pitchFamily="34" charset="-120"/>
               </a:rPr>
-              <a:t>热路径三层拆解</a:t>
+              <a:t>StackWriter 层三层拆解</a:t>
             </a:r>
             <a:endParaRPr lang="en-US" sz="2400" dirty="0"/>
           </a:p>
@@ -8713,7 +8713,7 @@
                   <a:srgbClr val="64748B"/>
                 </a:solidFill>
               </a:rPr>
-              <a:t>固定 100 万次迭代，逐条模式，修复后重新采集</a:t>
+              <a:t>热路径最后一段：环形写入 → eventfd 通知 → consumer drain · 固定 100 万次迭代 · 修复后重采</a:t>
             </a:r>
             <a:endParaRPr lang="en-US" sz="1300" dirty="0"/>
           </a:p>

</xml_diff>

<commit_message>
Clarify: only sub-stage 34/35 data was invalidated, 28-33 unaffected
Co-Authored-By: Claude Opus 4.8 <noreply@anthropic.com>
</commit_message>
<xml_diff>
--- a/presentation/native_hook_progress_2026-06-11.pptx
+++ b/presentation/native_hook_progress_2026-06-11.pptx
@@ -8435,7 +8435,7 @@
                   <a:srgbClr val="DC2626"/>
                 </a:solidFill>
               </a:rPr>
-              <a:t>→ POSIX 未定义行为 → 采集的数据无意义 → 全部作废重采</a:t>
+              <a:t>→ POSIX 未定义行为 → 子阶段 34/35 旧数据作废重采</a:t>
             </a:r>
             <a:endParaRPr lang="en-US" sz="1200" dirty="0"/>
           </a:p>
@@ -8532,7 +8532,7 @@
                 <a:ea typeface="Arial" pitchFamily="34" charset="-122"/>
                 <a:cs typeface="Arial" pitchFamily="34" charset="-120"/>
               </a:rPr>
-              <a:t>修复后全部 ablation 数据在 pink 重新采集 · 旧数据不再使用</a:t>
+              <a:t>子阶段 28-33 不受影响（HookWriter 锁）· 34/35 数据已修复重采</a:t>
             </a:r>
             <a:endParaRPr lang="en-US" sz="1300" dirty="0"/>
           </a:p>

</xml_diff>

<commit_message>
Remove perf analysis from slide 2 feedback list
</commit_message>
<xml_diff>
--- a/presentation/native_hook_progress_2026-06-11.pptx
+++ b/presentation/native_hook_progress_2026-06-11.pptx
@@ -7636,7 +7636,7 @@
                   <a:srgbClr val="1E293B"/>
                 </a:solidFill>
               </a:rPr>
-              <a:t>perf 分析</a:t>
+              <a:t>代码移植</a:t>
             </a:r>
             <a:endParaRPr lang="en-US" sz="1200" dirty="0"/>
           </a:p>
@@ -7672,7 +7672,7 @@
                   <a:srgbClr val="334155"/>
                 </a:solidFill>
               </a:rPr>
-              <a:t>用逐层拆解替代，粒度更细</a:t>
+              <a:t>Gitee fork 到公司 GitLab 并完成</a:t>
             </a:r>
             <a:endParaRPr lang="en-US" sz="1200" dirty="0"/>
           </a:p>
@@ -7769,139 +7769,6 @@
                   <a:srgbClr val="1E293B"/>
                 </a:solidFill>
               </a:rPr>
-              <a:t>代码移植</a:t>
-            </a:r>
-            <a:endParaRPr lang="en-US" sz="1200" dirty="0"/>
-          </a:p>
-        </p:txBody>
-      </p:sp>
-      <p:sp>
-        <p:nvSpPr>
-          <p:cNvPr id="20" name="Text 18"/>
-          <p:cNvSpPr/>
-          <p:nvPr/>
-        </p:nvSpPr>
-        <p:spPr>
-          <a:xfrm>
-            <a:off x="2103120" y="2953512"/>
-            <a:ext cx="3566160" cy="365760"/>
-          </a:xfrm>
-          <a:prstGeom prst="rect">
-            <a:avLst/>
-          </a:prstGeom>
-          <a:noFill/>
-          <a:ln/>
-        </p:spPr>
-        <p:txBody>
-          <a:bodyPr wrap="square" rtlCol="0" anchor="ctr"/>
-          <a:lstStyle/>
-          <a:p>
-            <a:pPr indent="0" marL="0">
-              <a:buNone/>
-            </a:pPr>
-            <a:r>
-              <a:rPr lang="en-US" sz="1200" dirty="0">
-                <a:solidFill>
-                  <a:srgbClr val="334155"/>
-                </a:solidFill>
-              </a:rPr>
-              <a:t>Gitee fork 到公司 GitLab 并完成</a:t>
-            </a:r>
-            <a:endParaRPr lang="en-US" sz="1200" dirty="0"/>
-          </a:p>
-        </p:txBody>
-      </p:sp>
-      <p:sp>
-        <p:nvSpPr>
-          <p:cNvPr id="21" name="Shape 19"/>
-          <p:cNvSpPr/>
-          <p:nvPr/>
-        </p:nvSpPr>
-        <p:spPr>
-          <a:xfrm>
-            <a:off x="502920" y="3566160"/>
-            <a:ext cx="365760" cy="365760"/>
-          </a:xfrm>
-          <a:prstGeom prst="rect">
-            <a:avLst>
-              <a:gd name="adj" fmla="val 50000"/>
-            </a:avLst>
-          </a:prstGeom>
-          <a:solidFill>
-            <a:srgbClr val="2563EB"/>
-          </a:solidFill>
-          <a:ln/>
-        </p:spPr>
-      </p:sp>
-      <p:sp>
-        <p:nvSpPr>
-          <p:cNvPr id="22" name="Text 20"/>
-          <p:cNvSpPr/>
-          <p:nvPr/>
-        </p:nvSpPr>
-        <p:spPr>
-          <a:xfrm>
-            <a:off x="502920" y="3566160"/>
-            <a:ext cx="365760" cy="365760"/>
-          </a:xfrm>
-          <a:prstGeom prst="rect">
-            <a:avLst/>
-          </a:prstGeom>
-          <a:noFill/>
-          <a:ln/>
-        </p:spPr>
-        <p:txBody>
-          <a:bodyPr wrap="square" rtlCol="0" anchor="ctr"/>
-          <a:lstStyle/>
-          <a:p>
-            <a:pPr algn="ctr" indent="0" marL="0">
-              <a:buNone/>
-            </a:pPr>
-            <a:r>
-              <a:rPr lang="en-US" sz="1200" b="1" dirty="0">
-                <a:solidFill>
-                  <a:srgbClr val="FFFFFF"/>
-                </a:solidFill>
-                <a:latin typeface="Consolas" pitchFamily="34" charset="0"/>
-                <a:ea typeface="Consolas" pitchFamily="34" charset="-122"/>
-                <a:cs typeface="Consolas" pitchFamily="34" charset="-120"/>
-              </a:rPr>
-              <a:t>4</a:t>
-            </a:r>
-            <a:endParaRPr lang="en-US" sz="1200" dirty="0"/>
-          </a:p>
-        </p:txBody>
-      </p:sp>
-      <p:sp>
-        <p:nvSpPr>
-          <p:cNvPr id="23" name="Text 21"/>
-          <p:cNvSpPr/>
-          <p:nvPr/>
-        </p:nvSpPr>
-        <p:spPr>
-          <a:xfrm>
-            <a:off x="1005840" y="3547872"/>
-            <a:ext cx="1097280" cy="365760"/>
-          </a:xfrm>
-          <a:prstGeom prst="rect">
-            <a:avLst/>
-          </a:prstGeom>
-          <a:noFill/>
-          <a:ln/>
-        </p:spPr>
-        <p:txBody>
-          <a:bodyPr wrap="square" rtlCol="0" anchor="ctr"/>
-          <a:lstStyle/>
-          <a:p>
-            <a:pPr indent="0" marL="0">
-              <a:buNone/>
-            </a:pPr>
-            <a:r>
-              <a:rPr lang="en-US" sz="1200" b="1" dirty="0">
-                <a:solidFill>
-                  <a:srgbClr val="1E293B"/>
-                </a:solidFill>
-              </a:rPr>
               <a:t>eBPF 数据</a:t>
             </a:r>
             <a:endParaRPr lang="en-US" sz="1200" dirty="0"/>
@@ -7910,13 +7777,13 @@
       </p:sp>
       <p:sp>
         <p:nvSpPr>
-          <p:cNvPr id="24" name="Text 22"/>
-          <p:cNvSpPr/>
-          <p:nvPr/>
-        </p:nvSpPr>
-        <p:spPr>
-          <a:xfrm>
-            <a:off x="2103120" y="3547872"/>
+          <p:cNvPr id="20" name="Text 18"/>
+          <p:cNvSpPr/>
+          <p:nvPr/>
+        </p:nvSpPr>
+        <p:spPr>
+          <a:xfrm>
+            <a:off x="2103120" y="2953512"/>
             <a:ext cx="3566160" cy="365760"/>
           </a:xfrm>
           <a:prstGeom prst="rect">
@@ -7946,7 +7813,7 @@
       </p:sp>
       <p:sp>
         <p:nvSpPr>
-          <p:cNvPr id="25" name="Shape 23"/>
+          <p:cNvPr id="21" name="Shape 19"/>
           <p:cNvSpPr/>
           <p:nvPr/>
         </p:nvSpPr>
@@ -7968,7 +7835,7 @@
       </p:sp>
       <p:sp>
         <p:nvSpPr>
-          <p:cNvPr id="26" name="Text 24"/>
+          <p:cNvPr id="22" name="Text 20"/>
           <p:cNvSpPr/>
           <p:nvPr/>
         </p:nvSpPr>
@@ -8004,7 +7871,7 @@
       </p:sp>
       <p:sp>
         <p:nvSpPr>
-          <p:cNvPr id="27" name="Shape 25"/>
+          <p:cNvPr id="23" name="Shape 21"/>
           <p:cNvSpPr/>
           <p:nvPr/>
         </p:nvSpPr>
@@ -8026,7 +7893,7 @@
       </p:sp>
       <p:sp>
         <p:nvSpPr>
-          <p:cNvPr id="28" name="Text 26"/>
+          <p:cNvPr id="24" name="Text 22"/>
           <p:cNvSpPr/>
           <p:nvPr/>
         </p:nvSpPr>
@@ -8062,7 +7929,7 @@
       </p:sp>
       <p:sp>
         <p:nvSpPr>
-          <p:cNvPr id="29" name="Text 27"/>
+          <p:cNvPr id="25" name="Text 23"/>
           <p:cNvSpPr/>
           <p:nvPr/>
         </p:nvSpPr>
@@ -8101,7 +7968,7 @@
       </p:sp>
       <p:sp>
         <p:nvSpPr>
-          <p:cNvPr id="30" name="Text 28"/>
+          <p:cNvPr id="26" name="Text 24"/>
           <p:cNvSpPr/>
           <p:nvPr/>
         </p:nvSpPr>
@@ -8137,7 +8004,7 @@
       </p:sp>
       <p:sp>
         <p:nvSpPr>
-          <p:cNvPr id="31" name="Shape 29"/>
+          <p:cNvPr id="27" name="Shape 25"/>
           <p:cNvSpPr/>
           <p:nvPr/>
         </p:nvSpPr>
@@ -8159,7 +8026,7 @@
       </p:sp>
       <p:sp>
         <p:nvSpPr>
-          <p:cNvPr id="32" name="Text 30"/>
+          <p:cNvPr id="28" name="Text 26"/>
           <p:cNvSpPr/>
           <p:nvPr/>
         </p:nvSpPr>
@@ -8195,7 +8062,7 @@
       </p:sp>
       <p:sp>
         <p:nvSpPr>
-          <p:cNvPr id="33" name="Text 31"/>
+          <p:cNvPr id="29" name="Text 27"/>
           <p:cNvSpPr/>
           <p:nvPr/>
         </p:nvSpPr>
@@ -8234,7 +8101,7 @@
       </p:sp>
       <p:sp>
         <p:nvSpPr>
-          <p:cNvPr id="34" name="Text 32"/>
+          <p:cNvPr id="30" name="Text 28"/>
           <p:cNvSpPr/>
           <p:nvPr/>
         </p:nvSpPr>
@@ -8270,7 +8137,7 @@
       </p:sp>
       <p:sp>
         <p:nvSpPr>
-          <p:cNvPr id="35" name="Text 33"/>
+          <p:cNvPr id="31" name="Text 29"/>
           <p:cNvSpPr/>
           <p:nvPr/>
         </p:nvSpPr>
@@ -8306,7 +8173,7 @@
       </p:sp>
       <p:sp>
         <p:nvSpPr>
-          <p:cNvPr id="36" name="Shape 34"/>
+          <p:cNvPr id="32" name="Shape 30"/>
           <p:cNvSpPr/>
           <p:nvPr/>
         </p:nvSpPr>
@@ -8335,7 +8202,7 @@
       </p:sp>
       <p:sp>
         <p:nvSpPr>
-          <p:cNvPr id="37" name="Text 35"/>
+          <p:cNvPr id="33" name="Text 31"/>
           <p:cNvSpPr/>
           <p:nvPr/>
         </p:nvSpPr>
@@ -8371,7 +8238,7 @@
       </p:sp>
       <p:sp>
         <p:nvSpPr>
-          <p:cNvPr id="38" name="Text 36"/>
+          <p:cNvPr id="34" name="Text 32"/>
           <p:cNvSpPr/>
           <p:nvPr/>
         </p:nvSpPr>
@@ -8407,7 +8274,7 @@
       </p:sp>
       <p:sp>
         <p:nvSpPr>
-          <p:cNvPr id="39" name="Text 37"/>
+          <p:cNvPr id="35" name="Text 33"/>
           <p:cNvSpPr/>
           <p:nvPr/>
         </p:nvSpPr>
@@ -8443,7 +8310,7 @@
       </p:sp>
       <p:sp>
         <p:nvSpPr>
-          <p:cNvPr id="40" name="Text 38"/>
+          <p:cNvPr id="36" name="Text 34"/>
           <p:cNvSpPr/>
           <p:nvPr/>
         </p:nvSpPr>
@@ -8479,7 +8346,7 @@
       </p:sp>
       <p:sp>
         <p:nvSpPr>
-          <p:cNvPr id="41" name="Shape 39"/>
+          <p:cNvPr id="37" name="Shape 35"/>
           <p:cNvSpPr/>
           <p:nvPr/>
         </p:nvSpPr>
@@ -8501,7 +8368,7 @@
       </p:sp>
       <p:sp>
         <p:nvSpPr>
-          <p:cNvPr id="42" name="Text 40"/>
+          <p:cNvPr id="38" name="Text 36"/>
           <p:cNvSpPr/>
           <p:nvPr/>
         </p:nvSpPr>

</xml_diff>

<commit_message>
Remove eBPF 8T/16T from slide 2 — already reported last meeting
</commit_message>
<xml_diff>
--- a/presentation/native_hook_progress_2026-06-11.pptx
+++ b/presentation/native_hook_progress_2026-06-11.pptx
@@ -7686,139 +7686,6 @@
         </p:nvSpPr>
         <p:spPr>
           <a:xfrm>
-            <a:off x="502920" y="2971800"/>
-            <a:ext cx="365760" cy="365760"/>
-          </a:xfrm>
-          <a:prstGeom prst="rect">
-            <a:avLst>
-              <a:gd name="adj" fmla="val 50000"/>
-            </a:avLst>
-          </a:prstGeom>
-          <a:solidFill>
-            <a:srgbClr val="2563EB"/>
-          </a:solidFill>
-          <a:ln/>
-        </p:spPr>
-      </p:sp>
-      <p:sp>
-        <p:nvSpPr>
-          <p:cNvPr id="18" name="Text 16"/>
-          <p:cNvSpPr/>
-          <p:nvPr/>
-        </p:nvSpPr>
-        <p:spPr>
-          <a:xfrm>
-            <a:off x="502920" y="2971800"/>
-            <a:ext cx="365760" cy="365760"/>
-          </a:xfrm>
-          <a:prstGeom prst="rect">
-            <a:avLst/>
-          </a:prstGeom>
-          <a:noFill/>
-          <a:ln/>
-        </p:spPr>
-        <p:txBody>
-          <a:bodyPr wrap="square" rtlCol="0" anchor="ctr"/>
-          <a:lstStyle/>
-          <a:p>
-            <a:pPr algn="ctr" indent="0" marL="0">
-              <a:buNone/>
-            </a:pPr>
-            <a:r>
-              <a:rPr lang="en-US" sz="1200" b="1" dirty="0">
-                <a:solidFill>
-                  <a:srgbClr val="FFFFFF"/>
-                </a:solidFill>
-                <a:latin typeface="Consolas" pitchFamily="34" charset="0"/>
-                <a:ea typeface="Consolas" pitchFamily="34" charset="-122"/>
-                <a:cs typeface="Consolas" pitchFamily="34" charset="-120"/>
-              </a:rPr>
-              <a:t>3</a:t>
-            </a:r>
-            <a:endParaRPr lang="en-US" sz="1200" dirty="0"/>
-          </a:p>
-        </p:txBody>
-      </p:sp>
-      <p:sp>
-        <p:nvSpPr>
-          <p:cNvPr id="19" name="Text 17"/>
-          <p:cNvSpPr/>
-          <p:nvPr/>
-        </p:nvSpPr>
-        <p:spPr>
-          <a:xfrm>
-            <a:off x="1005840" y="2953512"/>
-            <a:ext cx="1097280" cy="365760"/>
-          </a:xfrm>
-          <a:prstGeom prst="rect">
-            <a:avLst/>
-          </a:prstGeom>
-          <a:noFill/>
-          <a:ln/>
-        </p:spPr>
-        <p:txBody>
-          <a:bodyPr wrap="square" rtlCol="0" anchor="ctr"/>
-          <a:lstStyle/>
-          <a:p>
-            <a:pPr indent="0" marL="0">
-              <a:buNone/>
-            </a:pPr>
-            <a:r>
-              <a:rPr lang="en-US" sz="1200" b="1" dirty="0">
-                <a:solidFill>
-                  <a:srgbClr val="1E293B"/>
-                </a:solidFill>
-              </a:rPr>
-              <a:t>eBPF 数据</a:t>
-            </a:r>
-            <a:endParaRPr lang="en-US" sz="1200" dirty="0"/>
-          </a:p>
-        </p:txBody>
-      </p:sp>
-      <p:sp>
-        <p:nvSpPr>
-          <p:cNvPr id="20" name="Text 18"/>
-          <p:cNvSpPr/>
-          <p:nvPr/>
-        </p:nvSpPr>
-        <p:spPr>
-          <a:xfrm>
-            <a:off x="2103120" y="2953512"/>
-            <a:ext cx="3566160" cy="365760"/>
-          </a:xfrm>
-          <a:prstGeom prst="rect">
-            <a:avLst/>
-          </a:prstGeom>
-          <a:noFill/>
-          <a:ln/>
-        </p:spPr>
-        <p:txBody>
-          <a:bodyPr wrap="square" rtlCol="0" anchor="ctr"/>
-          <a:lstStyle/>
-          <a:p>
-            <a:pPr indent="0" marL="0">
-              <a:buNone/>
-            </a:pPr>
-            <a:r>
-              <a:rPr lang="en-US" sz="1200" dirty="0">
-                <a:solidFill>
-                  <a:srgbClr val="334155"/>
-                </a:solidFill>
-              </a:rPr>
-              <a:t>补 8T/16T，高线程反超 2.5~3x</a:t>
-            </a:r>
-            <a:endParaRPr lang="en-US" sz="1200" dirty="0"/>
-          </a:p>
-        </p:txBody>
-      </p:sp>
-      <p:sp>
-        <p:nvSpPr>
-          <p:cNvPr id="21" name="Shape 19"/>
-          <p:cNvSpPr/>
-          <p:nvPr/>
-        </p:nvSpPr>
-        <p:spPr>
-          <a:xfrm>
             <a:off x="6217920" y="1234440"/>
             <a:ext cx="5486400" cy="411480"/>
           </a:xfrm>
@@ -7835,7 +7702,7 @@
       </p:sp>
       <p:sp>
         <p:nvSpPr>
-          <p:cNvPr id="22" name="Text 20"/>
+          <p:cNvPr id="18" name="Text 16"/>
           <p:cNvSpPr/>
           <p:nvPr/>
         </p:nvSpPr>
@@ -7871,7 +7738,7 @@
       </p:sp>
       <p:sp>
         <p:nvSpPr>
-          <p:cNvPr id="23" name="Shape 21"/>
+          <p:cNvPr id="19" name="Shape 17"/>
           <p:cNvSpPr/>
           <p:nvPr/>
         </p:nvSpPr>
@@ -7893,7 +7760,7 @@
       </p:sp>
       <p:sp>
         <p:nvSpPr>
-          <p:cNvPr id="24" name="Text 22"/>
+          <p:cNvPr id="20" name="Text 18"/>
           <p:cNvSpPr/>
           <p:nvPr/>
         </p:nvSpPr>
@@ -7929,7 +7796,7 @@
       </p:sp>
       <p:sp>
         <p:nvSpPr>
-          <p:cNvPr id="25" name="Text 23"/>
+          <p:cNvPr id="21" name="Text 19"/>
           <p:cNvSpPr/>
           <p:nvPr/>
         </p:nvSpPr>
@@ -7968,7 +7835,7 @@
       </p:sp>
       <p:sp>
         <p:nvSpPr>
-          <p:cNvPr id="26" name="Text 24"/>
+          <p:cNvPr id="22" name="Text 20"/>
           <p:cNvSpPr/>
           <p:nvPr/>
         </p:nvSpPr>
@@ -8004,7 +7871,7 @@
       </p:sp>
       <p:sp>
         <p:nvSpPr>
-          <p:cNvPr id="27" name="Shape 25"/>
+          <p:cNvPr id="23" name="Shape 21"/>
           <p:cNvSpPr/>
           <p:nvPr/>
         </p:nvSpPr>
@@ -8026,7 +7893,7 @@
       </p:sp>
       <p:sp>
         <p:nvSpPr>
-          <p:cNvPr id="28" name="Text 26"/>
+          <p:cNvPr id="24" name="Text 22"/>
           <p:cNvSpPr/>
           <p:nvPr/>
         </p:nvSpPr>
@@ -8062,7 +7929,7 @@
       </p:sp>
       <p:sp>
         <p:nvSpPr>
-          <p:cNvPr id="29" name="Text 27"/>
+          <p:cNvPr id="25" name="Text 23"/>
           <p:cNvSpPr/>
           <p:nvPr/>
         </p:nvSpPr>
@@ -8101,7 +7968,7 @@
       </p:sp>
       <p:sp>
         <p:nvSpPr>
-          <p:cNvPr id="30" name="Text 28"/>
+          <p:cNvPr id="26" name="Text 24"/>
           <p:cNvSpPr/>
           <p:nvPr/>
         </p:nvSpPr>
@@ -8137,7 +8004,7 @@
       </p:sp>
       <p:sp>
         <p:nvSpPr>
-          <p:cNvPr id="31" name="Text 29"/>
+          <p:cNvPr id="27" name="Text 25"/>
           <p:cNvSpPr/>
           <p:nvPr/>
         </p:nvSpPr>
@@ -8173,7 +8040,7 @@
       </p:sp>
       <p:sp>
         <p:nvSpPr>
-          <p:cNvPr id="32" name="Shape 30"/>
+          <p:cNvPr id="28" name="Shape 26"/>
           <p:cNvSpPr/>
           <p:nvPr/>
         </p:nvSpPr>
@@ -8202,7 +8069,7 @@
       </p:sp>
       <p:sp>
         <p:nvSpPr>
-          <p:cNvPr id="33" name="Text 31"/>
+          <p:cNvPr id="29" name="Text 27"/>
           <p:cNvSpPr/>
           <p:nvPr/>
         </p:nvSpPr>
@@ -8238,7 +8105,7 @@
       </p:sp>
       <p:sp>
         <p:nvSpPr>
-          <p:cNvPr id="34" name="Text 32"/>
+          <p:cNvPr id="30" name="Text 28"/>
           <p:cNvSpPr/>
           <p:nvPr/>
         </p:nvSpPr>
@@ -8274,7 +8141,7 @@
       </p:sp>
       <p:sp>
         <p:nvSpPr>
-          <p:cNvPr id="35" name="Text 33"/>
+          <p:cNvPr id="31" name="Text 29"/>
           <p:cNvSpPr/>
           <p:nvPr/>
         </p:nvSpPr>
@@ -8310,7 +8177,7 @@
       </p:sp>
       <p:sp>
         <p:nvSpPr>
-          <p:cNvPr id="36" name="Text 34"/>
+          <p:cNvPr id="32" name="Text 30"/>
           <p:cNvSpPr/>
           <p:nvPr/>
         </p:nvSpPr>
@@ -8346,7 +8213,7 @@
       </p:sp>
       <p:sp>
         <p:nvSpPr>
-          <p:cNvPr id="37" name="Shape 35"/>
+          <p:cNvPr id="33" name="Shape 31"/>
           <p:cNvSpPr/>
           <p:nvPr/>
         </p:nvSpPr>
@@ -8368,7 +8235,7 @@
       </p:sp>
       <p:sp>
         <p:nvSpPr>
-          <p:cNvPr id="38" name="Text 36"/>
+          <p:cNvPr id="34" name="Text 32"/>
           <p:cNvSpPr/>
           <p:nvPr/>
         </p:nvSpPr>

</xml_diff>

<commit_message>
Replace slide 9 table with before/after flow diagram
Co-Authored-By: Claude Opus 4.8 <noreply@anthropic.com>
</commit_message>
<xml_diff>
--- a/presentation/native_hook_progress_2026-06-11.pptx
+++ b/presentation/native_hook_progress_2026-06-11.pptx
@@ -15516,7 +15516,7 @@
                   <a:srgbClr val="64748B"/>
                 </a:solidFill>
               </a:rPr>
-              <a:t>已在 OH 仓库源码上用 SHARDED_RING: 标注</a:t>
+              <a:t>三个改动点 · 集中在 StackWriter 层 · 不影响上层 hook 函数</a:t>
             </a:r>
             <a:endParaRPr lang="en-US" sz="1300" dirty="0"/>
           </a:p>
@@ -15542,1060 +15542,16 @@
           <a:ln/>
         </p:spPr>
       </p:sp>
-      <p:graphicFrame>
-        <p:nvGraphicFramePr>
-          <p:cNvPr id="10" name="Table 0"/>
-          <p:cNvGraphicFramePr>
-            <a:graphicFrameLocks noGrp="1"/>
-          </p:cNvGraphicFramePr>
-          <p:nvPr>
-            <p:extLst>
-              <p:ext uri="{D42A27DB-BD31-4B8C-83A1-F6EECF244321}">
-                <p14:modId xmlns:p14="http://schemas.microsoft.com/office/powerpoint/2010/main" val="1579011935"/>
-              </p:ext>
-            </p:extLst>
-          </p:nvPr>
-        </p:nvGraphicFramePr>
-        <p:xfrm>
-          <a:off x="502920" y="1371600"/>
-          <a:ext cx="11247120" cy="914400"/>
-        </p:xfrm>
-        <a:graphic>
-          <a:graphicData uri="http://schemas.openxmlformats.org/drawingml/2006/table">
-            <a:tbl>
-              <a:tblPr/>
-              <a:tblGrid>
-                <a:gridCol w="3749040"/>
-                <a:gridCol w="3749040"/>
-                <a:gridCol w="3749040"/>
-              </a:tblGrid>
-              <a:tr h="347472">
-                <a:tc>
-                  <a:txBody>
-                    <a:bodyPr/>
-                    <a:lstStyle/>
-                    <a:p>
-                      <a:pPr algn="ctr" indent="0" marL="0">
-                        <a:buNone/>
-                      </a:pPr>
-                      <a:r>
-                        <a:rPr lang="en-US" sz="1200" b="1" dirty="0">
-                          <a:solidFill>
-                            <a:srgbClr val="2563EB"/>
-                          </a:solidFill>
-                          <a:latin typeface="Arial" pitchFamily="34" charset="0"/>
-                          <a:ea typeface="Arial" pitchFamily="34" charset="-122"/>
-                          <a:cs typeface="Arial" pitchFamily="34" charset="-120"/>
-                        </a:rPr>
-                        <a:t>位置</a:t>
-                      </a:r>
-                      <a:endParaRPr lang="en-US" sz="1200" dirty="0">
-                        <a:latin typeface="Arial" charset="0"/>
-                        <a:ea typeface="Arial" charset="0"/>
-                        <a:cs typeface="Arial" charset="0"/>
-                      </a:endParaRPr>
-                    </a:p>
-                  </a:txBody>
-                  <a:tcPr marL="91440" marR="91440" marT="45720" marB="45720" anchor="ctr">
-                    <a:lnL w="6350" cap="flat" cmpd="sng" algn="ctr">
-                      <a:solidFill>
-                        <a:srgbClr val="E2E8F0"/>
-                      </a:solidFill>
-                      <a:prstDash val="solid"/>
-                      <a:round/>
-                      <a:headEnd type="none" w="med" len="med"/>
-                      <a:tailEnd type="none" w="med" len="med"/>
-                    </a:lnL>
-                    <a:lnR w="6350" cap="flat" cmpd="sng" algn="ctr">
-                      <a:solidFill>
-                        <a:srgbClr val="E2E8F0"/>
-                      </a:solidFill>
-                      <a:prstDash val="solid"/>
-                      <a:round/>
-                      <a:headEnd type="none" w="med" len="med"/>
-                      <a:tailEnd type="none" w="med" len="med"/>
-                    </a:lnR>
-                    <a:lnT w="6350" cap="flat" cmpd="sng" algn="ctr">
-                      <a:solidFill>
-                        <a:srgbClr val="E2E8F0"/>
-                      </a:solidFill>
-                      <a:prstDash val="solid"/>
-                      <a:round/>
-                      <a:headEnd type="none" w="med" len="med"/>
-                      <a:tailEnd type="none" w="med" len="med"/>
-                    </a:lnT>
-                    <a:lnB w="6350" cap="flat" cmpd="sng" algn="ctr">
-                      <a:solidFill>
-                        <a:srgbClr val="E2E8F0"/>
-                      </a:solidFill>
-                      <a:prstDash val="solid"/>
-                      <a:round/>
-                      <a:headEnd type="none" w="med" len="med"/>
-                      <a:tailEnd type="none" w="med" len="med"/>
-                    </a:lnB>
-                    <a:solidFill>
-                      <a:srgbClr val="EFF6FF"/>
-                    </a:solidFill>
-                  </a:tcPr>
-                </a:tc>
-                <a:tc>
-                  <a:txBody>
-                    <a:bodyPr/>
-                    <a:lstStyle/>
-                    <a:p>
-                      <a:pPr algn="ctr" indent="0" marL="0">
-                        <a:buNone/>
-                      </a:pPr>
-                      <a:r>
-                        <a:rPr lang="en-US" sz="1200" b="1" dirty="0">
-                          <a:solidFill>
-                            <a:srgbClr val="2563EB"/>
-                          </a:solidFill>
-                          <a:latin typeface="Arial" pitchFamily="34" charset="0"/>
-                          <a:ea typeface="Arial" pitchFamily="34" charset="-122"/>
-                          <a:cs typeface="Arial" pitchFamily="34" charset="-120"/>
-                        </a:rPr>
-                        <a:t>当前实现</a:t>
-                      </a:r>
-                      <a:endParaRPr lang="en-US" sz="1200" dirty="0">
-                        <a:latin typeface="Arial" charset="0"/>
-                        <a:ea typeface="Arial" charset="0"/>
-                        <a:cs typeface="Arial" charset="0"/>
-                      </a:endParaRPr>
-                    </a:p>
-                  </a:txBody>
-                  <a:tcPr marL="91440" marR="91440" marT="45720" marB="45720" anchor="ctr">
-                    <a:lnL w="6350" cap="flat" cmpd="sng" algn="ctr">
-                      <a:solidFill>
-                        <a:srgbClr val="E2E8F0"/>
-                      </a:solidFill>
-                      <a:prstDash val="solid"/>
-                      <a:round/>
-                      <a:headEnd type="none" w="med" len="med"/>
-                      <a:tailEnd type="none" w="med" len="med"/>
-                    </a:lnL>
-                    <a:lnR w="6350" cap="flat" cmpd="sng" algn="ctr">
-                      <a:solidFill>
-                        <a:srgbClr val="E2E8F0"/>
-                      </a:solidFill>
-                      <a:prstDash val="solid"/>
-                      <a:round/>
-                      <a:headEnd type="none" w="med" len="med"/>
-                      <a:tailEnd type="none" w="med" len="med"/>
-                    </a:lnR>
-                    <a:lnT w="6350" cap="flat" cmpd="sng" algn="ctr">
-                      <a:solidFill>
-                        <a:srgbClr val="E2E8F0"/>
-                      </a:solidFill>
-                      <a:prstDash val="solid"/>
-                      <a:round/>
-                      <a:headEnd type="none" w="med" len="med"/>
-                      <a:tailEnd type="none" w="med" len="med"/>
-                    </a:lnT>
-                    <a:lnB w="6350" cap="flat" cmpd="sng" algn="ctr">
-                      <a:solidFill>
-                        <a:srgbClr val="E2E8F0"/>
-                      </a:solidFill>
-                      <a:prstDash val="solid"/>
-                      <a:round/>
-                      <a:headEnd type="none" w="med" len="med"/>
-                      <a:tailEnd type="none" w="med" len="med"/>
-                    </a:lnB>
-                    <a:solidFill>
-                      <a:srgbClr val="EFF6FF"/>
-                    </a:solidFill>
-                  </a:tcPr>
-                </a:tc>
-                <a:tc>
-                  <a:txBody>
-                    <a:bodyPr/>
-                    <a:lstStyle/>
-                    <a:p>
-                      <a:pPr algn="ctr" indent="0" marL="0">
-                        <a:buNone/>
-                      </a:pPr>
-                      <a:r>
-                        <a:rPr lang="en-US" sz="1200" b="1" dirty="0">
-                          <a:solidFill>
-                            <a:srgbClr val="2563EB"/>
-                          </a:solidFill>
-                          <a:latin typeface="Arial" pitchFamily="34" charset="0"/>
-                          <a:ea typeface="Arial" pitchFamily="34" charset="-122"/>
-                          <a:cs typeface="Arial" pitchFamily="34" charset="-120"/>
-                        </a:rPr>
-                        <a:t>改为</a:t>
-                      </a:r>
-                      <a:endParaRPr lang="en-US" sz="1200" dirty="0">
-                        <a:latin typeface="Arial" charset="0"/>
-                        <a:ea typeface="Arial" charset="0"/>
-                        <a:cs typeface="Arial" charset="0"/>
-                      </a:endParaRPr>
-                    </a:p>
-                  </a:txBody>
-                  <a:tcPr marL="91440" marR="91440" marT="45720" marB="45720" anchor="ctr">
-                    <a:lnL w="6350" cap="flat" cmpd="sng" algn="ctr">
-                      <a:solidFill>
-                        <a:srgbClr val="E2E8F0"/>
-                      </a:solidFill>
-                      <a:prstDash val="solid"/>
-                      <a:round/>
-                      <a:headEnd type="none" w="med" len="med"/>
-                      <a:tailEnd type="none" w="med" len="med"/>
-                    </a:lnL>
-                    <a:lnR w="6350" cap="flat" cmpd="sng" algn="ctr">
-                      <a:solidFill>
-                        <a:srgbClr val="E2E8F0"/>
-                      </a:solidFill>
-                      <a:prstDash val="solid"/>
-                      <a:round/>
-                      <a:headEnd type="none" w="med" len="med"/>
-                      <a:tailEnd type="none" w="med" len="med"/>
-                    </a:lnR>
-                    <a:lnT w="6350" cap="flat" cmpd="sng" algn="ctr">
-                      <a:solidFill>
-                        <a:srgbClr val="E2E8F0"/>
-                      </a:solidFill>
-                      <a:prstDash val="solid"/>
-                      <a:round/>
-                      <a:headEnd type="none" w="med" len="med"/>
-                      <a:tailEnd type="none" w="med" len="med"/>
-                    </a:lnT>
-                    <a:lnB w="6350" cap="flat" cmpd="sng" algn="ctr">
-                      <a:solidFill>
-                        <a:srgbClr val="E2E8F0"/>
-                      </a:solidFill>
-                      <a:prstDash val="solid"/>
-                      <a:round/>
-                      <a:headEnd type="none" w="med" len="med"/>
-                      <a:tailEnd type="none" w="med" len="med"/>
-                    </a:lnB>
-                    <a:solidFill>
-                      <a:srgbClr val="EFF6FF"/>
-                    </a:solidFill>
-                  </a:tcPr>
-                </a:tc>
-              </a:tr>
-              <a:tr h="347472">
-                <a:tc>
-                  <a:txBody>
-                    <a:bodyPr/>
-                    <a:lstStyle/>
-                    <a:p>
-                      <a:pPr algn="l" indent="0" marL="0">
-                        <a:buNone/>
-                      </a:pPr>
-                      <a:r>
-                        <a:rPr lang="en-US" sz="1200" dirty="0">
-                          <a:solidFill>
-                            <a:srgbClr val="334155"/>
-                          </a:solidFill>
-                          <a:latin typeface="Consolas" pitchFamily="34" charset="0"/>
-                          <a:ea typeface="Consolas" pitchFamily="34" charset="-122"/>
-                          <a:cs typeface="Consolas" pitchFamily="34" charset="-120"/>
-                        </a:rPr>
-                        <a:t>hook_client.cpp:628</a:t>
-                      </a:r>
-                      <a:endParaRPr lang="en-US" sz="1200" dirty="0">
-                        <a:latin typeface="Consolas" charset="0"/>
-                        <a:ea typeface="Consolas" charset="0"/>
-                        <a:cs typeface="Consolas" charset="0"/>
-                      </a:endParaRPr>
-                    </a:p>
-                    <a:p>
-                      <a:pPr algn="l" indent="0" marL="0">
-                        <a:buNone/>
-                      </a:pPr>
-                      <a:r>
-                        <a:rPr lang="en-US" sz="1200" dirty="0">
-                          <a:solidFill>
-                            <a:srgbClr val="334155"/>
-                          </a:solidFill>
-                          <a:latin typeface="Consolas" pitchFamily="34" charset="0"/>
-                          <a:ea typeface="Consolas" pitchFamily="34" charset="-122"/>
-                          <a:cs typeface="Consolas" pitchFamily="34" charset="-120"/>
-                        </a:rPr>
-                        <a:t>SendStackWithPayload</a:t>
-                      </a:r>
-                      <a:endParaRPr lang="en-US" sz="1200" dirty="0">
-                        <a:latin typeface="Consolas" charset="0"/>
-                        <a:ea typeface="Consolas" charset="0"/>
-                        <a:cs typeface="Consolas" charset="0"/>
-                      </a:endParaRPr>
-                    </a:p>
-                  </a:txBody>
-                  <a:tcPr marL="91440" marR="91440" marT="45720" marB="45720" anchor="ctr">
-                    <a:lnL w="6350" cap="flat" cmpd="sng" algn="ctr">
-                      <a:solidFill>
-                        <a:srgbClr val="E2E8F0"/>
-                      </a:solidFill>
-                      <a:prstDash val="solid"/>
-                      <a:round/>
-                      <a:headEnd type="none" w="med" len="med"/>
-                      <a:tailEnd type="none" w="med" len="med"/>
-                    </a:lnL>
-                    <a:lnR w="6350" cap="flat" cmpd="sng" algn="ctr">
-                      <a:solidFill>
-                        <a:srgbClr val="E2E8F0"/>
-                      </a:solidFill>
-                      <a:prstDash val="solid"/>
-                      <a:round/>
-                      <a:headEnd type="none" w="med" len="med"/>
-                      <a:tailEnd type="none" w="med" len="med"/>
-                    </a:lnR>
-                    <a:lnT w="6350" cap="flat" cmpd="sng" algn="ctr">
-                      <a:solidFill>
-                        <a:srgbClr val="E2E8F0"/>
-                      </a:solidFill>
-                      <a:prstDash val="solid"/>
-                      <a:round/>
-                      <a:headEnd type="none" w="med" len="med"/>
-                      <a:tailEnd type="none" w="med" len="med"/>
-                    </a:lnT>
-                    <a:lnB w="6350" cap="flat" cmpd="sng" algn="ctr">
-                      <a:solidFill>
-                        <a:srgbClr val="E2E8F0"/>
-                      </a:solidFill>
-                      <a:prstDash val="solid"/>
-                      <a:round/>
-                      <a:headEnd type="none" w="med" len="med"/>
-                      <a:tailEnd type="none" w="med" len="med"/>
-                    </a:lnB>
-                    <a:solidFill>
-                      <a:srgbClr val="FFFFFF"/>
-                    </a:solidFill>
-                  </a:tcPr>
-                </a:tc>
-                <a:tc>
-                  <a:txBody>
-                    <a:bodyPr/>
-                    <a:lstStyle/>
-                    <a:p>
-                      <a:pPr algn="ctr" indent="0" marL="0">
-                        <a:buNone/>
-                      </a:pPr>
-                      <a:r>
-                        <a:rPr lang="en-US" sz="1200" dirty="0">
-                          <a:solidFill>
-                            <a:srgbClr val="334155"/>
-                          </a:solidFill>
-                          <a:latin typeface="Consolas" pitchFamily="34" charset="0"/>
-                          <a:ea typeface="Consolas" pitchFamily="34" charset="-122"/>
-                          <a:cs typeface="Consolas" pitchFamily="34" charset="-120"/>
-                        </a:rPr>
-                        <a:t>addr % g_sharedMemCount</a:t>
-                      </a:r>
-                      <a:endParaRPr lang="en-US" sz="1200" dirty="0">
-                        <a:latin typeface="Consolas" charset="0"/>
-                        <a:ea typeface="Consolas" charset="0"/>
-                        <a:cs typeface="Consolas" charset="0"/>
-                      </a:endParaRPr>
-                    </a:p>
-                    <a:p>
-                      <a:pPr algn="ctr" indent="0" marL="0">
-                        <a:buNone/>
-                      </a:pPr>
-                      <a:r>
-                        <a:rPr lang="en-US" sz="1200" dirty="0">
-                          <a:solidFill>
-                            <a:srgbClr val="334155"/>
-                          </a:solidFill>
-                          <a:latin typeface="Consolas" pitchFamily="34" charset="0"/>
-                          <a:ea typeface="Consolas" pitchFamily="34" charset="-122"/>
-                          <a:cs typeface="Consolas" pitchFamily="34" charset="-120"/>
-                        </a:rPr>
-                        <a:t>(地址分片)</a:t>
-                      </a:r>
-                      <a:endParaRPr lang="en-US" sz="1200" dirty="0">
-                        <a:latin typeface="Consolas" charset="0"/>
-                        <a:ea typeface="Consolas" charset="0"/>
-                        <a:cs typeface="Consolas" charset="0"/>
-                      </a:endParaRPr>
-                    </a:p>
-                  </a:txBody>
-                  <a:tcPr marL="91440" marR="91440" marT="45720" marB="45720" anchor="ctr">
-                    <a:lnL w="6350" cap="flat" cmpd="sng" algn="ctr">
-                      <a:solidFill>
-                        <a:srgbClr val="E2E8F0"/>
-                      </a:solidFill>
-                      <a:prstDash val="solid"/>
-                      <a:round/>
-                      <a:headEnd type="none" w="med" len="med"/>
-                      <a:tailEnd type="none" w="med" len="med"/>
-                    </a:lnL>
-                    <a:lnR w="6350" cap="flat" cmpd="sng" algn="ctr">
-                      <a:solidFill>
-                        <a:srgbClr val="E2E8F0"/>
-                      </a:solidFill>
-                      <a:prstDash val="solid"/>
-                      <a:round/>
-                      <a:headEnd type="none" w="med" len="med"/>
-                      <a:tailEnd type="none" w="med" len="med"/>
-                    </a:lnR>
-                    <a:lnT w="6350" cap="flat" cmpd="sng" algn="ctr">
-                      <a:solidFill>
-                        <a:srgbClr val="E2E8F0"/>
-                      </a:solidFill>
-                      <a:prstDash val="solid"/>
-                      <a:round/>
-                      <a:headEnd type="none" w="med" len="med"/>
-                      <a:tailEnd type="none" w="med" len="med"/>
-                    </a:lnT>
-                    <a:lnB w="6350" cap="flat" cmpd="sng" algn="ctr">
-                      <a:solidFill>
-                        <a:srgbClr val="E2E8F0"/>
-                      </a:solidFill>
-                      <a:prstDash val="solid"/>
-                      <a:round/>
-                      <a:headEnd type="none" w="med" len="med"/>
-                      <a:tailEnd type="none" w="med" len="med"/>
-                    </a:lnB>
-                    <a:solidFill>
-                      <a:srgbClr val="FFFFFF"/>
-                    </a:solidFill>
-                  </a:tcPr>
-                </a:tc>
-                <a:tc>
-                  <a:txBody>
-                    <a:bodyPr/>
-                    <a:lstStyle/>
-                    <a:p>
-                      <a:pPr algn="ctr" indent="0" marL="0">
-                        <a:buNone/>
-                      </a:pPr>
-                      <a:r>
-                        <a:rPr lang="en-US" sz="1200" dirty="0">
-                          <a:solidFill>
-                            <a:srgbClr val="334155"/>
-                          </a:solidFill>
-                          <a:latin typeface="Consolas" pitchFamily="34" charset="0"/>
-                          <a:ea typeface="Consolas" pitchFamily="34" charset="-122"/>
-                          <a:cs typeface="Consolas" pitchFamily="34" charset="-120"/>
-                        </a:rPr>
-                        <a:t>tid % g_sharedMemCount</a:t>
-                      </a:r>
-                      <a:endParaRPr lang="en-US" sz="1200" dirty="0">
-                        <a:latin typeface="Consolas" charset="0"/>
-                        <a:ea typeface="Consolas" charset="0"/>
-                        <a:cs typeface="Consolas" charset="0"/>
-                      </a:endParaRPr>
-                    </a:p>
-                    <a:p>
-                      <a:pPr algn="ctr" indent="0" marL="0">
-                        <a:buNone/>
-                      </a:pPr>
-                      <a:r>
-                        <a:rPr lang="en-US" sz="1200" dirty="0">
-                          <a:solidFill>
-                            <a:srgbClr val="334155"/>
-                          </a:solidFill>
-                          <a:latin typeface="Consolas" pitchFamily="34" charset="0"/>
-                          <a:ea typeface="Consolas" pitchFamily="34" charset="-122"/>
-                          <a:cs typeface="Consolas" pitchFamily="34" charset="-120"/>
-                        </a:rPr>
-                        <a:t>(TID 分片) + thread_local 缓存</a:t>
-                      </a:r>
-                      <a:endParaRPr lang="en-US" sz="1200" dirty="0">
-                        <a:latin typeface="Consolas" charset="0"/>
-                        <a:ea typeface="Consolas" charset="0"/>
-                        <a:cs typeface="Consolas" charset="0"/>
-                      </a:endParaRPr>
-                    </a:p>
-                  </a:txBody>
-                  <a:tcPr marL="91440" marR="91440" marT="45720" marB="45720" anchor="ctr">
-                    <a:lnL w="6350" cap="flat" cmpd="sng" algn="ctr">
-                      <a:solidFill>
-                        <a:srgbClr val="E2E8F0"/>
-                      </a:solidFill>
-                      <a:prstDash val="solid"/>
-                      <a:round/>
-                      <a:headEnd type="none" w="med" len="med"/>
-                      <a:tailEnd type="none" w="med" len="med"/>
-                    </a:lnL>
-                    <a:lnR w="6350" cap="flat" cmpd="sng" algn="ctr">
-                      <a:solidFill>
-                        <a:srgbClr val="E2E8F0"/>
-                      </a:solidFill>
-                      <a:prstDash val="solid"/>
-                      <a:round/>
-                      <a:headEnd type="none" w="med" len="med"/>
-                      <a:tailEnd type="none" w="med" len="med"/>
-                    </a:lnR>
-                    <a:lnT w="6350" cap="flat" cmpd="sng" algn="ctr">
-                      <a:solidFill>
-                        <a:srgbClr val="E2E8F0"/>
-                      </a:solidFill>
-                      <a:prstDash val="solid"/>
-                      <a:round/>
-                      <a:headEnd type="none" w="med" len="med"/>
-                      <a:tailEnd type="none" w="med" len="med"/>
-                    </a:lnT>
-                    <a:lnB w="6350" cap="flat" cmpd="sng" algn="ctr">
-                      <a:solidFill>
-                        <a:srgbClr val="E2E8F0"/>
-                      </a:solidFill>
-                      <a:prstDash val="solid"/>
-                      <a:round/>
-                      <a:headEnd type="none" w="med" len="med"/>
-                      <a:tailEnd type="none" w="med" len="med"/>
-                    </a:lnB>
-                    <a:solidFill>
-                      <a:srgbClr val="FFFFFF"/>
-                    </a:solidFill>
-                  </a:tcPr>
-                </a:tc>
-              </a:tr>
-              <a:tr h="347472">
-                <a:tc>
-                  <a:txBody>
-                    <a:bodyPr/>
-                    <a:lstStyle/>
-                    <a:p>
-                      <a:pPr algn="l" indent="0" marL="0">
-                        <a:buNone/>
-                      </a:pPr>
-                      <a:r>
-                        <a:rPr lang="en-US" sz="1200" dirty="0">
-                          <a:solidFill>
-                            <a:srgbClr val="334155"/>
-                          </a:solidFill>
-                          <a:latin typeface="Consolas" pitchFamily="34" charset="0"/>
-                          <a:ea typeface="Consolas" pitchFamily="34" charset="-122"/>
-                          <a:cs typeface="Consolas" pitchFamily="34" charset="-120"/>
-                        </a:rPr>
-                        <a:t>stack_writer.cpp:89</a:t>
-                      </a:r>
-                      <a:endParaRPr lang="en-US" sz="1200" dirty="0">
-                        <a:latin typeface="Consolas" charset="0"/>
-                        <a:ea typeface="Consolas" charset="0"/>
-                        <a:cs typeface="Consolas" charset="0"/>
-                      </a:endParaRPr>
-                    </a:p>
-                    <a:p>
-                      <a:pPr algn="l" indent="0" marL="0">
-                        <a:buNone/>
-                      </a:pPr>
-                      <a:r>
-                        <a:rPr lang="en-US" sz="1200" dirty="0">
-                          <a:solidFill>
-                            <a:srgbClr val="334155"/>
-                          </a:solidFill>
-                          <a:latin typeface="Consolas" pitchFamily="34" charset="0"/>
-                          <a:ea typeface="Consolas" pitchFamily="34" charset="-122"/>
-                          <a:cs typeface="Consolas" pitchFamily="34" charset="-120"/>
-                        </a:rPr>
-                        <a:t>PutWithPayloadTimeout</a:t>
-                      </a:r>
-                      <a:endParaRPr lang="en-US" sz="1200" dirty="0">
-                        <a:latin typeface="Consolas" charset="0"/>
-                        <a:ea typeface="Consolas" charset="0"/>
-                        <a:cs typeface="Consolas" charset="0"/>
-                      </a:endParaRPr>
-                    </a:p>
-                  </a:txBody>
-                  <a:tcPr marL="91440" marR="91440" marT="45720" marB="45720" anchor="ctr">
-                    <a:lnL w="6350" cap="flat" cmpd="sng" algn="ctr">
-                      <a:solidFill>
-                        <a:srgbClr val="E2E8F0"/>
-                      </a:solidFill>
-                      <a:prstDash val="solid"/>
-                      <a:round/>
-                      <a:headEnd type="none" w="med" len="med"/>
-                      <a:tailEnd type="none" w="med" len="med"/>
-                    </a:lnL>
-                    <a:lnR w="6350" cap="flat" cmpd="sng" algn="ctr">
-                      <a:solidFill>
-                        <a:srgbClr val="E2E8F0"/>
-                      </a:solidFill>
-                      <a:prstDash val="solid"/>
-                      <a:round/>
-                      <a:headEnd type="none" w="med" len="med"/>
-                      <a:tailEnd type="none" w="med" len="med"/>
-                    </a:lnR>
-                    <a:lnT w="6350" cap="flat" cmpd="sng" algn="ctr">
-                      <a:solidFill>
-                        <a:srgbClr val="E2E8F0"/>
-                      </a:solidFill>
-                      <a:prstDash val="solid"/>
-                      <a:round/>
-                      <a:headEnd type="none" w="med" len="med"/>
-                      <a:tailEnd type="none" w="med" len="med"/>
-                    </a:lnT>
-                    <a:lnB w="6350" cap="flat" cmpd="sng" algn="ctr">
-                      <a:solidFill>
-                        <a:srgbClr val="E2E8F0"/>
-                      </a:solidFill>
-                      <a:prstDash val="solid"/>
-                      <a:round/>
-                      <a:headEnd type="none" w="med" len="med"/>
-                      <a:tailEnd type="none" w="med" len="med"/>
-                    </a:lnB>
-                    <a:solidFill>
-                      <a:srgbClr val="FFFFFF"/>
-                    </a:solidFill>
-                  </a:tcPr>
-                </a:tc>
-                <a:tc>
-                  <a:txBody>
-                    <a:bodyPr/>
-                    <a:lstStyle/>
-                    <a:p>
-                      <a:pPr algn="ctr" indent="0" marL="0">
-                        <a:buNone/>
-                      </a:pPr>
-                      <a:r>
-                        <a:rPr lang="en-US" sz="1200" dirty="0">
-                          <a:solidFill>
-                            <a:srgbClr val="334155"/>
-                          </a:solidFill>
-                          <a:latin typeface="Consolas" pitchFamily="34" charset="0"/>
-                          <a:ea typeface="Consolas" pitchFamily="34" charset="-122"/>
-                          <a:cs typeface="Consolas" pitchFamily="34" charset="-120"/>
-                        </a:rPr>
-                        <a:t>单 ring 写入</a:t>
-                      </a:r>
-                      <a:endParaRPr lang="en-US" sz="1200" dirty="0">
-                        <a:latin typeface="Consolas" charset="0"/>
-                        <a:ea typeface="Consolas" charset="0"/>
-                        <a:cs typeface="Consolas" charset="0"/>
-                      </a:endParaRPr>
-                    </a:p>
-                    <a:p>
-                      <a:pPr algn="ctr" indent="0" marL="0">
-                        <a:buNone/>
-                      </a:pPr>
-                      <a:r>
-                        <a:rPr lang="en-US" sz="1200" dirty="0">
-                          <a:solidFill>
-                            <a:srgbClr val="334155"/>
-                          </a:solidFill>
-                          <a:latin typeface="Consolas" pitchFamily="34" charset="0"/>
-                          <a:ea typeface="Consolas" pitchFamily="34" charset="-122"/>
-                          <a:cs typeface="Consolas" pitchFamily="34" charset="-120"/>
-                        </a:rPr>
-                        <a:t>内部 mutex</a:t>
-                      </a:r>
-                      <a:endParaRPr lang="en-US" sz="1200" dirty="0">
-                        <a:latin typeface="Consolas" charset="0"/>
-                        <a:ea typeface="Consolas" charset="0"/>
-                        <a:cs typeface="Consolas" charset="0"/>
-                      </a:endParaRPr>
-                    </a:p>
-                  </a:txBody>
-                  <a:tcPr marL="91440" marR="91440" marT="45720" marB="45720" anchor="ctr">
-                    <a:lnL w="6350" cap="flat" cmpd="sng" algn="ctr">
-                      <a:solidFill>
-                        <a:srgbClr val="E2E8F0"/>
-                      </a:solidFill>
-                      <a:prstDash val="solid"/>
-                      <a:round/>
-                      <a:headEnd type="none" w="med" len="med"/>
-                      <a:tailEnd type="none" w="med" len="med"/>
-                    </a:lnL>
-                    <a:lnR w="6350" cap="flat" cmpd="sng" algn="ctr">
-                      <a:solidFill>
-                        <a:srgbClr val="E2E8F0"/>
-                      </a:solidFill>
-                      <a:prstDash val="solid"/>
-                      <a:round/>
-                      <a:headEnd type="none" w="med" len="med"/>
-                      <a:tailEnd type="none" w="med" len="med"/>
-                    </a:lnR>
-                    <a:lnT w="6350" cap="flat" cmpd="sng" algn="ctr">
-                      <a:solidFill>
-                        <a:srgbClr val="E2E8F0"/>
-                      </a:solidFill>
-                      <a:prstDash val="solid"/>
-                      <a:round/>
-                      <a:headEnd type="none" w="med" len="med"/>
-                      <a:tailEnd type="none" w="med" len="med"/>
-                    </a:lnT>
-                    <a:lnB w="6350" cap="flat" cmpd="sng" algn="ctr">
-                      <a:solidFill>
-                        <a:srgbClr val="E2E8F0"/>
-                      </a:solidFill>
-                      <a:prstDash val="solid"/>
-                      <a:round/>
-                      <a:headEnd type="none" w="med" len="med"/>
-                      <a:tailEnd type="none" w="med" len="med"/>
-                    </a:lnB>
-                    <a:solidFill>
-                      <a:srgbClr val="FFFFFF"/>
-                    </a:solidFill>
-                  </a:tcPr>
-                </a:tc>
-                <a:tc>
-                  <a:txBody>
-                    <a:bodyPr/>
-                    <a:lstStyle/>
-                    <a:p>
-                      <a:pPr algn="ctr" indent="0" marL="0">
-                        <a:buNone/>
-                      </a:pPr>
-                      <a:r>
-                        <a:rPr lang="en-US" sz="1200" dirty="0">
-                          <a:solidFill>
-                            <a:srgbClr val="334155"/>
-                          </a:solidFill>
-                          <a:latin typeface="Consolas" pitchFamily="34" charset="0"/>
-                          <a:ea typeface="Consolas" pitchFamily="34" charset="-122"/>
-                          <a:cs typeface="Consolas" pitchFamily="34" charset="-120"/>
-                        </a:rPr>
-                        <a:t>新增 shard_idx 参数</a:t>
-                      </a:r>
-                      <a:endParaRPr lang="en-US" sz="1200" dirty="0">
-                        <a:latin typeface="Consolas" charset="0"/>
-                        <a:ea typeface="Consolas" charset="0"/>
-                        <a:cs typeface="Consolas" charset="0"/>
-                      </a:endParaRPr>
-                    </a:p>
-                    <a:p>
-                      <a:pPr algn="ctr" indent="0" marL="0">
-                        <a:buNone/>
-                      </a:pPr>
-                      <a:r>
-                        <a:rPr lang="en-US" sz="1200" dirty="0">
-                          <a:solidFill>
-                            <a:srgbClr val="334155"/>
-                          </a:solidFill>
-                          <a:latin typeface="Consolas" pitchFamily="34" charset="0"/>
-                          <a:ea typeface="Consolas" pitchFamily="34" charset="-122"/>
-                          <a:cs typeface="Consolas" pitchFamily="34" charset="-120"/>
-                        </a:rPr>
-                        <a:t>ShareMemoryBlock 按 shard 无锁写</a:t>
-                      </a:r>
-                      <a:endParaRPr lang="en-US" sz="1200" dirty="0">
-                        <a:latin typeface="Consolas" charset="0"/>
-                        <a:ea typeface="Consolas" charset="0"/>
-                        <a:cs typeface="Consolas" charset="0"/>
-                      </a:endParaRPr>
-                    </a:p>
-                  </a:txBody>
-                  <a:tcPr marL="91440" marR="91440" marT="45720" marB="45720" anchor="ctr">
-                    <a:lnL w="6350" cap="flat" cmpd="sng" algn="ctr">
-                      <a:solidFill>
-                        <a:srgbClr val="E2E8F0"/>
-                      </a:solidFill>
-                      <a:prstDash val="solid"/>
-                      <a:round/>
-                      <a:headEnd type="none" w="med" len="med"/>
-                      <a:tailEnd type="none" w="med" len="med"/>
-                    </a:lnL>
-                    <a:lnR w="6350" cap="flat" cmpd="sng" algn="ctr">
-                      <a:solidFill>
-                        <a:srgbClr val="E2E8F0"/>
-                      </a:solidFill>
-                      <a:prstDash val="solid"/>
-                      <a:round/>
-                      <a:headEnd type="none" w="med" len="med"/>
-                      <a:tailEnd type="none" w="med" len="med"/>
-                    </a:lnR>
-                    <a:lnT w="6350" cap="flat" cmpd="sng" algn="ctr">
-                      <a:solidFill>
-                        <a:srgbClr val="E2E8F0"/>
-                      </a:solidFill>
-                      <a:prstDash val="solid"/>
-                      <a:round/>
-                      <a:headEnd type="none" w="med" len="med"/>
-                      <a:tailEnd type="none" w="med" len="med"/>
-                    </a:lnT>
-                    <a:lnB w="6350" cap="flat" cmpd="sng" algn="ctr">
-                      <a:solidFill>
-                        <a:srgbClr val="E2E8F0"/>
-                      </a:solidFill>
-                      <a:prstDash val="solid"/>
-                      <a:round/>
-                      <a:headEnd type="none" w="med" len="med"/>
-                      <a:tailEnd type="none" w="med" len="med"/>
-                    </a:lnB>
-                    <a:solidFill>
-                      <a:srgbClr val="FFFFFF"/>
-                    </a:solidFill>
-                  </a:tcPr>
-                </a:tc>
-              </a:tr>
-              <a:tr h="347472">
-                <a:tc>
-                  <a:txBody>
-                    <a:bodyPr/>
-                    <a:lstStyle/>
-                    <a:p>
-                      <a:pPr algn="l" indent="0" marL="0">
-                        <a:buNone/>
-                      </a:pPr>
-                      <a:r>
-                        <a:rPr lang="en-US" sz="1200" dirty="0">
-                          <a:solidFill>
-                            <a:srgbClr val="334155"/>
-                          </a:solidFill>
-                          <a:latin typeface="Consolas" pitchFamily="34" charset="0"/>
-                          <a:ea typeface="Consolas" pitchFamily="34" charset="-122"/>
-                          <a:cs typeface="Consolas" pitchFamily="34" charset="-120"/>
-                        </a:rPr>
-                        <a:t>stack_writer.cpp:94</a:t>
-                      </a:r>
-                      <a:endParaRPr lang="en-US" sz="1200" dirty="0">
-                        <a:latin typeface="Consolas" charset="0"/>
-                        <a:ea typeface="Consolas" charset="0"/>
-                        <a:cs typeface="Consolas" charset="0"/>
-                      </a:endParaRPr>
-                    </a:p>
-                    <a:p>
-                      <a:pPr algn="l" indent="0" marL="0">
-                        <a:buNone/>
-                      </a:pPr>
-                      <a:r>
-                        <a:rPr lang="en-US" sz="1200" dirty="0">
-                          <a:solidFill>
-                            <a:srgbClr val="334155"/>
-                          </a:solidFill>
-                          <a:latin typeface="Consolas" pitchFamily="34" charset="0"/>
-                          <a:ea typeface="Consolas" pitchFamily="34" charset="-122"/>
-                          <a:cs typeface="Consolas" pitchFamily="34" charset="-120"/>
-                        </a:rPr>
-                        <a:t>PrepareFlush / Flush</a:t>
-                      </a:r>
-                      <a:endParaRPr lang="en-US" sz="1200" dirty="0">
-                        <a:latin typeface="Consolas" charset="0"/>
-                        <a:ea typeface="Consolas" charset="0"/>
-                        <a:cs typeface="Consolas" charset="0"/>
-                      </a:endParaRPr>
-                    </a:p>
-                  </a:txBody>
-                  <a:tcPr marL="91440" marR="91440" marT="45720" marB="45720" anchor="ctr">
-                    <a:lnL w="6350" cap="flat" cmpd="sng" algn="ctr">
-                      <a:solidFill>
-                        <a:srgbClr val="E2E8F0"/>
-                      </a:solidFill>
-                      <a:prstDash val="solid"/>
-                      <a:round/>
-                      <a:headEnd type="none" w="med" len="med"/>
-                      <a:tailEnd type="none" w="med" len="med"/>
-                    </a:lnL>
-                    <a:lnR w="6350" cap="flat" cmpd="sng" algn="ctr">
-                      <a:solidFill>
-                        <a:srgbClr val="E2E8F0"/>
-                      </a:solidFill>
-                      <a:prstDash val="solid"/>
-                      <a:round/>
-                      <a:headEnd type="none" w="med" len="med"/>
-                      <a:tailEnd type="none" w="med" len="med"/>
-                    </a:lnR>
-                    <a:lnT w="6350" cap="flat" cmpd="sng" algn="ctr">
-                      <a:solidFill>
-                        <a:srgbClr val="E2E8F0"/>
-                      </a:solidFill>
-                      <a:prstDash val="solid"/>
-                      <a:round/>
-                      <a:headEnd type="none" w="med" len="med"/>
-                      <a:tailEnd type="none" w="med" len="med"/>
-                    </a:lnT>
-                    <a:lnB w="6350" cap="flat" cmpd="sng" algn="ctr">
-                      <a:solidFill>
-                        <a:srgbClr val="E2E8F0"/>
-                      </a:solidFill>
-                      <a:prstDash val="solid"/>
-                      <a:round/>
-                      <a:headEnd type="none" w="med" len="med"/>
-                      <a:tailEnd type="none" w="med" len="med"/>
-                    </a:lnB>
-                    <a:solidFill>
-                      <a:srgbClr val="FFFFFF"/>
-                    </a:solidFill>
-                  </a:tcPr>
-                </a:tc>
-                <a:tc>
-                  <a:txBody>
-                    <a:bodyPr/>
-                    <a:lstStyle/>
-                    <a:p>
-                      <a:pPr algn="ctr" indent="0" marL="0">
-                        <a:buNone/>
-                      </a:pPr>
-                      <a:r>
-                        <a:rPr lang="en-US" sz="1200" dirty="0">
-                          <a:solidFill>
-                            <a:srgbClr val="334155"/>
-                          </a:solidFill>
-                          <a:latin typeface="Consolas" pitchFamily="34" charset="0"/>
-                          <a:ea typeface="Consolas" pitchFamily="34" charset="-122"/>
-                          <a:cs typeface="Consolas" pitchFamily="34" charset="-120"/>
-                        </a:rPr>
-                        <a:t>全局 dataCount_</a:t>
-                      </a:r>
-                      <a:endParaRPr lang="en-US" sz="1200" dirty="0">
-                        <a:latin typeface="Consolas" charset="0"/>
-                        <a:ea typeface="Consolas" charset="0"/>
-                        <a:cs typeface="Consolas" charset="0"/>
-                      </a:endParaRPr>
-                    </a:p>
-                    <a:p>
-                      <a:pPr algn="ctr" indent="0" marL="0">
-                        <a:buNone/>
-                      </a:pPr>
-                      <a:r>
-                        <a:rPr lang="en-US" sz="1200" dirty="0">
-                          <a:solidFill>
-                            <a:srgbClr val="334155"/>
-                          </a:solidFill>
-                          <a:latin typeface="Consolas" pitchFamily="34" charset="0"/>
-                          <a:ea typeface="Consolas" pitchFamily="34" charset="-122"/>
-                          <a:cs typeface="Consolas" pitchFamily="34" charset="-120"/>
-                        </a:rPr>
-                        <a:t>global flushCount_</a:t>
-                      </a:r>
-                      <a:endParaRPr lang="en-US" sz="1200" dirty="0">
-                        <a:latin typeface="Consolas" charset="0"/>
-                        <a:ea typeface="Consolas" charset="0"/>
-                        <a:cs typeface="Consolas" charset="0"/>
-                      </a:endParaRPr>
-                    </a:p>
-                  </a:txBody>
-                  <a:tcPr marL="91440" marR="91440" marT="45720" marB="45720" anchor="ctr">
-                    <a:lnL w="6350" cap="flat" cmpd="sng" algn="ctr">
-                      <a:solidFill>
-                        <a:srgbClr val="E2E8F0"/>
-                      </a:solidFill>
-                      <a:prstDash val="solid"/>
-                      <a:round/>
-                      <a:headEnd type="none" w="med" len="med"/>
-                      <a:tailEnd type="none" w="med" len="med"/>
-                    </a:lnL>
-                    <a:lnR w="6350" cap="flat" cmpd="sng" algn="ctr">
-                      <a:solidFill>
-                        <a:srgbClr val="E2E8F0"/>
-                      </a:solidFill>
-                      <a:prstDash val="solid"/>
-                      <a:round/>
-                      <a:headEnd type="none" w="med" len="med"/>
-                      <a:tailEnd type="none" w="med" len="med"/>
-                    </a:lnR>
-                    <a:lnT w="6350" cap="flat" cmpd="sng" algn="ctr">
-                      <a:solidFill>
-                        <a:srgbClr val="E2E8F0"/>
-                      </a:solidFill>
-                      <a:prstDash val="solid"/>
-                      <a:round/>
-                      <a:headEnd type="none" w="med" len="med"/>
-                      <a:tailEnd type="none" w="med" len="med"/>
-                    </a:lnT>
-                    <a:lnB w="6350" cap="flat" cmpd="sng" algn="ctr">
-                      <a:solidFill>
-                        <a:srgbClr val="E2E8F0"/>
-                      </a:solidFill>
-                      <a:prstDash val="solid"/>
-                      <a:round/>
-                      <a:headEnd type="none" w="med" len="med"/>
-                      <a:tailEnd type="none" w="med" len="med"/>
-                    </a:lnB>
-                    <a:solidFill>
-                      <a:srgbClr val="FFFFFF"/>
-                    </a:solidFill>
-                  </a:tcPr>
-                </a:tc>
-                <a:tc>
-                  <a:txBody>
-                    <a:bodyPr/>
-                    <a:lstStyle/>
-                    <a:p>
-                      <a:pPr algn="ctr" indent="0" marL="0">
-                        <a:buNone/>
-                      </a:pPr>
-                      <a:r>
-                        <a:rPr lang="en-US" sz="1200" dirty="0">
-                          <a:solidFill>
-                            <a:srgbClr val="334155"/>
-                          </a:solidFill>
-                          <a:latin typeface="Consolas" pitchFamily="34" charset="0"/>
-                          <a:ea typeface="Consolas" pitchFamily="34" charset="-122"/>
-                          <a:cs typeface="Consolas" pitchFamily="34" charset="-120"/>
-                        </a:rPr>
-                        <a:t>每 shard 独立计数器</a:t>
-                      </a:r>
-                      <a:endParaRPr lang="en-US" sz="1200" dirty="0">
-                        <a:latin typeface="Consolas" charset="0"/>
-                        <a:ea typeface="Consolas" charset="0"/>
-                        <a:cs typeface="Consolas" charset="0"/>
-                      </a:endParaRPr>
-                    </a:p>
-                    <a:p>
-                      <a:pPr algn="ctr" indent="0" marL="0">
-                        <a:buNone/>
-                      </a:pPr>
-                      <a:r>
-                        <a:rPr lang="en-US" sz="1200" dirty="0">
-                          <a:solidFill>
-                            <a:srgbClr val="334155"/>
-                          </a:solidFill>
-                          <a:latin typeface="Consolas" pitchFamily="34" charset="0"/>
-                          <a:ea typeface="Consolas" pitchFamily="34" charset="-122"/>
-                          <a:cs typeface="Consolas" pitchFamily="34" charset="-120"/>
-                        </a:rPr>
-                        <a:t>汇总后 Post 一次</a:t>
-                      </a:r>
-                      <a:endParaRPr lang="en-US" sz="1200" dirty="0">
-                        <a:latin typeface="Consolas" charset="0"/>
-                        <a:ea typeface="Consolas" charset="0"/>
-                        <a:cs typeface="Consolas" charset="0"/>
-                      </a:endParaRPr>
-                    </a:p>
-                  </a:txBody>
-                  <a:tcPr marL="91440" marR="91440" marT="45720" marB="45720" anchor="ctr">
-                    <a:lnL w="6350" cap="flat" cmpd="sng" algn="ctr">
-                      <a:solidFill>
-                        <a:srgbClr val="E2E8F0"/>
-                      </a:solidFill>
-                      <a:prstDash val="solid"/>
-                      <a:round/>
-                      <a:headEnd type="none" w="med" len="med"/>
-                      <a:tailEnd type="none" w="med" len="med"/>
-                    </a:lnL>
-                    <a:lnR w="6350" cap="flat" cmpd="sng" algn="ctr">
-                      <a:solidFill>
-                        <a:srgbClr val="E2E8F0"/>
-                      </a:solidFill>
-                      <a:prstDash val="solid"/>
-                      <a:round/>
-                      <a:headEnd type="none" w="med" len="med"/>
-                      <a:tailEnd type="none" w="med" len="med"/>
-                    </a:lnR>
-                    <a:lnT w="6350" cap="flat" cmpd="sng" algn="ctr">
-                      <a:solidFill>
-                        <a:srgbClr val="E2E8F0"/>
-                      </a:solidFill>
-                      <a:prstDash val="solid"/>
-                      <a:round/>
-                      <a:headEnd type="none" w="med" len="med"/>
-                      <a:tailEnd type="none" w="med" len="med"/>
-                    </a:lnT>
-                    <a:lnB w="6350" cap="flat" cmpd="sng" algn="ctr">
-                      <a:solidFill>
-                        <a:srgbClr val="E2E8F0"/>
-                      </a:solidFill>
-                      <a:prstDash val="solid"/>
-                      <a:round/>
-                      <a:headEnd type="none" w="med" len="med"/>
-                      <a:tailEnd type="none" w="med" len="med"/>
-                    </a:lnB>
-                    <a:solidFill>
-                      <a:srgbClr val="FFFFFF"/>
-                    </a:solidFill>
-                  </a:tcPr>
-                </a:tc>
-              </a:tr>
-            </a:tbl>
-          </a:graphicData>
-        </a:graphic>
-      </p:graphicFrame>
-      <p:sp>
-        <p:nvSpPr>
-          <p:cNvPr id="9" name="Text 6"/>
-          <p:cNvSpPr/>
-          <p:nvPr/>
-        </p:nvSpPr>
-        <p:spPr>
-          <a:xfrm>
-            <a:off x="594360" y="4754880"/>
-            <a:ext cx="10972800" cy="5029200"/>
+      <p:sp>
+        <p:nvSpPr>
+          <p:cNvPr id="8" name="Text 6"/>
+          <p:cNvSpPr/>
+          <p:nvPr/>
+        </p:nvSpPr>
+        <p:spPr>
+          <a:xfrm>
+            <a:off x="457200" y="1234440"/>
+            <a:ext cx="2743200" cy="274320"/>
           </a:xfrm>
           <a:prstGeom prst="rect">
             <a:avLst/>
@@ -16604,60 +15560,1911 @@
           <a:ln/>
         </p:spPr>
         <p:txBody>
-          <a:bodyPr wrap="square" rtlCol="0" anchor="t"/>
+          <a:bodyPr wrap="square" rtlCol="0" anchor="ctr"/>
           <a:lstStyle/>
           <a:p>
             <a:pPr indent="0" marL="0">
-              <a:lnSpc>
-                <a:spcPts val="2400"/>
-              </a:lnSpc>
               <a:buNone/>
             </a:pPr>
             <a:r>
-              <a:rPr lang="en-US" sz="1500" b="1" dirty="0">
+              <a:rPr lang="en-US" sz="1200" b="1" dirty="0">
+                <a:solidFill>
+                  <a:srgbClr val="64748B"/>
+                </a:solidFill>
+              </a:rPr>
+              <a:t>当前：地址分片</a:t>
+            </a:r>
+            <a:endParaRPr lang="en-US" sz="1200" dirty="0"/>
+          </a:p>
+        </p:txBody>
+      </p:sp>
+      <p:sp>
+        <p:nvSpPr>
+          <p:cNvPr id="9" name="Shape 7"/>
+          <p:cNvSpPr/>
+          <p:nvPr/>
+        </p:nvSpPr>
+        <p:spPr>
+          <a:xfrm>
+            <a:off x="365760" y="1554480"/>
+            <a:ext cx="1645920" cy="457200"/>
+          </a:xfrm>
+          <a:prstGeom prst="rect">
+            <a:avLst>
+              <a:gd name="adj" fmla="val 10000"/>
+            </a:avLst>
+          </a:prstGeom>
+          <a:solidFill>
+            <a:srgbClr val="EFF6FF"/>
+          </a:solidFill>
+          <a:ln w="12700">
+            <a:solidFill>
+              <a:srgbClr val="E2E8F0"/>
+            </a:solidFill>
+            <a:prstDash val="solid"/>
+          </a:ln>
+        </p:spPr>
+      </p:sp>
+      <p:sp>
+        <p:nvSpPr>
+          <p:cNvPr id="10" name="Text 8"/>
+          <p:cNvSpPr/>
+          <p:nvPr/>
+        </p:nvSpPr>
+        <p:spPr>
+          <a:xfrm>
+            <a:off x="365760" y="1554480"/>
+            <a:ext cx="1645920" cy="457200"/>
+          </a:xfrm>
+          <a:prstGeom prst="rect">
+            <a:avLst/>
+          </a:prstGeom>
+          <a:noFill/>
+          <a:ln/>
+        </p:spPr>
+        <p:txBody>
+          <a:bodyPr wrap="square" rtlCol="0" anchor="ctr"/>
+          <a:lstStyle/>
+          <a:p>
+            <a:pPr algn="ctr" indent="0" marL="0">
+              <a:buNone/>
+            </a:pPr>
+            <a:r>
+              <a:rPr lang="en-US" sz="1000" dirty="0">
+                <a:solidFill>
+                  <a:srgbClr val="1E293B"/>
+                </a:solidFill>
+                <a:latin typeface="Arial" pitchFamily="34" charset="0"/>
+                <a:ea typeface="Arial" pitchFamily="34" charset="-122"/>
+                <a:cs typeface="Arial" pitchFamily="34" charset="-120"/>
+              </a:rPr>
+              <a:t>hook_malloc</a:t>
+            </a:r>
+            <a:endParaRPr lang="en-US" sz="1000" dirty="0"/>
+          </a:p>
+          <a:p>
+            <a:pPr algn="ctr" indent="0" marL="0">
+              <a:buNone/>
+            </a:pPr>
+            <a:r>
+              <a:rPr lang="en-US" sz="1000" dirty="0">
+                <a:solidFill>
+                  <a:srgbClr val="1E293B"/>
+                </a:solidFill>
+                <a:latin typeface="Arial" pitchFamily="34" charset="0"/>
+                <a:ea typeface="Arial" pitchFamily="34" charset="-122"/>
+                <a:cs typeface="Arial" pitchFamily="34" charset="-120"/>
+              </a:rPr>
+              <a:t>FpUnwind + fill</a:t>
+            </a:r>
+            <a:endParaRPr lang="en-US" sz="1000" dirty="0"/>
+          </a:p>
+        </p:txBody>
+      </p:sp>
+      <p:sp>
+        <p:nvSpPr>
+          <p:cNvPr id="11" name="Text 9"/>
+          <p:cNvSpPr/>
+          <p:nvPr/>
+        </p:nvSpPr>
+        <p:spPr>
+          <a:xfrm>
+            <a:off x="2240280" y="1554480"/>
+            <a:ext cx="228600" cy="457200"/>
+          </a:xfrm>
+          <a:prstGeom prst="rect">
+            <a:avLst/>
+          </a:prstGeom>
+          <a:noFill/>
+          <a:ln/>
+        </p:spPr>
+        <p:txBody>
+          <a:bodyPr wrap="square" rtlCol="0" anchor="ctr"/>
+          <a:lstStyle/>
+          <a:p>
+            <a:pPr algn="ctr" indent="0" marL="0">
+              <a:buNone/>
+            </a:pPr>
+            <a:r>
+              <a:rPr lang="en-US" sz="1400" dirty="0">
+                <a:solidFill>
+                  <a:srgbClr val="64748B"/>
+                </a:solidFill>
+              </a:rPr>
+              <a:t>→</a:t>
+            </a:r>
+            <a:endParaRPr lang="en-US" sz="1400" dirty="0"/>
+          </a:p>
+        </p:txBody>
+      </p:sp>
+      <p:sp>
+        <p:nvSpPr>
+          <p:cNvPr id="12" name="Shape 10"/>
+          <p:cNvSpPr/>
+          <p:nvPr/>
+        </p:nvSpPr>
+        <p:spPr>
+          <a:xfrm>
+            <a:off x="2468880" y="1554480"/>
+            <a:ext cx="1828800" cy="457200"/>
+          </a:xfrm>
+          <a:prstGeom prst="rect">
+            <a:avLst>
+              <a:gd name="adj" fmla="val 10000"/>
+            </a:avLst>
+          </a:prstGeom>
+          <a:solidFill>
+            <a:srgbClr val="FFFFFF"/>
+          </a:solidFill>
+          <a:ln w="12700">
+            <a:solidFill>
+              <a:srgbClr val="E2E8F0"/>
+            </a:solidFill>
+            <a:prstDash val="solid"/>
+          </a:ln>
+        </p:spPr>
+      </p:sp>
+      <p:sp>
+        <p:nvSpPr>
+          <p:cNvPr id="13" name="Text 11"/>
+          <p:cNvSpPr/>
+          <p:nvPr/>
+        </p:nvSpPr>
+        <p:spPr>
+          <a:xfrm>
+            <a:off x="2468880" y="1554480"/>
+            <a:ext cx="1828800" cy="457200"/>
+          </a:xfrm>
+          <a:prstGeom prst="rect">
+            <a:avLst/>
+          </a:prstGeom>
+          <a:noFill/>
+          <a:ln/>
+        </p:spPr>
+        <p:txBody>
+          <a:bodyPr wrap="square" rtlCol="0" anchor="ctr"/>
+          <a:lstStyle/>
+          <a:p>
+            <a:pPr algn="ctr" indent="0" marL="0">
+              <a:buNone/>
+            </a:pPr>
+            <a:r>
+              <a:rPr lang="en-US" sz="1000" dirty="0">
+                <a:solidFill>
+                  <a:srgbClr val="1E293B"/>
+                </a:solidFill>
+                <a:latin typeface="Arial" pitchFamily="34" charset="0"/>
+                <a:ea typeface="Arial" pitchFamily="34" charset="-122"/>
+                <a:cs typeface="Arial" pitchFamily="34" charset="-120"/>
+              </a:rPr>
+              <a:t>SendStackWithPayload</a:t>
+            </a:r>
+            <a:endParaRPr lang="en-US" sz="1000" dirty="0"/>
+          </a:p>
+          <a:p>
+            <a:pPr algn="ctr" indent="0" marL="0">
+              <a:buNone/>
+            </a:pPr>
+            <a:r>
+              <a:rPr lang="en-US" sz="1000" dirty="0">
+                <a:solidFill>
+                  <a:srgbClr val="1E293B"/>
+                </a:solidFill>
+                <a:latin typeface="Arial" pitchFamily="34" charset="0"/>
+                <a:ea typeface="Arial" pitchFamily="34" charset="-122"/>
+                <a:cs typeface="Arial" pitchFamily="34" charset="-120"/>
+              </a:rPr>
+              <a:t>addr % N → Block</a:t>
+            </a:r>
+            <a:endParaRPr lang="en-US" sz="1000" dirty="0"/>
+          </a:p>
+        </p:txBody>
+      </p:sp>
+      <p:sp>
+        <p:nvSpPr>
+          <p:cNvPr id="14" name="Shape 12"/>
+          <p:cNvSpPr/>
+          <p:nvPr/>
+        </p:nvSpPr>
+        <p:spPr>
+          <a:xfrm>
+            <a:off x="2560320" y="1426464"/>
+            <a:ext cx="256032" cy="256032"/>
+          </a:xfrm>
+          <a:prstGeom prst="ellipse">
+            <a:avLst/>
+          </a:prstGeom>
+          <a:solidFill>
+            <a:srgbClr val="DC2626"/>
+          </a:solidFill>
+          <a:ln/>
+        </p:spPr>
+      </p:sp>
+      <p:sp>
+        <p:nvSpPr>
+          <p:cNvPr id="15" name="Text 13"/>
+          <p:cNvSpPr/>
+          <p:nvPr/>
+        </p:nvSpPr>
+        <p:spPr>
+          <a:xfrm>
+            <a:off x="2560320" y="1426464"/>
+            <a:ext cx="256032" cy="256032"/>
+          </a:xfrm>
+          <a:prstGeom prst="rect">
+            <a:avLst/>
+          </a:prstGeom>
+          <a:noFill/>
+          <a:ln/>
+        </p:spPr>
+        <p:txBody>
+          <a:bodyPr wrap="square" rtlCol="0" anchor="ctr"/>
+          <a:lstStyle/>
+          <a:p>
+            <a:pPr algn="ctr" indent="0" marL="0">
+              <a:buNone/>
+            </a:pPr>
+            <a:r>
+              <a:rPr lang="en-US" sz="900" b="1" dirty="0">
+                <a:solidFill>
+                  <a:srgbClr val="FFFFFF"/>
+                </a:solidFill>
+                <a:latin typeface="Consolas" pitchFamily="34" charset="0"/>
+                <a:ea typeface="Consolas" pitchFamily="34" charset="-122"/>
+                <a:cs typeface="Consolas" pitchFamily="34" charset="-120"/>
+              </a:rPr>
+              <a:t>1</a:t>
+            </a:r>
+            <a:endParaRPr lang="en-US" sz="900" dirty="0"/>
+          </a:p>
+        </p:txBody>
+      </p:sp>
+      <p:sp>
+        <p:nvSpPr>
+          <p:cNvPr id="16" name="Text 14"/>
+          <p:cNvSpPr/>
+          <p:nvPr/>
+        </p:nvSpPr>
+        <p:spPr>
+          <a:xfrm>
+            <a:off x="4526280" y="1554480"/>
+            <a:ext cx="228600" cy="457200"/>
+          </a:xfrm>
+          <a:prstGeom prst="rect">
+            <a:avLst/>
+          </a:prstGeom>
+          <a:noFill/>
+          <a:ln/>
+        </p:spPr>
+        <p:txBody>
+          <a:bodyPr wrap="square" rtlCol="0" anchor="ctr"/>
+          <a:lstStyle/>
+          <a:p>
+            <a:pPr algn="ctr" indent="0" marL="0">
+              <a:buNone/>
+            </a:pPr>
+            <a:r>
+              <a:rPr lang="en-US" sz="1400" dirty="0">
+                <a:solidFill>
+                  <a:srgbClr val="64748B"/>
+                </a:solidFill>
+              </a:rPr>
+              <a:t>→</a:t>
+            </a:r>
+            <a:endParaRPr lang="en-US" sz="1400" dirty="0"/>
+          </a:p>
+        </p:txBody>
+      </p:sp>
+      <p:sp>
+        <p:nvSpPr>
+          <p:cNvPr id="17" name="Shape 15"/>
+          <p:cNvSpPr/>
+          <p:nvPr/>
+        </p:nvSpPr>
+        <p:spPr>
+          <a:xfrm>
+            <a:off x="4754880" y="1554480"/>
+            <a:ext cx="1645920" cy="457200"/>
+          </a:xfrm>
+          <a:prstGeom prst="rect">
+            <a:avLst>
+              <a:gd name="adj" fmla="val 10000"/>
+            </a:avLst>
+          </a:prstGeom>
+          <a:solidFill>
+            <a:srgbClr val="FFFBEB"/>
+          </a:solidFill>
+          <a:ln w="12700">
+            <a:solidFill>
+              <a:srgbClr val="E2E8F0"/>
+            </a:solidFill>
+            <a:prstDash val="solid"/>
+          </a:ln>
+        </p:spPr>
+      </p:sp>
+      <p:sp>
+        <p:nvSpPr>
+          <p:cNvPr id="18" name="Text 16"/>
+          <p:cNvSpPr/>
+          <p:nvPr/>
+        </p:nvSpPr>
+        <p:spPr>
+          <a:xfrm>
+            <a:off x="4754880" y="1554480"/>
+            <a:ext cx="1645920" cy="457200"/>
+          </a:xfrm>
+          <a:prstGeom prst="rect">
+            <a:avLst/>
+          </a:prstGeom>
+          <a:noFill/>
+          <a:ln/>
+        </p:spPr>
+        <p:txBody>
+          <a:bodyPr wrap="square" rtlCol="0" anchor="ctr"/>
+          <a:lstStyle/>
+          <a:p>
+            <a:pPr algn="ctr" indent="0" marL="0">
+              <a:buNone/>
+            </a:pPr>
+            <a:r>
+              <a:rPr lang="en-US" sz="1000" dirty="0">
+                <a:solidFill>
+                  <a:srgbClr val="D97706"/>
+                </a:solidFill>
+                <a:latin typeface="Arial" pitchFamily="34" charset="0"/>
+                <a:ea typeface="Arial" pitchFamily="34" charset="-122"/>
+                <a:cs typeface="Arial" pitchFamily="34" charset="-120"/>
+              </a:rPr>
+              <a:t>ShareMemoryBlock</a:t>
+            </a:r>
+            <a:endParaRPr lang="en-US" sz="1000" dirty="0"/>
+          </a:p>
+          <a:p>
+            <a:pPr algn="ctr" indent="0" marL="0">
+              <a:buNone/>
+            </a:pPr>
+            <a:r>
+              <a:rPr lang="en-US" sz="1000" dirty="0">
+                <a:solidFill>
+                  <a:srgbClr val="D97706"/>
+                </a:solidFill>
+                <a:latin typeface="Arial" pitchFamily="34" charset="0"/>
+                <a:ea typeface="Arial" pitchFamily="34" charset="-122"/>
+                <a:cs typeface="Arial" pitchFamily="34" charset="-120"/>
+              </a:rPr>
+              <a:t>内部全局锁</a:t>
+            </a:r>
+            <a:endParaRPr lang="en-US" sz="1000" dirty="0"/>
+          </a:p>
+        </p:txBody>
+      </p:sp>
+      <p:sp>
+        <p:nvSpPr>
+          <p:cNvPr id="19" name="Shape 17"/>
+          <p:cNvSpPr/>
+          <p:nvPr/>
+        </p:nvSpPr>
+        <p:spPr>
+          <a:xfrm>
+            <a:off x="4846320" y="1426464"/>
+            <a:ext cx="256032" cy="256032"/>
+          </a:xfrm>
+          <a:prstGeom prst="ellipse">
+            <a:avLst/>
+          </a:prstGeom>
+          <a:solidFill>
+            <a:srgbClr val="DC2626"/>
+          </a:solidFill>
+          <a:ln/>
+        </p:spPr>
+      </p:sp>
+      <p:sp>
+        <p:nvSpPr>
+          <p:cNvPr id="20" name="Text 18"/>
+          <p:cNvSpPr/>
+          <p:nvPr/>
+        </p:nvSpPr>
+        <p:spPr>
+          <a:xfrm>
+            <a:off x="4846320" y="1426464"/>
+            <a:ext cx="256032" cy="256032"/>
+          </a:xfrm>
+          <a:prstGeom prst="rect">
+            <a:avLst/>
+          </a:prstGeom>
+          <a:noFill/>
+          <a:ln/>
+        </p:spPr>
+        <p:txBody>
+          <a:bodyPr wrap="square" rtlCol="0" anchor="ctr"/>
+          <a:lstStyle/>
+          <a:p>
+            <a:pPr algn="ctr" indent="0" marL="0">
+              <a:buNone/>
+            </a:pPr>
+            <a:r>
+              <a:rPr lang="en-US" sz="900" b="1" dirty="0">
+                <a:solidFill>
+                  <a:srgbClr val="FFFFFF"/>
+                </a:solidFill>
+                <a:latin typeface="Consolas" pitchFamily="34" charset="0"/>
+                <a:ea typeface="Consolas" pitchFamily="34" charset="-122"/>
+                <a:cs typeface="Consolas" pitchFamily="34" charset="-120"/>
+              </a:rPr>
+              <a:t>2</a:t>
+            </a:r>
+            <a:endParaRPr lang="en-US" sz="900" dirty="0"/>
+          </a:p>
+        </p:txBody>
+      </p:sp>
+      <p:sp>
+        <p:nvSpPr>
+          <p:cNvPr id="21" name="Text 19"/>
+          <p:cNvSpPr/>
+          <p:nvPr/>
+        </p:nvSpPr>
+        <p:spPr>
+          <a:xfrm>
+            <a:off x="6629400" y="1554480"/>
+            <a:ext cx="228600" cy="457200"/>
+          </a:xfrm>
+          <a:prstGeom prst="rect">
+            <a:avLst/>
+          </a:prstGeom>
+          <a:noFill/>
+          <a:ln/>
+        </p:spPr>
+        <p:txBody>
+          <a:bodyPr wrap="square" rtlCol="0" anchor="ctr"/>
+          <a:lstStyle/>
+          <a:p>
+            <a:pPr algn="ctr" indent="0" marL="0">
+              <a:buNone/>
+            </a:pPr>
+            <a:r>
+              <a:rPr lang="en-US" sz="1400" dirty="0">
+                <a:solidFill>
+                  <a:srgbClr val="64748B"/>
+                </a:solidFill>
+              </a:rPr>
+              <a:t>→</a:t>
+            </a:r>
+            <a:endParaRPr lang="en-US" sz="1400" dirty="0"/>
+          </a:p>
+        </p:txBody>
+      </p:sp>
+      <p:sp>
+        <p:nvSpPr>
+          <p:cNvPr id="22" name="Shape 20"/>
+          <p:cNvSpPr/>
+          <p:nvPr/>
+        </p:nvSpPr>
+        <p:spPr>
+          <a:xfrm>
+            <a:off x="6858000" y="1554480"/>
+            <a:ext cx="1828800" cy="457200"/>
+          </a:xfrm>
+          <a:prstGeom prst="rect">
+            <a:avLst>
+              <a:gd name="adj" fmla="val 10000"/>
+            </a:avLst>
+          </a:prstGeom>
+          <a:solidFill>
+            <a:srgbClr val="FFFFFF"/>
+          </a:solidFill>
+          <a:ln w="12700">
+            <a:solidFill>
+              <a:srgbClr val="E2E8F0"/>
+            </a:solidFill>
+            <a:prstDash val="solid"/>
+          </a:ln>
+        </p:spPr>
+      </p:sp>
+      <p:sp>
+        <p:nvSpPr>
+          <p:cNvPr id="23" name="Text 21"/>
+          <p:cNvSpPr/>
+          <p:nvPr/>
+        </p:nvSpPr>
+        <p:spPr>
+          <a:xfrm>
+            <a:off x="6858000" y="1554480"/>
+            <a:ext cx="1828800" cy="457200"/>
+          </a:xfrm>
+          <a:prstGeom prst="rect">
+            <a:avLst/>
+          </a:prstGeom>
+          <a:noFill/>
+          <a:ln/>
+        </p:spPr>
+        <p:txBody>
+          <a:bodyPr wrap="square" rtlCol="0" anchor="ctr"/>
+          <a:lstStyle/>
+          <a:p>
+            <a:pPr algn="ctr" indent="0" marL="0">
+              <a:buNone/>
+            </a:pPr>
+            <a:r>
+              <a:rPr lang="en-US" sz="1000" dirty="0">
+                <a:solidFill>
+                  <a:srgbClr val="1E293B"/>
+                </a:solidFill>
+                <a:latin typeface="Arial" pitchFamily="34" charset="0"/>
+                <a:ea typeface="Arial" pitchFamily="34" charset="-122"/>
+                <a:cs typeface="Arial" pitchFamily="34" charset="-120"/>
+              </a:rPr>
+              <a:t>PrepareFlush / Flush</a:t>
+            </a:r>
+            <a:endParaRPr lang="en-US" sz="1000" dirty="0"/>
+          </a:p>
+          <a:p>
+            <a:pPr algn="ctr" indent="0" marL="0">
+              <a:buNone/>
+            </a:pPr>
+            <a:r>
+              <a:rPr lang="en-US" sz="1000" dirty="0">
+                <a:solidFill>
+                  <a:srgbClr val="1E293B"/>
+                </a:solidFill>
+                <a:latin typeface="Arial" pitchFamily="34" charset="0"/>
+                <a:ea typeface="Arial" pitchFamily="34" charset="-122"/>
+                <a:cs typeface="Arial" pitchFamily="34" charset="-120"/>
+              </a:rPr>
+              <a:t>global counter → Post</a:t>
+            </a:r>
+            <a:endParaRPr lang="en-US" sz="1000" dirty="0"/>
+          </a:p>
+        </p:txBody>
+      </p:sp>
+      <p:sp>
+        <p:nvSpPr>
+          <p:cNvPr id="24" name="Shape 22"/>
+          <p:cNvSpPr/>
+          <p:nvPr/>
+        </p:nvSpPr>
+        <p:spPr>
+          <a:xfrm>
+            <a:off x="6949440" y="1426464"/>
+            <a:ext cx="256032" cy="256032"/>
+          </a:xfrm>
+          <a:prstGeom prst="ellipse">
+            <a:avLst/>
+          </a:prstGeom>
+          <a:solidFill>
+            <a:srgbClr val="DC2626"/>
+          </a:solidFill>
+          <a:ln/>
+        </p:spPr>
+      </p:sp>
+      <p:sp>
+        <p:nvSpPr>
+          <p:cNvPr id="25" name="Text 23"/>
+          <p:cNvSpPr/>
+          <p:nvPr/>
+        </p:nvSpPr>
+        <p:spPr>
+          <a:xfrm>
+            <a:off x="6949440" y="1426464"/>
+            <a:ext cx="256032" cy="256032"/>
+          </a:xfrm>
+          <a:prstGeom prst="rect">
+            <a:avLst/>
+          </a:prstGeom>
+          <a:noFill/>
+          <a:ln/>
+        </p:spPr>
+        <p:txBody>
+          <a:bodyPr wrap="square" rtlCol="0" anchor="ctr"/>
+          <a:lstStyle/>
+          <a:p>
+            <a:pPr algn="ctr" indent="0" marL="0">
+              <a:buNone/>
+            </a:pPr>
+            <a:r>
+              <a:rPr lang="en-US" sz="900" b="1" dirty="0">
+                <a:solidFill>
+                  <a:srgbClr val="FFFFFF"/>
+                </a:solidFill>
+                <a:latin typeface="Consolas" pitchFamily="34" charset="0"/>
+                <a:ea typeface="Consolas" pitchFamily="34" charset="-122"/>
+                <a:cs typeface="Consolas" pitchFamily="34" charset="-120"/>
+              </a:rPr>
+              <a:t>3</a:t>
+            </a:r>
+            <a:endParaRPr lang="en-US" sz="900" dirty="0"/>
+          </a:p>
+        </p:txBody>
+      </p:sp>
+      <p:sp>
+        <p:nvSpPr>
+          <p:cNvPr id="26" name="Text 24"/>
+          <p:cNvSpPr/>
+          <p:nvPr/>
+        </p:nvSpPr>
+        <p:spPr>
+          <a:xfrm>
+            <a:off x="8915400" y="1554480"/>
+            <a:ext cx="228600" cy="457200"/>
+          </a:xfrm>
+          <a:prstGeom prst="rect">
+            <a:avLst/>
+          </a:prstGeom>
+          <a:noFill/>
+          <a:ln/>
+        </p:spPr>
+        <p:txBody>
+          <a:bodyPr wrap="square" rtlCol="0" anchor="ctr"/>
+          <a:lstStyle/>
+          <a:p>
+            <a:pPr algn="ctr" indent="0" marL="0">
+              <a:buNone/>
+            </a:pPr>
+            <a:r>
+              <a:rPr lang="en-US" sz="1400" dirty="0">
+                <a:solidFill>
+                  <a:srgbClr val="64748B"/>
+                </a:solidFill>
+              </a:rPr>
+              <a:t>→</a:t>
+            </a:r>
+            <a:endParaRPr lang="en-US" sz="1400" dirty="0"/>
+          </a:p>
+        </p:txBody>
+      </p:sp>
+      <p:sp>
+        <p:nvSpPr>
+          <p:cNvPr id="27" name="Shape 25"/>
+          <p:cNvSpPr/>
+          <p:nvPr/>
+        </p:nvSpPr>
+        <p:spPr>
+          <a:xfrm>
+            <a:off x="9144000" y="1554480"/>
+            <a:ext cx="2011680" cy="457200"/>
+          </a:xfrm>
+          <a:prstGeom prst="rect">
+            <a:avLst>
+              <a:gd name="adj" fmla="val 10000"/>
+            </a:avLst>
+          </a:prstGeom>
+          <a:solidFill>
+            <a:srgbClr val="ECFDF5"/>
+          </a:solidFill>
+          <a:ln w="12700">
+            <a:solidFill>
+              <a:srgbClr val="E2E8F0"/>
+            </a:solidFill>
+            <a:prstDash val="solid"/>
+          </a:ln>
+        </p:spPr>
+      </p:sp>
+      <p:sp>
+        <p:nvSpPr>
+          <p:cNvPr id="28" name="Text 26"/>
+          <p:cNvSpPr/>
+          <p:nvPr/>
+        </p:nvSpPr>
+        <p:spPr>
+          <a:xfrm>
+            <a:off x="9144000" y="1554480"/>
+            <a:ext cx="2011680" cy="457200"/>
+          </a:xfrm>
+          <a:prstGeom prst="rect">
+            <a:avLst/>
+          </a:prstGeom>
+          <a:noFill/>
+          <a:ln/>
+        </p:spPr>
+        <p:txBody>
+          <a:bodyPr wrap="square" rtlCol="0" anchor="ctr"/>
+          <a:lstStyle/>
+          <a:p>
+            <a:pPr algn="ctr" indent="0" marL="0">
+              <a:buNone/>
+            </a:pPr>
+            <a:r>
+              <a:rPr lang="en-US" sz="1000" dirty="0">
+                <a:solidFill>
+                  <a:srgbClr val="1E293B"/>
+                </a:solidFill>
+                <a:latin typeface="Arial" pitchFamily="34" charset="0"/>
+                <a:ea typeface="Arial" pitchFamily="34" charset="-122"/>
+                <a:cs typeface="Arial" pitchFamily="34" charset="-120"/>
+              </a:rPr>
+              <a:t>Consumer</a:t>
+            </a:r>
+            <a:endParaRPr lang="en-US" sz="1000" dirty="0"/>
+          </a:p>
+          <a:p>
+            <a:pPr algn="ctr" indent="0" marL="0">
+              <a:buNone/>
+            </a:pPr>
+            <a:r>
+              <a:rPr lang="en-US" sz="1000" dirty="0">
+                <a:solidFill>
+                  <a:srgbClr val="1E293B"/>
+                </a:solidFill>
+                <a:latin typeface="Arial" pitchFamily="34" charset="0"/>
+                <a:ea typeface="Arial" pitchFamily="34" charset="-122"/>
+                <a:cs typeface="Arial" pitchFamily="34" charset="-120"/>
+              </a:rPr>
+              <a:t>单个环形区遍历</a:t>
+            </a:r>
+            <a:endParaRPr lang="en-US" sz="1000" dirty="0"/>
+          </a:p>
+        </p:txBody>
+      </p:sp>
+      <p:sp>
+        <p:nvSpPr>
+          <p:cNvPr id="29" name="Text 27"/>
+          <p:cNvSpPr/>
+          <p:nvPr/>
+        </p:nvSpPr>
+        <p:spPr>
+          <a:xfrm>
+            <a:off x="5669280" y="2194560"/>
+            <a:ext cx="731520" cy="320040"/>
+          </a:xfrm>
+          <a:prstGeom prst="rect">
+            <a:avLst/>
+          </a:prstGeom>
+          <a:noFill/>
+          <a:ln/>
+        </p:spPr>
+        <p:txBody>
+          <a:bodyPr wrap="square" rtlCol="0" anchor="ctr"/>
+          <a:lstStyle/>
+          <a:p>
+            <a:pPr algn="ctr" indent="0" marL="0">
+              <a:buNone/>
+            </a:pPr>
+            <a:r>
+              <a:rPr lang="en-US" sz="1800" dirty="0">
                 <a:solidFill>
                   <a:srgbClr val="2563EB"/>
                 </a:solidFill>
               </a:rPr>
-              <a:t>改动集中在 StackWriter 层，不影响上层 hook_malloc/hook_free 等函数</a:t>
+              <a:t>↓</a:t>
             </a:r>
-            <a:endParaRPr lang="en-US" sz="1500" dirty="0"/>
-          </a:p>
-          <a:p>
-            <a:pPr marL="342900" indent="-342900">
-              <a:lnSpc>
-                <a:spcPts val="2400"/>
-              </a:lnSpc>
-              <a:buSzPct val="100000"/>
-              <a:buChar char="•"/>
+            <a:endParaRPr lang="en-US" sz="1800" dirty="0"/>
+          </a:p>
+        </p:txBody>
+      </p:sp>
+      <p:sp>
+        <p:nvSpPr>
+          <p:cNvPr id="30" name="Text 28"/>
+          <p:cNvSpPr/>
+          <p:nvPr/>
+        </p:nvSpPr>
+        <p:spPr>
+          <a:xfrm>
+            <a:off x="457200" y="2560320"/>
+            <a:ext cx="2743200" cy="274320"/>
+          </a:xfrm>
+          <a:prstGeom prst="rect">
+            <a:avLst/>
+          </a:prstGeom>
+          <a:noFill/>
+          <a:ln/>
+        </p:spPr>
+        <p:txBody>
+          <a:bodyPr wrap="square" rtlCol="0" anchor="ctr"/>
+          <a:lstStyle/>
+          <a:p>
+            <a:pPr indent="0" marL="0">
+              <a:buNone/>
+            </a:pPr>
+            <a:r>
+              <a:rPr lang="en-US" sz="1200" b="1" dirty="0">
+                <a:solidFill>
+                  <a:srgbClr val="059669"/>
+                </a:solidFill>
+              </a:rPr>
+              <a:t>改为：线程分片</a:t>
+            </a:r>
+            <a:endParaRPr lang="en-US" sz="1200" dirty="0"/>
+          </a:p>
+        </p:txBody>
+      </p:sp>
+      <p:sp>
+        <p:nvSpPr>
+          <p:cNvPr id="31" name="Shape 29"/>
+          <p:cNvSpPr/>
+          <p:nvPr/>
+        </p:nvSpPr>
+        <p:spPr>
+          <a:xfrm>
+            <a:off x="365760" y="2880360"/>
+            <a:ext cx="1645920" cy="457200"/>
+          </a:xfrm>
+          <a:prstGeom prst="rect">
+            <a:avLst>
+              <a:gd name="adj" fmla="val 10000"/>
+            </a:avLst>
+          </a:prstGeom>
+          <a:solidFill>
+            <a:srgbClr val="EFF6FF"/>
+          </a:solidFill>
+          <a:ln w="12700">
+            <a:solidFill>
+              <a:srgbClr val="E2E8F0"/>
+            </a:solidFill>
+            <a:prstDash val="solid"/>
+          </a:ln>
+        </p:spPr>
+      </p:sp>
+      <p:sp>
+        <p:nvSpPr>
+          <p:cNvPr id="32" name="Text 30"/>
+          <p:cNvSpPr/>
+          <p:nvPr/>
+        </p:nvSpPr>
+        <p:spPr>
+          <a:xfrm>
+            <a:off x="365760" y="2880360"/>
+            <a:ext cx="1645920" cy="457200"/>
+          </a:xfrm>
+          <a:prstGeom prst="rect">
+            <a:avLst/>
+          </a:prstGeom>
+          <a:noFill/>
+          <a:ln/>
+        </p:spPr>
+        <p:txBody>
+          <a:bodyPr wrap="square" rtlCol="0" anchor="ctr"/>
+          <a:lstStyle/>
+          <a:p>
+            <a:pPr algn="ctr" indent="0" marL="0">
+              <a:buNone/>
+            </a:pPr>
+            <a:r>
+              <a:rPr lang="en-US" sz="1000" dirty="0">
+                <a:solidFill>
+                  <a:srgbClr val="1E293B"/>
+                </a:solidFill>
+                <a:latin typeface="Arial" pitchFamily="34" charset="0"/>
+                <a:ea typeface="Arial" pitchFamily="34" charset="-122"/>
+                <a:cs typeface="Arial" pitchFamily="34" charset="-120"/>
+              </a:rPr>
+              <a:t>hook_malloc</a:t>
+            </a:r>
+            <a:endParaRPr lang="en-US" sz="1000" dirty="0"/>
+          </a:p>
+          <a:p>
+            <a:pPr algn="ctr" indent="0" marL="0">
+              <a:buNone/>
+            </a:pPr>
+            <a:r>
+              <a:rPr lang="en-US" sz="1000" dirty="0">
+                <a:solidFill>
+                  <a:srgbClr val="1E293B"/>
+                </a:solidFill>
+                <a:latin typeface="Arial" pitchFamily="34" charset="0"/>
+                <a:ea typeface="Arial" pitchFamily="34" charset="-122"/>
+                <a:cs typeface="Arial" pitchFamily="34" charset="-120"/>
+              </a:rPr>
+              <a:t>FpUnwind + fill</a:t>
+            </a:r>
+            <a:endParaRPr lang="en-US" sz="1000" dirty="0"/>
+          </a:p>
+        </p:txBody>
+      </p:sp>
+      <p:sp>
+        <p:nvSpPr>
+          <p:cNvPr id="33" name="Text 31"/>
+          <p:cNvSpPr/>
+          <p:nvPr/>
+        </p:nvSpPr>
+        <p:spPr>
+          <a:xfrm>
+            <a:off x="2240280" y="2880360"/>
+            <a:ext cx="228600" cy="457200"/>
+          </a:xfrm>
+          <a:prstGeom prst="rect">
+            <a:avLst/>
+          </a:prstGeom>
+          <a:noFill/>
+          <a:ln/>
+        </p:spPr>
+        <p:txBody>
+          <a:bodyPr wrap="square" rtlCol="0" anchor="ctr"/>
+          <a:lstStyle/>
+          <a:p>
+            <a:pPr algn="ctr" indent="0" marL="0">
+              <a:buNone/>
             </a:pPr>
             <a:r>
               <a:rPr lang="en-US" sz="1400" dirty="0">
                 <a:solidFill>
-                  <a:srgbClr val="334155"/>
+                  <a:srgbClr val="64748B"/>
                 </a:solidFill>
               </a:rPr>
-              <a:t>兼容性：num_shards=0 时保持现有行为，向后兼容</a:t>
+              <a:t>→</a:t>
             </a:r>
-            <a:endParaRPr lang="en-US" sz="1500" dirty="0"/>
-          </a:p>
-          <a:p>
-            <a:pPr marL="342900" indent="-342900">
-              <a:lnSpc>
-                <a:spcPts val="2400"/>
-              </a:lnSpc>
-              <a:buSzPct val="100000"/>
-              <a:buChar char="•"/>
+            <a:endParaRPr lang="en-US" sz="1400" dirty="0"/>
+          </a:p>
+        </p:txBody>
+      </p:sp>
+      <p:sp>
+        <p:nvSpPr>
+          <p:cNvPr id="34" name="Shape 32"/>
+          <p:cNvSpPr/>
+          <p:nvPr/>
+        </p:nvSpPr>
+        <p:spPr>
+          <a:xfrm>
+            <a:off x="2468880" y="2880360"/>
+            <a:ext cx="1828800" cy="457200"/>
+          </a:xfrm>
+          <a:prstGeom prst="rect">
+            <a:avLst>
+              <a:gd name="adj" fmla="val 10000"/>
+            </a:avLst>
+          </a:prstGeom>
+          <a:solidFill>
+            <a:srgbClr val="ECFDF5"/>
+          </a:solidFill>
+          <a:ln w="12700">
+            <a:solidFill>
+              <a:srgbClr val="E2E8F0"/>
+            </a:solidFill>
+            <a:prstDash val="solid"/>
+          </a:ln>
+        </p:spPr>
+      </p:sp>
+      <p:sp>
+        <p:nvSpPr>
+          <p:cNvPr id="35" name="Text 33"/>
+          <p:cNvSpPr/>
+          <p:nvPr/>
+        </p:nvSpPr>
+        <p:spPr>
+          <a:xfrm>
+            <a:off x="2468880" y="2880360"/>
+            <a:ext cx="1828800" cy="457200"/>
+          </a:xfrm>
+          <a:prstGeom prst="rect">
+            <a:avLst/>
+          </a:prstGeom>
+          <a:noFill/>
+          <a:ln/>
+        </p:spPr>
+        <p:txBody>
+          <a:bodyPr wrap="square" rtlCol="0" anchor="ctr"/>
+          <a:lstStyle/>
+          <a:p>
+            <a:pPr algn="ctr" indent="0" marL="0">
+              <a:buNone/>
+            </a:pPr>
+            <a:r>
+              <a:rPr lang="en-US" sz="1000" dirty="0">
+                <a:solidFill>
+                  <a:srgbClr val="059669"/>
+                </a:solidFill>
+                <a:latin typeface="Arial" pitchFamily="34" charset="0"/>
+                <a:ea typeface="Arial" pitchFamily="34" charset="-122"/>
+                <a:cs typeface="Arial" pitchFamily="34" charset="-120"/>
+              </a:rPr>
+              <a:t>SendStackWithPayload</a:t>
+            </a:r>
+            <a:endParaRPr lang="en-US" sz="1000" dirty="0"/>
+          </a:p>
+          <a:p>
+            <a:pPr algn="ctr" indent="0" marL="0">
+              <a:buNone/>
+            </a:pPr>
+            <a:r>
+              <a:rPr lang="en-US" sz="1000" dirty="0">
+                <a:solidFill>
+                  <a:srgbClr val="059669"/>
+                </a:solidFill>
+                <a:latin typeface="Arial" pitchFamily="34" charset="0"/>
+                <a:ea typeface="Arial" pitchFamily="34" charset="-122"/>
+                <a:cs typeface="Arial" pitchFamily="34" charset="-120"/>
+              </a:rPr>
+              <a:t>tid % N → Block[shard]</a:t>
+            </a:r>
+            <a:endParaRPr lang="en-US" sz="1000" dirty="0"/>
+          </a:p>
+        </p:txBody>
+      </p:sp>
+      <p:sp>
+        <p:nvSpPr>
+          <p:cNvPr id="36" name="Shape 34"/>
+          <p:cNvSpPr/>
+          <p:nvPr/>
+        </p:nvSpPr>
+        <p:spPr>
+          <a:xfrm>
+            <a:off x="2560320" y="2752344"/>
+            <a:ext cx="256032" cy="256032"/>
+          </a:xfrm>
+          <a:prstGeom prst="ellipse">
+            <a:avLst/>
+          </a:prstGeom>
+          <a:solidFill>
+            <a:srgbClr val="059669"/>
+          </a:solidFill>
+          <a:ln/>
+        </p:spPr>
+      </p:sp>
+      <p:sp>
+        <p:nvSpPr>
+          <p:cNvPr id="37" name="Text 35"/>
+          <p:cNvSpPr/>
+          <p:nvPr/>
+        </p:nvSpPr>
+        <p:spPr>
+          <a:xfrm>
+            <a:off x="2560320" y="2752344"/>
+            <a:ext cx="256032" cy="256032"/>
+          </a:xfrm>
+          <a:prstGeom prst="rect">
+            <a:avLst/>
+          </a:prstGeom>
+          <a:noFill/>
+          <a:ln/>
+        </p:spPr>
+        <p:txBody>
+          <a:bodyPr wrap="square" rtlCol="0" anchor="ctr"/>
+          <a:lstStyle/>
+          <a:p>
+            <a:pPr algn="ctr" indent="0" marL="0">
+              <a:buNone/>
+            </a:pPr>
+            <a:r>
+              <a:rPr lang="en-US" sz="900" b="1" dirty="0">
+                <a:solidFill>
+                  <a:srgbClr val="FFFFFF"/>
+                </a:solidFill>
+                <a:latin typeface="Consolas" pitchFamily="34" charset="0"/>
+                <a:ea typeface="Consolas" pitchFamily="34" charset="-122"/>
+                <a:cs typeface="Consolas" pitchFamily="34" charset="-120"/>
+              </a:rPr>
+              <a:t>1</a:t>
+            </a:r>
+            <a:endParaRPr lang="en-US" sz="900" dirty="0"/>
+          </a:p>
+        </p:txBody>
+      </p:sp>
+      <p:sp>
+        <p:nvSpPr>
+          <p:cNvPr id="38" name="Text 36"/>
+          <p:cNvSpPr/>
+          <p:nvPr/>
+        </p:nvSpPr>
+        <p:spPr>
+          <a:xfrm>
+            <a:off x="4526280" y="2880360"/>
+            <a:ext cx="228600" cy="457200"/>
+          </a:xfrm>
+          <a:prstGeom prst="rect">
+            <a:avLst/>
+          </a:prstGeom>
+          <a:noFill/>
+          <a:ln/>
+        </p:spPr>
+        <p:txBody>
+          <a:bodyPr wrap="square" rtlCol="0" anchor="ctr"/>
+          <a:lstStyle/>
+          <a:p>
+            <a:pPr algn="ctr" indent="0" marL="0">
+              <a:buNone/>
             </a:pPr>
             <a:r>
               <a:rPr lang="en-US" sz="1400" dirty="0">
                 <a:solidFill>
+                  <a:srgbClr val="64748B"/>
+                </a:solidFill>
+              </a:rPr>
+              <a:t>→</a:t>
+            </a:r>
+            <a:endParaRPr lang="en-US" sz="1400" dirty="0"/>
+          </a:p>
+        </p:txBody>
+      </p:sp>
+      <p:sp>
+        <p:nvSpPr>
+          <p:cNvPr id="39" name="Shape 37"/>
+          <p:cNvSpPr/>
+          <p:nvPr/>
+        </p:nvSpPr>
+        <p:spPr>
+          <a:xfrm>
+            <a:off x="4754880" y="2880360"/>
+            <a:ext cx="1645920" cy="457200"/>
+          </a:xfrm>
+          <a:prstGeom prst="rect">
+            <a:avLst>
+              <a:gd name="adj" fmla="val 10000"/>
+            </a:avLst>
+          </a:prstGeom>
+          <a:solidFill>
+            <a:srgbClr val="ECFDF5"/>
+          </a:solidFill>
+          <a:ln w="12700">
+            <a:solidFill>
+              <a:srgbClr val="E2E8F0"/>
+            </a:solidFill>
+            <a:prstDash val="solid"/>
+          </a:ln>
+        </p:spPr>
+      </p:sp>
+      <p:sp>
+        <p:nvSpPr>
+          <p:cNvPr id="40" name="Text 38"/>
+          <p:cNvSpPr/>
+          <p:nvPr/>
+        </p:nvSpPr>
+        <p:spPr>
+          <a:xfrm>
+            <a:off x="4754880" y="2880360"/>
+            <a:ext cx="1645920" cy="457200"/>
+          </a:xfrm>
+          <a:prstGeom prst="rect">
+            <a:avLst/>
+          </a:prstGeom>
+          <a:noFill/>
+          <a:ln/>
+        </p:spPr>
+        <p:txBody>
+          <a:bodyPr wrap="square" rtlCol="0" anchor="ctr"/>
+          <a:lstStyle/>
+          <a:p>
+            <a:pPr algn="ctr" indent="0" marL="0">
+              <a:buNone/>
+            </a:pPr>
+            <a:r>
+              <a:rPr lang="en-US" sz="1000" dirty="0">
+                <a:solidFill>
+                  <a:srgbClr val="059669"/>
+                </a:solidFill>
+                <a:latin typeface="Arial" pitchFamily="34" charset="0"/>
+                <a:ea typeface="Arial" pitchFamily="34" charset="-122"/>
+                <a:cs typeface="Arial" pitchFamily="34" charset="-120"/>
+              </a:rPr>
+              <a:t>ShareMemoryBlock</a:t>
+            </a:r>
+            <a:endParaRPr lang="en-US" sz="1000" dirty="0"/>
+          </a:p>
+          <a:p>
+            <a:pPr algn="ctr" indent="0" marL="0">
+              <a:buNone/>
+            </a:pPr>
+            <a:r>
+              <a:rPr lang="en-US" sz="1000" dirty="0">
+                <a:solidFill>
+                  <a:srgbClr val="059669"/>
+                </a:solidFill>
+                <a:latin typeface="Arial" pitchFamily="34" charset="0"/>
+                <a:ea typeface="Arial" pitchFamily="34" charset="-122"/>
+                <a:cs typeface="Arial" pitchFamily="34" charset="-120"/>
+              </a:rPr>
+              <a:t>shard 内无锁写入</a:t>
+            </a:r>
+            <a:endParaRPr lang="en-US" sz="1000" dirty="0"/>
+          </a:p>
+        </p:txBody>
+      </p:sp>
+      <p:sp>
+        <p:nvSpPr>
+          <p:cNvPr id="41" name="Shape 39"/>
+          <p:cNvSpPr/>
+          <p:nvPr/>
+        </p:nvSpPr>
+        <p:spPr>
+          <a:xfrm>
+            <a:off x="4846320" y="2752344"/>
+            <a:ext cx="256032" cy="256032"/>
+          </a:xfrm>
+          <a:prstGeom prst="ellipse">
+            <a:avLst/>
+          </a:prstGeom>
+          <a:solidFill>
+            <a:srgbClr val="059669"/>
+          </a:solidFill>
+          <a:ln/>
+        </p:spPr>
+      </p:sp>
+      <p:sp>
+        <p:nvSpPr>
+          <p:cNvPr id="42" name="Text 40"/>
+          <p:cNvSpPr/>
+          <p:nvPr/>
+        </p:nvSpPr>
+        <p:spPr>
+          <a:xfrm>
+            <a:off x="4846320" y="2752344"/>
+            <a:ext cx="256032" cy="256032"/>
+          </a:xfrm>
+          <a:prstGeom prst="rect">
+            <a:avLst/>
+          </a:prstGeom>
+          <a:noFill/>
+          <a:ln/>
+        </p:spPr>
+        <p:txBody>
+          <a:bodyPr wrap="square" rtlCol="0" anchor="ctr"/>
+          <a:lstStyle/>
+          <a:p>
+            <a:pPr algn="ctr" indent="0" marL="0">
+              <a:buNone/>
+            </a:pPr>
+            <a:r>
+              <a:rPr lang="en-US" sz="900" b="1" dirty="0">
+                <a:solidFill>
+                  <a:srgbClr val="FFFFFF"/>
+                </a:solidFill>
+                <a:latin typeface="Consolas" pitchFamily="34" charset="0"/>
+                <a:ea typeface="Consolas" pitchFamily="34" charset="-122"/>
+                <a:cs typeface="Consolas" pitchFamily="34" charset="-120"/>
+              </a:rPr>
+              <a:t>2</a:t>
+            </a:r>
+            <a:endParaRPr lang="en-US" sz="900" dirty="0"/>
+          </a:p>
+        </p:txBody>
+      </p:sp>
+      <p:sp>
+        <p:nvSpPr>
+          <p:cNvPr id="43" name="Text 41"/>
+          <p:cNvSpPr/>
+          <p:nvPr/>
+        </p:nvSpPr>
+        <p:spPr>
+          <a:xfrm>
+            <a:off x="6629400" y="2880360"/>
+            <a:ext cx="228600" cy="457200"/>
+          </a:xfrm>
+          <a:prstGeom prst="rect">
+            <a:avLst/>
+          </a:prstGeom>
+          <a:noFill/>
+          <a:ln/>
+        </p:spPr>
+        <p:txBody>
+          <a:bodyPr wrap="square" rtlCol="0" anchor="ctr"/>
+          <a:lstStyle/>
+          <a:p>
+            <a:pPr algn="ctr" indent="0" marL="0">
+              <a:buNone/>
+            </a:pPr>
+            <a:r>
+              <a:rPr lang="en-US" sz="1400" dirty="0">
+                <a:solidFill>
+                  <a:srgbClr val="64748B"/>
+                </a:solidFill>
+              </a:rPr>
+              <a:t>→</a:t>
+            </a:r>
+            <a:endParaRPr lang="en-US" sz="1400" dirty="0"/>
+          </a:p>
+        </p:txBody>
+      </p:sp>
+      <p:sp>
+        <p:nvSpPr>
+          <p:cNvPr id="44" name="Shape 42"/>
+          <p:cNvSpPr/>
+          <p:nvPr/>
+        </p:nvSpPr>
+        <p:spPr>
+          <a:xfrm>
+            <a:off x="6858000" y="2880360"/>
+            <a:ext cx="1828800" cy="457200"/>
+          </a:xfrm>
+          <a:prstGeom prst="rect">
+            <a:avLst>
+              <a:gd name="adj" fmla="val 10000"/>
+            </a:avLst>
+          </a:prstGeom>
+          <a:solidFill>
+            <a:srgbClr val="ECFDF5"/>
+          </a:solidFill>
+          <a:ln w="12700">
+            <a:solidFill>
+              <a:srgbClr val="E2E8F0"/>
+            </a:solidFill>
+            <a:prstDash val="solid"/>
+          </a:ln>
+        </p:spPr>
+      </p:sp>
+      <p:sp>
+        <p:nvSpPr>
+          <p:cNvPr id="45" name="Text 43"/>
+          <p:cNvSpPr/>
+          <p:nvPr/>
+        </p:nvSpPr>
+        <p:spPr>
+          <a:xfrm>
+            <a:off x="6858000" y="2880360"/>
+            <a:ext cx="1828800" cy="457200"/>
+          </a:xfrm>
+          <a:prstGeom prst="rect">
+            <a:avLst/>
+          </a:prstGeom>
+          <a:noFill/>
+          <a:ln/>
+        </p:spPr>
+        <p:txBody>
+          <a:bodyPr wrap="square" rtlCol="0" anchor="ctr"/>
+          <a:lstStyle/>
+          <a:p>
+            <a:pPr algn="ctr" indent="0" marL="0">
+              <a:buNone/>
+            </a:pPr>
+            <a:r>
+              <a:rPr lang="en-US" sz="1000" dirty="0">
+                <a:solidFill>
+                  <a:srgbClr val="059669"/>
+                </a:solidFill>
+                <a:latin typeface="Arial" pitchFamily="34" charset="0"/>
+                <a:ea typeface="Arial" pitchFamily="34" charset="-122"/>
+                <a:cs typeface="Arial" pitchFamily="34" charset="-120"/>
+              </a:rPr>
+              <a:t>PrepareFlush / Flush</a:t>
+            </a:r>
+            <a:endParaRPr lang="en-US" sz="1000" dirty="0"/>
+          </a:p>
+          <a:p>
+            <a:pPr algn="ctr" indent="0" marL="0">
+              <a:buNone/>
+            </a:pPr>
+            <a:r>
+              <a:rPr lang="en-US" sz="1000" dirty="0">
+                <a:solidFill>
+                  <a:srgbClr val="059669"/>
+                </a:solidFill>
+                <a:latin typeface="Arial" pitchFamily="34" charset="0"/>
+                <a:ea typeface="Arial" pitchFamily="34" charset="-122"/>
+                <a:cs typeface="Arial" pitchFamily="34" charset="-120"/>
+              </a:rPr>
+              <a:t>per-shard counter → Post</a:t>
+            </a:r>
+            <a:endParaRPr lang="en-US" sz="1000" dirty="0"/>
+          </a:p>
+        </p:txBody>
+      </p:sp>
+      <p:sp>
+        <p:nvSpPr>
+          <p:cNvPr id="46" name="Shape 44"/>
+          <p:cNvSpPr/>
+          <p:nvPr/>
+        </p:nvSpPr>
+        <p:spPr>
+          <a:xfrm>
+            <a:off x="6949440" y="2752344"/>
+            <a:ext cx="256032" cy="256032"/>
+          </a:xfrm>
+          <a:prstGeom prst="ellipse">
+            <a:avLst/>
+          </a:prstGeom>
+          <a:solidFill>
+            <a:srgbClr val="059669"/>
+          </a:solidFill>
+          <a:ln/>
+        </p:spPr>
+      </p:sp>
+      <p:sp>
+        <p:nvSpPr>
+          <p:cNvPr id="47" name="Text 45"/>
+          <p:cNvSpPr/>
+          <p:nvPr/>
+        </p:nvSpPr>
+        <p:spPr>
+          <a:xfrm>
+            <a:off x="6949440" y="2752344"/>
+            <a:ext cx="256032" cy="256032"/>
+          </a:xfrm>
+          <a:prstGeom prst="rect">
+            <a:avLst/>
+          </a:prstGeom>
+          <a:noFill/>
+          <a:ln/>
+        </p:spPr>
+        <p:txBody>
+          <a:bodyPr wrap="square" rtlCol="0" anchor="ctr"/>
+          <a:lstStyle/>
+          <a:p>
+            <a:pPr algn="ctr" indent="0" marL="0">
+              <a:buNone/>
+            </a:pPr>
+            <a:r>
+              <a:rPr lang="en-US" sz="900" b="1" dirty="0">
+                <a:solidFill>
+                  <a:srgbClr val="FFFFFF"/>
+                </a:solidFill>
+                <a:latin typeface="Consolas" pitchFamily="34" charset="0"/>
+                <a:ea typeface="Consolas" pitchFamily="34" charset="-122"/>
+                <a:cs typeface="Consolas" pitchFamily="34" charset="-120"/>
+              </a:rPr>
+              <a:t>3</a:t>
+            </a:r>
+            <a:endParaRPr lang="en-US" sz="900" dirty="0"/>
+          </a:p>
+        </p:txBody>
+      </p:sp>
+      <p:sp>
+        <p:nvSpPr>
+          <p:cNvPr id="48" name="Text 46"/>
+          <p:cNvSpPr/>
+          <p:nvPr/>
+        </p:nvSpPr>
+        <p:spPr>
+          <a:xfrm>
+            <a:off x="8915400" y="2880360"/>
+            <a:ext cx="228600" cy="457200"/>
+          </a:xfrm>
+          <a:prstGeom prst="rect">
+            <a:avLst/>
+          </a:prstGeom>
+          <a:noFill/>
+          <a:ln/>
+        </p:spPr>
+        <p:txBody>
+          <a:bodyPr wrap="square" rtlCol="0" anchor="ctr"/>
+          <a:lstStyle/>
+          <a:p>
+            <a:pPr algn="ctr" indent="0" marL="0">
+              <a:buNone/>
+            </a:pPr>
+            <a:r>
+              <a:rPr lang="en-US" sz="1400" dirty="0">
+                <a:solidFill>
+                  <a:srgbClr val="64748B"/>
+                </a:solidFill>
+              </a:rPr>
+              <a:t>→</a:t>
+            </a:r>
+            <a:endParaRPr lang="en-US" sz="1400" dirty="0"/>
+          </a:p>
+        </p:txBody>
+      </p:sp>
+      <p:sp>
+        <p:nvSpPr>
+          <p:cNvPr id="49" name="Shape 47"/>
+          <p:cNvSpPr/>
+          <p:nvPr/>
+        </p:nvSpPr>
+        <p:spPr>
+          <a:xfrm>
+            <a:off x="9144000" y="2880360"/>
+            <a:ext cx="2011680" cy="457200"/>
+          </a:xfrm>
+          <a:prstGeom prst="rect">
+            <a:avLst>
+              <a:gd name="adj" fmla="val 10000"/>
+            </a:avLst>
+          </a:prstGeom>
+          <a:solidFill>
+            <a:srgbClr val="ECFDF5"/>
+          </a:solidFill>
+          <a:ln w="12700">
+            <a:solidFill>
+              <a:srgbClr val="E2E8F0"/>
+            </a:solidFill>
+            <a:prstDash val="solid"/>
+          </a:ln>
+        </p:spPr>
+      </p:sp>
+      <p:sp>
+        <p:nvSpPr>
+          <p:cNvPr id="50" name="Text 48"/>
+          <p:cNvSpPr/>
+          <p:nvPr/>
+        </p:nvSpPr>
+        <p:spPr>
+          <a:xfrm>
+            <a:off x="9144000" y="2880360"/>
+            <a:ext cx="2011680" cy="457200"/>
+          </a:xfrm>
+          <a:prstGeom prst="rect">
+            <a:avLst/>
+          </a:prstGeom>
+          <a:noFill/>
+          <a:ln/>
+        </p:spPr>
+        <p:txBody>
+          <a:bodyPr wrap="square" rtlCol="0" anchor="ctr"/>
+          <a:lstStyle/>
+          <a:p>
+            <a:pPr algn="ctr" indent="0" marL="0">
+              <a:buNone/>
+            </a:pPr>
+            <a:r>
+              <a:rPr lang="en-US" sz="1000" dirty="0">
+                <a:solidFill>
+                  <a:srgbClr val="1E293B"/>
+                </a:solidFill>
+                <a:latin typeface="Arial" pitchFamily="34" charset="0"/>
+                <a:ea typeface="Arial" pitchFamily="34" charset="-122"/>
+                <a:cs typeface="Arial" pitchFamily="34" charset="-120"/>
+              </a:rPr>
+              <a:t>Consumer</a:t>
+            </a:r>
+            <a:endParaRPr lang="en-US" sz="1000" dirty="0"/>
+          </a:p>
+          <a:p>
+            <a:pPr algn="ctr" indent="0" marL="0">
+              <a:buNone/>
+            </a:pPr>
+            <a:r>
+              <a:rPr lang="en-US" sz="1000" dirty="0">
+                <a:solidFill>
+                  <a:srgbClr val="1E293B"/>
+                </a:solidFill>
+                <a:latin typeface="Arial" pitchFamily="34" charset="0"/>
+                <a:ea typeface="Arial" pitchFamily="34" charset="-122"/>
+                <a:cs typeface="Arial" pitchFamily="34" charset="-120"/>
+              </a:rPr>
+              <a:t>轮询所有分片</a:t>
+            </a:r>
+            <a:endParaRPr lang="en-US" sz="1000" dirty="0"/>
+          </a:p>
+        </p:txBody>
+      </p:sp>
+      <p:sp>
+        <p:nvSpPr>
+          <p:cNvPr id="51" name="Shape 49"/>
+          <p:cNvSpPr/>
+          <p:nvPr/>
+        </p:nvSpPr>
+        <p:spPr>
+          <a:xfrm>
+            <a:off x="640080" y="3803904"/>
+            <a:ext cx="256032" cy="256032"/>
+          </a:xfrm>
+          <a:prstGeom prst="ellipse">
+            <a:avLst/>
+          </a:prstGeom>
+          <a:solidFill>
+            <a:srgbClr val="059669"/>
+          </a:solidFill>
+          <a:ln/>
+        </p:spPr>
+      </p:sp>
+      <p:sp>
+        <p:nvSpPr>
+          <p:cNvPr id="52" name="Text 50"/>
+          <p:cNvSpPr/>
+          <p:nvPr/>
+        </p:nvSpPr>
+        <p:spPr>
+          <a:xfrm>
+            <a:off x="640080" y="3803904"/>
+            <a:ext cx="256032" cy="256032"/>
+          </a:xfrm>
+          <a:prstGeom prst="rect">
+            <a:avLst/>
+          </a:prstGeom>
+          <a:noFill/>
+          <a:ln/>
+        </p:spPr>
+        <p:txBody>
+          <a:bodyPr wrap="square" rtlCol="0" anchor="ctr"/>
+          <a:lstStyle/>
+          <a:p>
+            <a:pPr algn="ctr" indent="0" marL="0">
+              <a:buNone/>
+            </a:pPr>
+            <a:r>
+              <a:rPr lang="en-US" sz="900" b="1" dirty="0">
+                <a:solidFill>
+                  <a:srgbClr val="FFFFFF"/>
+                </a:solidFill>
+                <a:latin typeface="Consolas" pitchFamily="34" charset="0"/>
+                <a:ea typeface="Consolas" pitchFamily="34" charset="-122"/>
+                <a:cs typeface="Consolas" pitchFamily="34" charset="-120"/>
+              </a:rPr>
+              <a:t>1</a:t>
+            </a:r>
+            <a:endParaRPr lang="en-US" sz="900" dirty="0"/>
+          </a:p>
+        </p:txBody>
+      </p:sp>
+      <p:sp>
+        <p:nvSpPr>
+          <p:cNvPr id="53" name="Text 51"/>
+          <p:cNvSpPr/>
+          <p:nvPr/>
+        </p:nvSpPr>
+        <p:spPr>
+          <a:xfrm>
+            <a:off x="1051560" y="3749040"/>
+            <a:ext cx="10058400" cy="365760"/>
+          </a:xfrm>
+          <a:prstGeom prst="rect">
+            <a:avLst/>
+          </a:prstGeom>
+          <a:noFill/>
+          <a:ln/>
+        </p:spPr>
+        <p:txBody>
+          <a:bodyPr wrap="square" rtlCol="0" anchor="ctr"/>
+          <a:lstStyle/>
+          <a:p>
+            <a:pPr indent="0" marL="0">
+              <a:buNone/>
+            </a:pPr>
+            <a:r>
+              <a:rPr lang="en-US" sz="1100" dirty="0">
+                <a:solidFill>
                   <a:srgbClr val="334155"/>
                 </a:solidFill>
               </a:rPr>
-              <a:t>等待 OH SDK 环境到位后编译验证</a:t>
+              <a:t>hook_client.cpp:628 — addr % N → tid % N + thread_local 缓存 TID</a:t>
             </a:r>
-            <a:endParaRPr lang="en-US" sz="1500" dirty="0"/>
+            <a:endParaRPr lang="en-US" sz="1100" dirty="0"/>
+          </a:p>
+        </p:txBody>
+      </p:sp>
+      <p:sp>
+        <p:nvSpPr>
+          <p:cNvPr id="54" name="Shape 52"/>
+          <p:cNvSpPr/>
+          <p:nvPr/>
+        </p:nvSpPr>
+        <p:spPr>
+          <a:xfrm>
+            <a:off x="640080" y="4215384"/>
+            <a:ext cx="256032" cy="256032"/>
+          </a:xfrm>
+          <a:prstGeom prst="ellipse">
+            <a:avLst/>
+          </a:prstGeom>
+          <a:solidFill>
+            <a:srgbClr val="059669"/>
+          </a:solidFill>
+          <a:ln/>
+        </p:spPr>
+      </p:sp>
+      <p:sp>
+        <p:nvSpPr>
+          <p:cNvPr id="55" name="Text 53"/>
+          <p:cNvSpPr/>
+          <p:nvPr/>
+        </p:nvSpPr>
+        <p:spPr>
+          <a:xfrm>
+            <a:off x="640080" y="4215384"/>
+            <a:ext cx="256032" cy="256032"/>
+          </a:xfrm>
+          <a:prstGeom prst="rect">
+            <a:avLst/>
+          </a:prstGeom>
+          <a:noFill/>
+          <a:ln/>
+        </p:spPr>
+        <p:txBody>
+          <a:bodyPr wrap="square" rtlCol="0" anchor="ctr"/>
+          <a:lstStyle/>
+          <a:p>
+            <a:pPr algn="ctr" indent="0" marL="0">
+              <a:buNone/>
+            </a:pPr>
+            <a:r>
+              <a:rPr lang="en-US" sz="900" b="1" dirty="0">
+                <a:solidFill>
+                  <a:srgbClr val="FFFFFF"/>
+                </a:solidFill>
+                <a:latin typeface="Consolas" pitchFamily="34" charset="0"/>
+                <a:ea typeface="Consolas" pitchFamily="34" charset="-122"/>
+                <a:cs typeface="Consolas" pitchFamily="34" charset="-120"/>
+              </a:rPr>
+              <a:t>2</a:t>
+            </a:r>
+            <a:endParaRPr lang="en-US" sz="900" dirty="0"/>
+          </a:p>
+        </p:txBody>
+      </p:sp>
+      <p:sp>
+        <p:nvSpPr>
+          <p:cNvPr id="56" name="Text 54"/>
+          <p:cNvSpPr/>
+          <p:nvPr/>
+        </p:nvSpPr>
+        <p:spPr>
+          <a:xfrm>
+            <a:off x="1051560" y="4160520"/>
+            <a:ext cx="10058400" cy="365760"/>
+          </a:xfrm>
+          <a:prstGeom prst="rect">
+            <a:avLst/>
+          </a:prstGeom>
+          <a:noFill/>
+          <a:ln/>
+        </p:spPr>
+        <p:txBody>
+          <a:bodyPr wrap="square" rtlCol="0" anchor="ctr"/>
+          <a:lstStyle/>
+          <a:p>
+            <a:pPr indent="0" marL="0">
+              <a:buNone/>
+            </a:pPr>
+            <a:r>
+              <a:rPr lang="en-US" sz="1100" dirty="0">
+                <a:solidFill>
+                  <a:srgbClr val="334155"/>
+                </a:solidFill>
+              </a:rPr>
+              <a:t>stack_writer.cpp:89 — PutWithPayloadTimeout 新增 shard_idx 参数，内部无锁</a:t>
+            </a:r>
+            <a:endParaRPr lang="en-US" sz="1100" dirty="0"/>
+          </a:p>
+        </p:txBody>
+      </p:sp>
+      <p:sp>
+        <p:nvSpPr>
+          <p:cNvPr id="57" name="Shape 55"/>
+          <p:cNvSpPr/>
+          <p:nvPr/>
+        </p:nvSpPr>
+        <p:spPr>
+          <a:xfrm>
+            <a:off x="640080" y="4626864"/>
+            <a:ext cx="256032" cy="256032"/>
+          </a:xfrm>
+          <a:prstGeom prst="ellipse">
+            <a:avLst/>
+          </a:prstGeom>
+          <a:solidFill>
+            <a:srgbClr val="059669"/>
+          </a:solidFill>
+          <a:ln/>
+        </p:spPr>
+      </p:sp>
+      <p:sp>
+        <p:nvSpPr>
+          <p:cNvPr id="58" name="Text 56"/>
+          <p:cNvSpPr/>
+          <p:nvPr/>
+        </p:nvSpPr>
+        <p:spPr>
+          <a:xfrm>
+            <a:off x="640080" y="4626864"/>
+            <a:ext cx="256032" cy="256032"/>
+          </a:xfrm>
+          <a:prstGeom prst="rect">
+            <a:avLst/>
+          </a:prstGeom>
+          <a:noFill/>
+          <a:ln/>
+        </p:spPr>
+        <p:txBody>
+          <a:bodyPr wrap="square" rtlCol="0" anchor="ctr"/>
+          <a:lstStyle/>
+          <a:p>
+            <a:pPr algn="ctr" indent="0" marL="0">
+              <a:buNone/>
+            </a:pPr>
+            <a:r>
+              <a:rPr lang="en-US" sz="900" b="1" dirty="0">
+                <a:solidFill>
+                  <a:srgbClr val="FFFFFF"/>
+                </a:solidFill>
+                <a:latin typeface="Consolas" pitchFamily="34" charset="0"/>
+                <a:ea typeface="Consolas" pitchFamily="34" charset="-122"/>
+                <a:cs typeface="Consolas" pitchFamily="34" charset="-120"/>
+              </a:rPr>
+              <a:t>3</a:t>
+            </a:r>
+            <a:endParaRPr lang="en-US" sz="900" dirty="0"/>
+          </a:p>
+        </p:txBody>
+      </p:sp>
+      <p:sp>
+        <p:nvSpPr>
+          <p:cNvPr id="59" name="Text 57"/>
+          <p:cNvSpPr/>
+          <p:nvPr/>
+        </p:nvSpPr>
+        <p:spPr>
+          <a:xfrm>
+            <a:off x="1051560" y="4572000"/>
+            <a:ext cx="10058400" cy="365760"/>
+          </a:xfrm>
+          <a:prstGeom prst="rect">
+            <a:avLst/>
+          </a:prstGeom>
+          <a:noFill/>
+          <a:ln/>
+        </p:spPr>
+        <p:txBody>
+          <a:bodyPr wrap="square" rtlCol="0" anchor="ctr"/>
+          <a:lstStyle/>
+          <a:p>
+            <a:pPr indent="0" marL="0">
+              <a:buNone/>
+            </a:pPr>
+            <a:r>
+              <a:rPr lang="en-US" sz="1100" dirty="0">
+                <a:solidFill>
+                  <a:srgbClr val="334155"/>
+                </a:solidFill>
+              </a:rPr>
+              <a:t>stack_writer.cpp:94 — PrepareFlush/Flush 每 shard 独立计数，汇总 Post</a:t>
+            </a:r>
+            <a:endParaRPr lang="en-US" sz="1100" dirty="0"/>
+          </a:p>
+        </p:txBody>
+      </p:sp>
+      <p:sp>
+        <p:nvSpPr>
+          <p:cNvPr id="60" name="Shape 58"/>
+          <p:cNvSpPr/>
+          <p:nvPr/>
+        </p:nvSpPr>
+        <p:spPr>
+          <a:xfrm>
+            <a:off x="502920" y="5394960"/>
+            <a:ext cx="11247120" cy="411480"/>
+          </a:xfrm>
+          <a:prstGeom prst="rect">
+            <a:avLst>
+              <a:gd name="adj" fmla="val 13333"/>
+            </a:avLst>
+          </a:prstGeom>
+          <a:solidFill>
+            <a:srgbClr val="EFF6FF"/>
+          </a:solidFill>
+          <a:ln/>
+        </p:spPr>
+      </p:sp>
+      <p:sp>
+        <p:nvSpPr>
+          <p:cNvPr id="61" name="Text 59"/>
+          <p:cNvSpPr/>
+          <p:nvPr/>
+        </p:nvSpPr>
+        <p:spPr>
+          <a:xfrm>
+            <a:off x="502920" y="5394960"/>
+            <a:ext cx="11247120" cy="411480"/>
+          </a:xfrm>
+          <a:prstGeom prst="rect">
+            <a:avLst/>
+          </a:prstGeom>
+          <a:noFill/>
+          <a:ln/>
+        </p:spPr>
+        <p:txBody>
+          <a:bodyPr wrap="square" rtlCol="0" anchor="ctr"/>
+          <a:lstStyle/>
+          <a:p>
+            <a:pPr algn="ctr" indent="0" marL="0">
+              <a:buNone/>
+            </a:pPr>
+            <a:r>
+              <a:rPr lang="en-US" sz="1300" b="1" dirty="0">
+                <a:solidFill>
+                  <a:srgbClr val="2563EB"/>
+                </a:solidFill>
+                <a:latin typeface="Arial" pitchFamily="34" charset="0"/>
+                <a:ea typeface="Arial" pitchFamily="34" charset="-122"/>
+                <a:cs typeface="Arial" pitchFamily="34" charset="-120"/>
+              </a:rPr>
+              <a:t>改动集中在 StackWriter 层 · 不影响 hook_malloc/hook_free · num_shards=0 时向后兼容</a:t>
+            </a:r>
+            <a:endParaRPr lang="en-US" sz="1300" dirty="0"/>
           </a:p>
         </p:txBody>
       </p:sp>

</xml_diff>

<commit_message>
Fix marker positions on slide 8 — move away from box edges
</commit_message>
<xml_diff>
--- a/presentation/native_hook_progress_2026-06-11.pptx
+++ b/presentation/native_hook_progress_2026-06-11.pptx
@@ -15198,7 +15198,7 @@
         </p:nvSpPr>
         <p:spPr>
           <a:xfrm>
-            <a:off x="2560320" y="1426464"/>
+            <a:off x="3246120" y="1353312"/>
             <a:ext cx="256032" cy="256032"/>
           </a:xfrm>
           <a:prstGeom prst="ellipse">
@@ -15218,7 +15218,7 @@
         </p:nvSpPr>
         <p:spPr>
           <a:xfrm>
-            <a:off x="2560320" y="1426464"/>
+            <a:off x="3246120" y="1353312"/>
             <a:ext cx="256032" cy="256032"/>
           </a:xfrm>
           <a:prstGeom prst="rect">
@@ -15376,7 +15376,7 @@
         </p:nvSpPr>
         <p:spPr>
           <a:xfrm>
-            <a:off x="4846320" y="1426464"/>
+            <a:off x="5440680" y="1353312"/>
             <a:ext cx="256032" cy="256032"/>
           </a:xfrm>
           <a:prstGeom prst="ellipse">
@@ -15396,7 +15396,7 @@
         </p:nvSpPr>
         <p:spPr>
           <a:xfrm>
-            <a:off x="4846320" y="1426464"/>
+            <a:off x="5440680" y="1353312"/>
             <a:ext cx="256032" cy="256032"/>
           </a:xfrm>
           <a:prstGeom prst="rect">
@@ -15554,7 +15554,7 @@
         </p:nvSpPr>
         <p:spPr>
           <a:xfrm>
-            <a:off x="6949440" y="1426464"/>
+            <a:off x="7635240" y="1353312"/>
             <a:ext cx="256032" cy="256032"/>
           </a:xfrm>
           <a:prstGeom prst="ellipse">
@@ -15574,7 +15574,7 @@
         </p:nvSpPr>
         <p:spPr>
           <a:xfrm>
-            <a:off x="6949440" y="1426464"/>
+            <a:off x="7635240" y="1353312"/>
             <a:ext cx="256032" cy="256032"/>
           </a:xfrm>
           <a:prstGeom prst="rect">
@@ -16006,7 +16006,7 @@
         </p:nvSpPr>
         <p:spPr>
           <a:xfrm>
-            <a:off x="2560320" y="2752344"/>
+            <a:off x="3246120" y="2679192"/>
             <a:ext cx="256032" cy="256032"/>
           </a:xfrm>
           <a:prstGeom prst="ellipse">
@@ -16026,7 +16026,7 @@
         </p:nvSpPr>
         <p:spPr>
           <a:xfrm>
-            <a:off x="2560320" y="2752344"/>
+            <a:off x="3246120" y="2679192"/>
             <a:ext cx="256032" cy="256032"/>
           </a:xfrm>
           <a:prstGeom prst="rect">
@@ -16184,7 +16184,7 @@
         </p:nvSpPr>
         <p:spPr>
           <a:xfrm>
-            <a:off x="4846320" y="2752344"/>
+            <a:off x="5440680" y="2679192"/>
             <a:ext cx="256032" cy="256032"/>
           </a:xfrm>
           <a:prstGeom prst="ellipse">
@@ -16204,7 +16204,7 @@
         </p:nvSpPr>
         <p:spPr>
           <a:xfrm>
-            <a:off x="4846320" y="2752344"/>
+            <a:off x="5440680" y="2679192"/>
             <a:ext cx="256032" cy="256032"/>
           </a:xfrm>
           <a:prstGeom prst="rect">
@@ -16362,7 +16362,7 @@
         </p:nvSpPr>
         <p:spPr>
           <a:xfrm>
-            <a:off x="6949440" y="2752344"/>
+            <a:off x="7635240" y="2679192"/>
             <a:ext cx="256032" cy="256032"/>
           </a:xfrm>
           <a:prstGeom prst="ellipse">
@@ -16382,7 +16382,7 @@
         </p:nvSpPr>
         <p:spPr>
           <a:xfrm>
-            <a:off x="6949440" y="2752344"/>
+            <a:off x="7635240" y="2679192"/>
             <a:ext cx="256032" cy="256032"/>
           </a:xfrm>
           <a:prstGeom prst="rect">

</xml_diff>

<commit_message>
Fix slide 2: 四个→遗留, spread 2 items to fill left panel
</commit_message>
<xml_diff>
--- a/presentation/native_hook_progress_2026-06-11.pptx
+++ b/presentation/native_hook_progress_2026-06-11.pptx
@@ -7406,7 +7406,7 @@
                   <a:srgbClr val="2563EB"/>
                 </a:solidFill>
               </a:rPr>
-              <a:t>上次组会四个问题全部闭环</a:t>
+              <a:t>上次组会遗留问题闭环</a:t>
             </a:r>
             <a:endParaRPr lang="en-US" sz="1300" dirty="0"/>
           </a:p>
@@ -7420,12 +7420,12 @@
         </p:nvSpPr>
         <p:spPr>
           <a:xfrm>
-            <a:off x="502920" y="1783080"/>
-            <a:ext cx="365760" cy="365760"/>
+            <a:off x="502920" y="1920240"/>
+            <a:ext cx="411480" cy="411480"/>
           </a:xfrm>
           <a:prstGeom prst="rect">
             <a:avLst>
-              <a:gd name="adj" fmla="val 50000"/>
+              <a:gd name="adj" fmla="val 48889"/>
             </a:avLst>
           </a:prstGeom>
           <a:solidFill>
@@ -7442,8 +7442,8 @@
         </p:nvSpPr>
         <p:spPr>
           <a:xfrm>
-            <a:off x="502920" y="1783080"/>
-            <a:ext cx="365760" cy="365760"/>
+            <a:off x="502920" y="1920240"/>
+            <a:ext cx="411480" cy="411480"/>
           </a:xfrm>
           <a:prstGeom prst="rect">
             <a:avLst/>
@@ -7459,7 +7459,7 @@
               <a:buNone/>
             </a:pPr>
             <a:r>
-              <a:rPr lang="en-US" sz="1200" b="1" dirty="0">
+              <a:rPr lang="en-US" sz="1400" b="1" dirty="0">
                 <a:solidFill>
                   <a:srgbClr val="FFFFFF"/>
                 </a:solidFill>
@@ -7469,7 +7469,7 @@
               </a:rPr>
               <a:t>1</a:t>
             </a:r>
-            <a:endParaRPr lang="en-US" sz="1200" dirty="0"/>
+            <a:endParaRPr lang="en-US" sz="1400" dirty="0"/>
           </a:p>
         </p:txBody>
       </p:sp>
@@ -7481,8 +7481,8 @@
         </p:nvSpPr>
         <p:spPr>
           <a:xfrm>
-            <a:off x="1005840" y="1764792"/>
-            <a:ext cx="1097280" cy="365760"/>
+            <a:off x="1051560" y="1920240"/>
+            <a:ext cx="1188720" cy="411480"/>
           </a:xfrm>
           <a:prstGeom prst="rect">
             <a:avLst/>
@@ -7498,14 +7498,14 @@
               <a:buNone/>
             </a:pPr>
             <a:r>
-              <a:rPr lang="en-US" sz="1200" b="1" dirty="0">
+              <a:rPr lang="en-US" sz="1400" b="1" dirty="0">
                 <a:solidFill>
                   <a:srgbClr val="1E293B"/>
                 </a:solidFill>
               </a:rPr>
               <a:t>热点定位</a:t>
             </a:r>
-            <a:endParaRPr lang="en-US" sz="1200" dirty="0"/>
+            <a:endParaRPr lang="en-US" sz="1400" dirty="0"/>
           </a:p>
         </p:txBody>
       </p:sp>
@@ -7517,8 +7517,8 @@
         </p:nvSpPr>
         <p:spPr>
           <a:xfrm>
-            <a:off x="2103120" y="1764792"/>
-            <a:ext cx="3566160" cy="365760"/>
+            <a:off x="2286000" y="1920240"/>
+            <a:ext cx="3383280" cy="411480"/>
           </a:xfrm>
           <a:prstGeom prst="rect">
             <a:avLst/>
@@ -7534,14 +7534,14 @@
               <a:buNone/>
             </a:pPr>
             <a:r>
-              <a:rPr lang="en-US" sz="1200" dirty="0">
+              <a:rPr lang="en-US" sz="1300" dirty="0">
                 <a:solidFill>
                   <a:srgbClr val="334155"/>
                 </a:solidFill>
               </a:rPr>
               <a:t>ring 共享状态竞争 → 批量发布解决</a:t>
             </a:r>
-            <a:endParaRPr lang="en-US" sz="1200" dirty="0"/>
+            <a:endParaRPr lang="en-US" sz="1300" dirty="0"/>
           </a:p>
         </p:txBody>
       </p:sp>
@@ -7553,12 +7553,12 @@
         </p:nvSpPr>
         <p:spPr>
           <a:xfrm>
-            <a:off x="502920" y="2377440"/>
-            <a:ext cx="365760" cy="365760"/>
+            <a:off x="502920" y="2834640"/>
+            <a:ext cx="411480" cy="411480"/>
           </a:xfrm>
           <a:prstGeom prst="rect">
             <a:avLst>
-              <a:gd name="adj" fmla="val 50000"/>
+              <a:gd name="adj" fmla="val 48889"/>
             </a:avLst>
           </a:prstGeom>
           <a:solidFill>
@@ -7575,8 +7575,8 @@
         </p:nvSpPr>
         <p:spPr>
           <a:xfrm>
-            <a:off x="502920" y="2377440"/>
-            <a:ext cx="365760" cy="365760"/>
+            <a:off x="502920" y="2834640"/>
+            <a:ext cx="411480" cy="411480"/>
           </a:xfrm>
           <a:prstGeom prst="rect">
             <a:avLst/>
@@ -7592,7 +7592,7 @@
               <a:buNone/>
             </a:pPr>
             <a:r>
-              <a:rPr lang="en-US" sz="1200" b="1" dirty="0">
+              <a:rPr lang="en-US" sz="1400" b="1" dirty="0">
                 <a:solidFill>
                   <a:srgbClr val="FFFFFF"/>
                 </a:solidFill>
@@ -7602,7 +7602,7 @@
               </a:rPr>
               <a:t>2</a:t>
             </a:r>
-            <a:endParaRPr lang="en-US" sz="1200" dirty="0"/>
+            <a:endParaRPr lang="en-US" sz="1400" dirty="0"/>
           </a:p>
         </p:txBody>
       </p:sp>
@@ -7614,8 +7614,8 @@
         </p:nvSpPr>
         <p:spPr>
           <a:xfrm>
-            <a:off x="1005840" y="2359152"/>
-            <a:ext cx="1097280" cy="365760"/>
+            <a:off x="1051560" y="2834640"/>
+            <a:ext cx="1188720" cy="411480"/>
           </a:xfrm>
           <a:prstGeom prst="rect">
             <a:avLst/>
@@ -7631,14 +7631,14 @@
               <a:buNone/>
             </a:pPr>
             <a:r>
-              <a:rPr lang="en-US" sz="1200" b="1" dirty="0">
+              <a:rPr lang="en-US" sz="1400" b="1" dirty="0">
                 <a:solidFill>
                   <a:srgbClr val="1E293B"/>
                 </a:solidFill>
               </a:rPr>
               <a:t>代码移植</a:t>
             </a:r>
-            <a:endParaRPr lang="en-US" sz="1200" dirty="0"/>
+            <a:endParaRPr lang="en-US" sz="1400" dirty="0"/>
           </a:p>
         </p:txBody>
       </p:sp>
@@ -7650,8 +7650,8 @@
         </p:nvSpPr>
         <p:spPr>
           <a:xfrm>
-            <a:off x="2103120" y="2359152"/>
-            <a:ext cx="3566160" cy="365760"/>
+            <a:off x="2286000" y="2834640"/>
+            <a:ext cx="3383280" cy="411480"/>
           </a:xfrm>
           <a:prstGeom prst="rect">
             <a:avLst/>
@@ -7667,14 +7667,14 @@
               <a:buNone/>
             </a:pPr>
             <a:r>
-              <a:rPr lang="en-US" sz="1200" dirty="0">
+              <a:rPr lang="en-US" sz="1300" dirty="0">
                 <a:solidFill>
                   <a:srgbClr val="334155"/>
                 </a:solidFill>
               </a:rPr>
               <a:t>Gitee fork 到公司 GitLab 并完成</a:t>
             </a:r>
-            <a:endParaRPr lang="en-US" sz="1200" dirty="0"/>
+            <a:endParaRPr lang="en-US" sz="1300" dirty="0"/>
           </a:p>
         </p:txBody>
       </p:sp>

</xml_diff>

<commit_message>
Replace OH SDK steps with actionable prototype next steps
- Shard + batch combo optimization
- Shard count sweep
- Code merge + cleanup

Co-Authored-By: Claude Opus 4.8 <noreply@anthropic.com>
</commit_message>
<xml_diff>
--- a/presentation/native_hook_progress_2026-06-11.pptx
+++ b/presentation/native_hook_progress_2026-06-11.pptx
@@ -6725,7 +6725,7 @@
                   <a:srgbClr val="1E293B"/>
                 </a:solidFill>
               </a:rPr>
-              <a:t>真实代码编译验证</a:t>
+              <a:t>Shard + Batch 组合优化</a:t>
             </a:r>
             <a:endParaRPr lang="en-US" sz="1700" dirty="0"/>
           </a:p>
@@ -6764,7 +6764,7 @@
                   <a:srgbClr val="64748B"/>
                 </a:solidFill>
               </a:rPr>
-              <a:t>OH SDK 环境到位后</a:t>
+              <a:t>回归显示 batch64 16T=0.587s 仍优于 sharded 0.727s</a:t>
             </a:r>
             <a:endParaRPr lang="en-US" sz="1300" dirty="0"/>
           </a:p>
@@ -6781,7 +6781,7 @@
                   <a:srgbClr val="64748B"/>
                 </a:solidFill>
               </a:rPr>
-              <a:t>编译验证分片方案</a:t>
+              <a:t>两者组合（batch 减开销 + shard 消锁）可能进一步突破</a:t>
             </a:r>
             <a:endParaRPr lang="en-US" sz="1300" dirty="0"/>
           </a:p>
@@ -6898,7 +6898,7 @@
                   <a:srgbClr val="1E293B"/>
                 </a:solidFill>
               </a:rPr>
-              <a:t>团队评审</a:t>
+              <a:t>Shard 数量 Sweep</a:t>
             </a:r>
             <a:endParaRPr lang="en-US" sz="1700" dirty="0"/>
           </a:p>
@@ -6937,7 +6937,7 @@
                   <a:srgbClr val="64748B"/>
                 </a:solidFill>
               </a:rPr>
-              <a:t>基于 SHARDED_RING: 标注</a:t>
+              <a:t>当前固定 16 片，sweep 4/8/16/32/64</a:t>
             </a:r>
             <a:endParaRPr lang="en-US" sz="1300" dirty="0"/>
           </a:p>
@@ -6954,7 +6954,7 @@
                   <a:srgbClr val="64748B"/>
                 </a:solidFill>
               </a:rPr>
-              <a:t>在团队仓库提交合并请求</a:t>
+              <a:t>找到不同线程数下的最佳分片数</a:t>
             </a:r>
             <a:endParaRPr lang="en-US" sz="1300" dirty="0"/>
           </a:p>
@@ -7071,7 +7071,7 @@
                   <a:srgbClr val="1E293B"/>
                 </a:solidFill>
               </a:rPr>
-              <a:t>性能验证</a:t>
+              <a:t>代码合入 + 文档整理</a:t>
             </a:r>
             <a:endParaRPr lang="en-US" sz="1700" dirty="0"/>
           </a:p>
@@ -7110,7 +7110,7 @@
                   <a:srgbClr val="64748B"/>
                 </a:solidFill>
               </a:rPr>
-              <a:t>编译通过后在真实设备</a:t>
+              <a:t>实验代码已验证，合入 main 分支</a:t>
             </a:r>
             <a:endParaRPr lang="en-US" sz="1300" dirty="0"/>
           </a:p>
@@ -7127,7 +7127,7 @@
                   <a:srgbClr val="64748B"/>
                 </a:solidFill>
               </a:rPr>
-              <a:t>跑 benchmark 对比原型数据</a:t>
+              <a:t>清理实验分支，更新工作记录</a:t>
             </a:r>
             <a:endParaRPr lang="en-US" sz="1300" dirty="0"/>
           </a:p>

</xml_diff>

<commit_message>
Clarify eBPF limitation: can detect leak, cannot locate caller
Co-Authored-By: Claude Opus 4.8 <noreply@anthropic.com>
</commit_message>
<xml_diff>
--- a/presentation/native_hook_progress_2026-06-11.pptx
+++ b/presentation/native_hook_progress_2026-06-11.pptx
@@ -13660,7 +13660,7 @@
                           <a:ea typeface="Consolas" pitchFamily="34" charset="-122"/>
                           <a:cs typeface="Consolas" pitchFamily="34" charset="-120"/>
                         </a:rPr>
-                        <a:t>FpUnwind 栈回溯 (aarch64)</a:t>
+                        <a:t>栈回溯定位泄漏源</a:t>
                       </a:r>
                       <a:endParaRPr lang="en-US" sz="1200" dirty="0">
                         <a:latin typeface="Consolas" charset="0"/>
@@ -13728,7 +13728,7 @@
                           <a:ea typeface="Consolas" pitchFamily="34" charset="-122"/>
                           <a:cs typeface="Consolas" pitchFamily="34" charset="-120"/>
                         </a:rPr>
-                        <a:t>✓ 完整支持</a:t>
+                        <a:t>✓ 完整支持 FpUnwind</a:t>
                       </a:r>
                       <a:endParaRPr lang="en-US" sz="1200" dirty="0">
                         <a:latin typeface="Consolas" charset="0"/>
@@ -13796,7 +13796,7 @@
                           <a:ea typeface="Consolas" pitchFamily="34" charset="-122"/>
                           <a:cs typeface="Consolas" pitchFamily="34" charset="-120"/>
                         </a:rPr>
-                        <a:t>✗ 不能做</a:t>
+                        <a:t>✗ 能检测泄漏，不能定位调用栈</a:t>
                       </a:r>
                       <a:endParaRPr lang="en-US" sz="1200" dirty="0">
                         <a:latin typeface="Consolas" charset="0"/>

</xml_diff>

<commit_message>
Add sharded ring limitations to speech and PPT
- Ring utilization drops with sharding
- Thread count vs shard count mismatch
- Consumer scans extra empty shards (negligible)
- Lock-free safety depends on single-writer assumption

Co-Authored-By: Claude Opus 4.8 <noreply@anthropic.com>
</commit_message>
<xml_diff>
--- a/presentation/native_hook_progress_2026-06-11.pptx
+++ b/presentation/native_hook_progress_2026-06-11.pptx
@@ -17468,6 +17468,42 @@
           </a:p>
         </p:txBody>
       </p:sp>
+      <p:sp>
+        <p:nvSpPr>
+          <p:cNvPr id="20" name="Text 17"/>
+          <p:cNvSpPr/>
+          <p:nvPr/>
+        </p:nvSpPr>
+        <p:spPr>
+          <a:xfrm>
+            <a:off x="457200" y="6400800"/>
+            <a:ext cx="11247120" cy="320040"/>
+          </a:xfrm>
+          <a:prstGeom prst="rect">
+            <a:avLst/>
+          </a:prstGeom>
+          <a:noFill/>
+          <a:ln/>
+        </p:spPr>
+        <p:txBody>
+          <a:bodyPr wrap="square" rtlCol="0" anchor="ctr"/>
+          <a:lstStyle/>
+          <a:p>
+            <a:pPr algn="ctr" indent="0" marL="0">
+              <a:buNone/>
+            </a:pPr>
+            <a:r>
+              <a:rPr lang="en-US" sz="900" dirty="0">
+                <a:solidFill>
+                  <a:srgbClr val="64748B"/>
+                </a:solidFill>
+              </a:rPr>
+              <a:t>注意事项：环形区分片后空间利用率降低（单分片写满即丢）· 线程数需匹配分片数 · consumer 多扫 N-1 个空分片（实测 423ns，可忽略）</a:t>
+            </a:r>
+            <a:endParaRPr lang="en-US" sz="900" dirty="0"/>
+          </a:p>
+        </p:txBody>
+      </p:sp>
     </p:spTree>
   </p:cSld>
   <p:clrMapOvr>

</xml_diff>

<commit_message>
Remove deployment comparison from architecture argument
- Drop deployment row from slide 7 comparison table
- Update conclusion callout
- Change slide 11 pillar from 部署 to 实现

Co-Authored-By: Claude Opus 4.8 <noreply@anthropic.com>
</commit_message>
<xml_diff>
--- a/presentation/native_hook_progress_2026-06-11.pptx
+++ b/presentation/native_hook_progress_2026-06-11.pptx
@@ -6330,7 +6330,7 @@
                   <a:srgbClr val="93C5FD"/>
                 </a:solidFill>
               </a:rPr>
-              <a:t>保留 FpUnwind</a:t>
+              <a:t>保留栈回溯</a:t>
             </a:r>
             <a:endParaRPr lang="en-US" sz="1100" dirty="0"/>
           </a:p>
@@ -6391,7 +6391,7 @@
                 <a:ea typeface="Arial" pitchFamily="34" charset="-122"/>
                 <a:cs typeface="Arial" pitchFamily="34" charset="-120"/>
               </a:rPr>
-              <a:t>部署</a:t>
+              <a:t>实现</a:t>
             </a:r>
             <a:endParaRPr lang="en-US" sz="1200" dirty="0"/>
           </a:p>
@@ -6427,7 +6427,7 @@
                   <a:srgbClr val="FFFFFF"/>
                 </a:solidFill>
               </a:rPr>
-              <a:t>零依赖</a:t>
+              <a:t>轻量</a:t>
             </a:r>
             <a:endParaRPr lang="en-US" sz="2200" dirty="0"/>
           </a:p>
@@ -6463,7 +6463,7 @@
                   <a:srgbClr val="93C5FD"/>
                 </a:solidFill>
               </a:rPr>
-              <a:t>无需 root/BPF</a:t>
+              <a:t>仅改 StackWriter 层</a:t>
             </a:r>
             <a:endParaRPr lang="en-US" sz="1100" dirty="0"/>
           </a:p>
@@ -14072,212 +14072,6 @@
                           <a:ea typeface="Consolas" pitchFamily="34" charset="-122"/>
                           <a:cs typeface="Consolas" pitchFamily="34" charset="-120"/>
                         </a:rPr>
-                        <a:t>部署方式</a:t>
-                      </a:r>
-                      <a:endParaRPr lang="en-US" sz="1200" dirty="0">
-                        <a:latin typeface="Consolas" charset="0"/>
-                        <a:ea typeface="Consolas" charset="0"/>
-                        <a:cs typeface="Consolas" charset="0"/>
-                      </a:endParaRPr>
-                    </a:p>
-                  </a:txBody>
-                  <a:tcPr marL="91440" marR="91440" marT="45720" marB="45720" anchor="ctr">
-                    <a:lnL w="6350" cap="flat" cmpd="sng" algn="ctr">
-                      <a:solidFill>
-                        <a:srgbClr val="E2E8F0"/>
-                      </a:solidFill>
-                      <a:prstDash val="solid"/>
-                      <a:round/>
-                      <a:headEnd type="none" w="med" len="med"/>
-                      <a:tailEnd type="none" w="med" len="med"/>
-                    </a:lnL>
-                    <a:lnR w="6350" cap="flat" cmpd="sng" algn="ctr">
-                      <a:solidFill>
-                        <a:srgbClr val="E2E8F0"/>
-                      </a:solidFill>
-                      <a:prstDash val="solid"/>
-                      <a:round/>
-                      <a:headEnd type="none" w="med" len="med"/>
-                      <a:tailEnd type="none" w="med" len="med"/>
-                    </a:lnR>
-                    <a:lnT w="6350" cap="flat" cmpd="sng" algn="ctr">
-                      <a:solidFill>
-                        <a:srgbClr val="E2E8F0"/>
-                      </a:solidFill>
-                      <a:prstDash val="solid"/>
-                      <a:round/>
-                      <a:headEnd type="none" w="med" len="med"/>
-                      <a:tailEnd type="none" w="med" len="med"/>
-                    </a:lnT>
-                    <a:lnB w="6350" cap="flat" cmpd="sng" algn="ctr">
-                      <a:solidFill>
-                        <a:srgbClr val="E2E8F0"/>
-                      </a:solidFill>
-                      <a:prstDash val="solid"/>
-                      <a:round/>
-                      <a:headEnd type="none" w="med" len="med"/>
-                      <a:tailEnd type="none" w="med" len="med"/>
-                    </a:lnB>
-                    <a:solidFill>
-                      <a:srgbClr val="FFFFFF"/>
-                    </a:solidFill>
-                  </a:tcPr>
-                </a:tc>
-                <a:tc>
-                  <a:txBody>
-                    <a:bodyPr/>
-                    <a:lstStyle/>
-                    <a:p>
-                      <a:pPr algn="ctr" indent="0" marL="0">
-                        <a:buNone/>
-                      </a:pPr>
-                      <a:r>
-                        <a:rPr lang="en-US" sz="1200" dirty="0">
-                          <a:solidFill>
-                            <a:srgbClr val="334155"/>
-                          </a:solidFill>
-                          <a:latin typeface="Consolas" pitchFamily="34" charset="0"/>
-                          <a:ea typeface="Consolas" pitchFamily="34" charset="-122"/>
-                          <a:cs typeface="Consolas" pitchFamily="34" charset="-120"/>
-                        </a:rPr>
-                        <a:t>LD_PRELOAD (已有)</a:t>
-                      </a:r>
-                      <a:endParaRPr lang="en-US" sz="1200" dirty="0">
-                        <a:latin typeface="Consolas" charset="0"/>
-                        <a:ea typeface="Consolas" charset="0"/>
-                        <a:cs typeface="Consolas" charset="0"/>
-                      </a:endParaRPr>
-                    </a:p>
-                  </a:txBody>
-                  <a:tcPr marL="91440" marR="91440" marT="45720" marB="45720" anchor="ctr">
-                    <a:lnL w="6350" cap="flat" cmpd="sng" algn="ctr">
-                      <a:solidFill>
-                        <a:srgbClr val="E2E8F0"/>
-                      </a:solidFill>
-                      <a:prstDash val="solid"/>
-                      <a:round/>
-                      <a:headEnd type="none" w="med" len="med"/>
-                      <a:tailEnd type="none" w="med" len="med"/>
-                    </a:lnL>
-                    <a:lnR w="6350" cap="flat" cmpd="sng" algn="ctr">
-                      <a:solidFill>
-                        <a:srgbClr val="E2E8F0"/>
-                      </a:solidFill>
-                      <a:prstDash val="solid"/>
-                      <a:round/>
-                      <a:headEnd type="none" w="med" len="med"/>
-                      <a:tailEnd type="none" w="med" len="med"/>
-                    </a:lnR>
-                    <a:lnT w="6350" cap="flat" cmpd="sng" algn="ctr">
-                      <a:solidFill>
-                        <a:srgbClr val="E2E8F0"/>
-                      </a:solidFill>
-                      <a:prstDash val="solid"/>
-                      <a:round/>
-                      <a:headEnd type="none" w="med" len="med"/>
-                      <a:tailEnd type="none" w="med" len="med"/>
-                    </a:lnT>
-                    <a:lnB w="6350" cap="flat" cmpd="sng" algn="ctr">
-                      <a:solidFill>
-                        <a:srgbClr val="E2E8F0"/>
-                      </a:solidFill>
-                      <a:prstDash val="solid"/>
-                      <a:round/>
-                      <a:headEnd type="none" w="med" len="med"/>
-                      <a:tailEnd type="none" w="med" len="med"/>
-                    </a:lnB>
-                    <a:solidFill>
-                      <a:srgbClr val="FFFFFF"/>
-                    </a:solidFill>
-                  </a:tcPr>
-                </a:tc>
-                <a:tc>
-                  <a:txBody>
-                    <a:bodyPr/>
-                    <a:lstStyle/>
-                    <a:p>
-                      <a:pPr algn="ctr" indent="0" marL="0">
-                        <a:buNone/>
-                      </a:pPr>
-                      <a:r>
-                        <a:rPr lang="en-US" sz="1200" dirty="0">
-                          <a:solidFill>
-                            <a:srgbClr val="334155"/>
-                          </a:solidFill>
-                          <a:latin typeface="Consolas" pitchFamily="34" charset="0"/>
-                          <a:ea typeface="Consolas" pitchFamily="34" charset="-122"/>
-                          <a:cs typeface="Consolas" pitchFamily="34" charset="-120"/>
-                        </a:rPr>
-                        <a:t>需 root + BPF 权限</a:t>
-                      </a:r>
-                      <a:endParaRPr lang="en-US" sz="1200" dirty="0">
-                        <a:latin typeface="Consolas" charset="0"/>
-                        <a:ea typeface="Consolas" charset="0"/>
-                        <a:cs typeface="Consolas" charset="0"/>
-                      </a:endParaRPr>
-                    </a:p>
-                  </a:txBody>
-                  <a:tcPr marL="91440" marR="91440" marT="45720" marB="45720" anchor="ctr">
-                    <a:lnL w="6350" cap="flat" cmpd="sng" algn="ctr">
-                      <a:solidFill>
-                        <a:srgbClr val="E2E8F0"/>
-                      </a:solidFill>
-                      <a:prstDash val="solid"/>
-                      <a:round/>
-                      <a:headEnd type="none" w="med" len="med"/>
-                      <a:tailEnd type="none" w="med" len="med"/>
-                    </a:lnL>
-                    <a:lnR w="6350" cap="flat" cmpd="sng" algn="ctr">
-                      <a:solidFill>
-                        <a:srgbClr val="E2E8F0"/>
-                      </a:solidFill>
-                      <a:prstDash val="solid"/>
-                      <a:round/>
-                      <a:headEnd type="none" w="med" len="med"/>
-                      <a:tailEnd type="none" w="med" len="med"/>
-                    </a:lnR>
-                    <a:lnT w="6350" cap="flat" cmpd="sng" algn="ctr">
-                      <a:solidFill>
-                        <a:srgbClr val="E2E8F0"/>
-                      </a:solidFill>
-                      <a:prstDash val="solid"/>
-                      <a:round/>
-                      <a:headEnd type="none" w="med" len="med"/>
-                      <a:tailEnd type="none" w="med" len="med"/>
-                    </a:lnT>
-                    <a:lnB w="6350" cap="flat" cmpd="sng" algn="ctr">
-                      <a:solidFill>
-                        <a:srgbClr val="E2E8F0"/>
-                      </a:solidFill>
-                      <a:prstDash val="solid"/>
-                      <a:round/>
-                      <a:headEnd type="none" w="med" len="med"/>
-                      <a:tailEnd type="none" w="med" len="med"/>
-                    </a:lnB>
-                    <a:solidFill>
-                      <a:srgbClr val="FFFFFF"/>
-                    </a:solidFill>
-                  </a:tcPr>
-                </a:tc>
-              </a:tr>
-              <a:tr h="347472">
-                <a:tc>
-                  <a:txBody>
-                    <a:bodyPr/>
-                    <a:lstStyle/>
-                    <a:p>
-                      <a:pPr algn="l" indent="0" marL="0">
-                        <a:buNone/>
-                      </a:pPr>
-                      <a:r>
-                        <a:rPr lang="en-US" sz="1200" dirty="0">
-                          <a:solidFill>
-                            <a:srgbClr val="334155"/>
-                          </a:solidFill>
-                          <a:latin typeface="Consolas" pitchFamily="34" charset="0"/>
-                          <a:ea typeface="Consolas" pitchFamily="34" charset="-122"/>
-                          <a:cs typeface="Consolas" pitchFamily="34" charset="-120"/>
-                        </a:rPr>
                         <a:t>原型 16T sub=36</a:t>
                       </a:r>
                       <a:endParaRPr lang="en-US" sz="1200" dirty="0">
@@ -14709,7 +14503,7 @@
                   <a:srgbClr val="2563EB"/>
                 </a:solidFill>
               </a:rPr>
-              <a:t>结论：不需要引入 eBPF。Sharded ring 在保留全部功能的前提下，性能和部署都优于 eBPF。</a:t>
+              <a:t>结论：不需要引入 eBPF。Sharded ring 在保留全部功能的前提下，性能优于 eBPF。</a:t>
             </a:r>
             <a:endParaRPr lang="en-US" sz="1500" dirty="0"/>
           </a:p>

</xml_diff>

<commit_message>
Replace addr%/tid% with plain Chinese: 地址取余选块/线程取余选块
</commit_message>
<xml_diff>
--- a/presentation/native_hook_progress_2026-06-11.pptx
+++ b/presentation/native_hook_progress_2026-06-11.pptx
@@ -14978,7 +14978,7 @@
                 <a:ea typeface="Arial" pitchFamily="34" charset="-122"/>
                 <a:cs typeface="Arial" pitchFamily="34" charset="-120"/>
               </a:rPr>
-              <a:t>addr % N → Block</a:t>
+              <a:t>地址取余选块</a:t>
             </a:r>
             <a:endParaRPr lang="en-US" sz="1000" dirty="0"/>
           </a:p>
@@ -15786,7 +15786,7 @@
                 <a:ea typeface="Arial" pitchFamily="34" charset="-122"/>
                 <a:cs typeface="Arial" pitchFamily="34" charset="-120"/>
               </a:rPr>
-              <a:t>tid % N → Block[shard]</a:t>
+              <a:t>线程取余选块</a:t>
             </a:r>
             <a:endParaRPr lang="en-US" sz="1000" dirty="0"/>
           </a:p>
@@ -16415,7 +16415,7 @@
                   <a:srgbClr val="334155"/>
                 </a:solidFill>
               </a:rPr>
-              <a:t>hook_client.cpp:628 — addr % N → tid % N + thread_local 缓存 TID</a:t>
+              <a:t>hook_client.cpp:628 — 地址取余 → 线程取余 + 线程本地缓存</a:t>
             </a:r>
             <a:endParaRPr lang="en-US" sz="1100" dirty="0"/>
           </a:p>

</xml_diff>